<commit_message>
feat: bootstrap MVVM auth and Firestore scheduling flows
</commit_message>
<xml_diff>
--- a/.build/presentation/office-2026/candidate-office.pptx
+++ b/.build/presentation/office-2026/candidate-office.pptx
@@ -2,24 +2,24 @@
 <file path=ppt/presentation.xml><?xml version="1.0" encoding="utf-8"?>
 <p:presentation xmlns:p="http://schemas.openxmlformats.org/presentationml/2006/main">
   <p:sldMasterIdLst>
-    <p:sldMasterId xmlns:r="http://schemas.openxmlformats.org/officeDocument/2006/relationships" id="2147483648" r:id="R40483e2a27b84bbf"/>
+    <p:sldMasterId xmlns:r="http://schemas.openxmlformats.org/officeDocument/2006/relationships" id="2147483648" r:id="R3c46b76b0cc34227"/>
   </p:sldMasterIdLst>
   <p:notesMasterIdLst>
-    <p:notesMasterId xmlns:r="http://schemas.openxmlformats.org/officeDocument/2006/relationships" r:id="R6e46b2d23d374710"/>
+    <p:notesMasterId xmlns:r="http://schemas.openxmlformats.org/officeDocument/2006/relationships" r:id="R62284e0cfa5c408d"/>
   </p:notesMasterIdLst>
   <p:sldIdLst>
-    <p:sldId xmlns:r="http://schemas.openxmlformats.org/officeDocument/2006/relationships" id="256" r:id="Re889ad5010354c79"/>
-    <p:sldId xmlns:r="http://schemas.openxmlformats.org/officeDocument/2006/relationships" id="257" r:id="R171cff4e99ed4c3b"/>
-    <p:sldId xmlns:r="http://schemas.openxmlformats.org/officeDocument/2006/relationships" id="258" r:id="Rc4751f8919944da3"/>
-    <p:sldId xmlns:r="http://schemas.openxmlformats.org/officeDocument/2006/relationships" id="259" r:id="R6c1b53e4674b415e"/>
-    <p:sldId xmlns:r="http://schemas.openxmlformats.org/officeDocument/2006/relationships" id="260" r:id="Rb75198cd302d4e73"/>
-    <p:sldId xmlns:r="http://schemas.openxmlformats.org/officeDocument/2006/relationships" id="261" r:id="R23601064cdc04567"/>
-    <p:sldId xmlns:r="http://schemas.openxmlformats.org/officeDocument/2006/relationships" id="262" r:id="R814598578afc4db6"/>
-    <p:sldId xmlns:r="http://schemas.openxmlformats.org/officeDocument/2006/relationships" id="263" r:id="Rb1a56b7633e5413e"/>
-    <p:sldId xmlns:r="http://schemas.openxmlformats.org/officeDocument/2006/relationships" id="264" r:id="R3524d0c9fbaf403e"/>
-    <p:sldId xmlns:r="http://schemas.openxmlformats.org/officeDocument/2006/relationships" id="265" r:id="R6356dac6bec44d9c"/>
-    <p:sldId xmlns:r="http://schemas.openxmlformats.org/officeDocument/2006/relationships" id="266" r:id="R3a8137006e3644fd"/>
-    <p:sldId xmlns:r="http://schemas.openxmlformats.org/officeDocument/2006/relationships" id="267" r:id="R201cc89ca40d4eb9"/>
+    <p:sldId xmlns:r="http://schemas.openxmlformats.org/officeDocument/2006/relationships" id="256" r:id="R8ee3d26385d54eeb"/>
+    <p:sldId xmlns:r="http://schemas.openxmlformats.org/officeDocument/2006/relationships" id="257" r:id="R9ea0552288614654"/>
+    <p:sldId xmlns:r="http://schemas.openxmlformats.org/officeDocument/2006/relationships" id="258" r:id="R32a8fa536e4b434c"/>
+    <p:sldId xmlns:r="http://schemas.openxmlformats.org/officeDocument/2006/relationships" id="259" r:id="Rb47d802876b74450"/>
+    <p:sldId xmlns:r="http://schemas.openxmlformats.org/officeDocument/2006/relationships" id="260" r:id="R29fd6d784e214f9b"/>
+    <p:sldId xmlns:r="http://schemas.openxmlformats.org/officeDocument/2006/relationships" id="261" r:id="Rfdc10bd9afee4eab"/>
+    <p:sldId xmlns:r="http://schemas.openxmlformats.org/officeDocument/2006/relationships" id="262" r:id="Rc7d7b02ffdc1475b"/>
+    <p:sldId xmlns:r="http://schemas.openxmlformats.org/officeDocument/2006/relationships" id="263" r:id="R2e81141eb700433b"/>
+    <p:sldId xmlns:r="http://schemas.openxmlformats.org/officeDocument/2006/relationships" id="264" r:id="R0ae1bcfb86cd4de2"/>
+    <p:sldId xmlns:r="http://schemas.openxmlformats.org/officeDocument/2006/relationships" id="265" r:id="R0800c2e77a1c4a7d"/>
+    <p:sldId xmlns:r="http://schemas.openxmlformats.org/officeDocument/2006/relationships" id="266" r:id="R4dfa24cf67e04e22"/>
+    <p:sldId xmlns:r="http://schemas.openxmlformats.org/officeDocument/2006/relationships" id="267" r:id="R9a86e81f127e4d11"/>
   </p:sldIdLst>
   <p:sldSz cx="18288000" cy="10287000"/>
   <p:notesSz cx="6858000" cy="9144000"/>
@@ -468,7 +468,7 @@
           </a:p>
           <a:p xmlns:a="http://schemas.openxmlformats.org/drawingml/2006/main">
             <a:r>
-              <a:t>Hướng dẫn trình bày, mục 2: sources/guidelines/PRM323_Lab2_HuongDan_Slide_Presentation_Demo.docx</a:t>
+              <a:t>Hướng dẫn trình bày, mục 2: https://github.com/PhamQuangDuc1/PRM.POWER9/blob/aed77f1ccd9b8721816932cc7471992fbb7b7be8/output/presentation/Power9_Office_Lab2/sources/guidelines/PRM323_Lab2_HuongDan_Slide_Presentation_Demo.docx</a:t>
             </a:r>
           </a:p>
           <a:p xmlns:a="http://schemas.openxmlformats.org/drawingml/2006/main">
@@ -573,7 +573,7 @@
           </a:p>
           <a:p xmlns:a="http://schemas.openxmlformats.org/drawingml/2006/main">
             <a:r>
-              <a:t>Audit 360 / 412: sources/assets/figma/office-six-page-audit.json</a:t>
+              <a:t>Audit 360 / 412: https://github.com/PhamQuangDuc1/PRM.POWER9/blob/aed77f1ccd9b8721816932cc7471992fbb7b7be8/assets/figma/office-six-page-audit.json</a:t>
             </a:r>
           </a:p>
         </p:txBody>
@@ -663,12 +663,12 @@
           </a:p>
           <a:p xmlns:a="http://schemas.openxmlformats.org/drawingml/2006/main">
             <a:r>
-              <a:t>Kiểm tra dữ liệu flow: sources/assets/figma/office-behavior-audit.json</a:t>
+              <a:t>Kiểm tra dữ liệu flow: https://github.com/PhamQuangDuc1/PRM.POWER9/blob/aed77f1ccd9b8721816932cc7471992fbb7b7be8/assets/figma/office-behavior-audit.json</a:t>
             </a:r>
           </a:p>
           <a:p xmlns:a="http://schemas.openxmlformats.org/drawingml/2006/main">
             <a:r>
-              <a:t>Kiểm tra accordion: sources/assets/figma/office-accordion-audit.json</a:t>
+              <a:t>Kiểm tra accordion: https://github.com/PhamQuangDuc1/PRM.POWER9/blob/aed77f1ccd9b8721816932cc7471992fbb7b7be8/assets/figma/office-accordion-audit.json</a:t>
             </a:r>
           </a:p>
         </p:txBody>
@@ -738,7 +738,7 @@
           <a:lstStyle xmlns:a="http://schemas.openxmlformats.org/drawingml/2006/main"/>
           <a:p xmlns:a="http://schemas.openxmlformats.org/drawingml/2006/main">
             <a:r>
-              <a:t>Handoff Office có đủ sáu mục mỗi màn: layout, component, state, tương tác, điều hướng và ràng buộc UI. Hai bảng mapping mô tả token sang Flutter và component sang widget. Lập trình viên cần triển khai elapsed time thật, form tạm tách khỏi dữ liệu đã lưu và ghi nhận không trùng. Thiết kế và prototype đã sẵn sàng để trình bày. Trước buổi chấm cần tập demo, xác nhận toàn văn prompt thực gửi và kiểm tra quyền xem link bằng cửa sổ chưa đăng nhập. Nhóm chưa khảo sát persona, chưa có user test và chưa viết Flutter hoặc backend.</a:t>
+              <a:t>Handoff Office có sáu mục cho mỗi màn: bố cục, component, trạng thái, tương tác, điều hướng và ràng buộc UI. Hai bảng mapping nối token sang Flutter và component sang widget. Ví dụ màu dùng ColorScheme, chữ dùng TextTheme và accordion dùng ExpansionTile hoặc widget tùy chỉnh. Lập trình viên cần triển khai thời gian thực, draft riêng dữ liệu đã lưu và chống ghi nhận trùng. Nhóm bàn giao thiết kế, chưa có ứng dụng Flutter hoặc backend. Trước buổi trình bày cần mở thử quyền Figma và tập ba flow. Tiếp theo là kiểm thử với người dùng, TalkBack và chữ phóng lớn.</a:t>
             </a:r>
           </a:p>
           <a:p xmlns:a="http://schemas.openxmlformats.org/drawingml/2006/main">
@@ -753,7 +753,7 @@
           </a:p>
           <a:p xmlns:a="http://schemas.openxmlformats.org/drawingml/2006/main">
             <a:r>
-              <a:t>Handoff 10 màn, 6 mục/màn: sources/handoff/flutter-handoff.md</a:t>
+              <a:t>Handoff 10 màn, 6 mục/màn: https://github.com/PhamQuangDuc1/PRM.POWER9/blob/aed77f1ccd9b8721816932cc7471992fbb7b7be8/handoff/flutter-handoff.md</a:t>
             </a:r>
           </a:p>
           <a:p xmlns:a="http://schemas.openxmlformats.org/drawingml/2006/main">
@@ -763,7 +763,7 @@
           </a:p>
           <a:p xmlns:a="http://schemas.openxmlformats.org/drawingml/2006/main">
             <a:r>
-              <a:t>Repo và Figma: sources/README.md</a:t>
+              <a:t>GitHub dự án: https://github.com/PhamQuangDuc1/PRM.POWER9</a:t>
             </a:r>
           </a:p>
         </p:txBody>
@@ -848,12 +848,12 @@
           </a:p>
           <a:p xmlns:a="http://schemas.openxmlformats.org/drawingml/2006/main">
             <a:r>
-              <a:t>Ba persona và nhu cầu: sources/ux/persona.md</a:t>
+              <a:t>Ba persona và nhu cầu: https://github.com/PhamQuangDuc1/PRM.POWER9/blob/aed77f1ccd9b8721816932cc7471992fbb7b7be8/ux/persona.md</a:t>
             </a:r>
           </a:p>
           <a:p xmlns:a="http://schemas.openxmlformats.org/drawingml/2006/main">
             <a:r>
-              <a:t>Phạm vi và tiêu chí Lab 2: sources/guidelines/PRM323_Lab2_HuongDan_Slide_Presentation_Demo.docx</a:t>
+              <a:t>Phạm vi thiết kế Office: https://github.com/PhamQuangDuc1/PRM.POWER9/blob/aed77f1ccd9b8721816932cc7471992fbb7b7be8/design/DESIGN.md</a:t>
             </a:r>
           </a:p>
         </p:txBody>
@@ -938,7 +938,7 @@
           </a:p>
           <a:p xmlns:a="http://schemas.openxmlformats.org/drawingml/2006/main">
             <a:r>
-              <a:t>IA và mapping flow: sources/ux/user-flow.md</a:t>
+              <a:t>IA và mapping flow: https://github.com/PhamQuangDuc1/PRM.POWER9/blob/aed77f1ccd9b8721816932cc7471992fbb7b7be8/ux/user-flow.md</a:t>
             </a:r>
           </a:p>
           <a:p xmlns:a="http://schemas.openxmlformats.org/drawingml/2006/main">
@@ -1028,7 +1028,7 @@
           </a:p>
           <a:p xmlns:a="http://schemas.openxmlformats.org/drawingml/2006/main">
             <a:r>
-              <a:t>Đặc tả ba flow: sources/ux/user-flow.md</a:t>
+              <a:t>Đặc tả ba flow: https://github.com/PhamQuangDuc1/PRM.POWER9/blob/aed77f1ccd9b8721816932cc7471992fbb7b7be8/ux/user-flow.md</a:t>
             </a:r>
           </a:p>
           <a:p xmlns:a="http://schemas.openxmlformats.org/drawingml/2006/main">
@@ -1103,7 +1103,7 @@
           <a:lstStyle xmlns:a="http://schemas.openxmlformats.org/drawingml/2006/main"/>
           <a:p xmlns:a="http://schemas.openxmlformats.org/drawingml/2006/main">
             <a:r>
-              <a:t>Bên trái là trích nguyên văn từ bản prompt được lưu trong dự án. Toàn văn có ở nguồn và cuối notes. Prompt mô tả ba persona, nhiệm vụ Android, mười wireframe, phong cách xanh biển và ràng buộc về chữ, kích thước, điều hướng. Bên phải là output Stitch thật đã được cung cấp. Cần phân biệt bản prompt lưu với log chat đã gửi: hiện chưa có đầy đủ log chat để đối chiếu 100 phần trăm bản thực gửi. Nhóm không tự gán tên model nền của Stitch hoặc dùng lời báo hoàn thành của AI thay cho kiểm tra thiết kế.</a:t>
+              <a:t>Nhóm dùng Google Stitch để tạo UI từ mười wireframe Office đã chốt. Prompt quy định ba persona, Android, chín nhóm nội dung, màu xanh biển, font Be Vietnam Pro và hai chiều rộng 360, 412. Người dùng đã xác nhận gửi nguyên văn 100% các prompt Office do trợ lý cung cấp trên dự án Stitch mới. Bên phải là ảnh output Stitch thật. Toàn văn prompt giữ trong notes và nguồn GitHub. Codex hỗ trợ phân tích, phản biện, kiểm tra và biên soạn tài liệu. Nhóm quyết định giữ, sửa hoặc loại đề xuất dựa trên nhiệm vụ và bằng chứng.</a:t>
             </a:r>
           </a:p>
           <a:p xmlns:a="http://schemas.openxmlformats.org/drawingml/2006/main">
@@ -1114,31 +1114,6 @@
           <a:p xmlns:a="http://schemas.openxmlformats.org/drawingml/2006/main">
             <a:r>
               <a:t>TOÀN VĂN PROMPT LƯU</a:t>
-            </a:r>
-          </a:p>
-          <a:p xmlns:a="http://schemas.openxmlformats.org/drawingml/2006/main">
-            <a:r>
-              <a:t># UI01 — từ wireframe Office đã chốt</a:t>
-            </a:r>
-          </a:p>
-          <a:p xmlns:a="http://schemas.openxmlformats.org/drawingml/2006/main">
-            <a:r>
-              <a:t/>
-            </a:r>
-          </a:p>
-          <a:p xmlns:a="http://schemas.openxmlformats.org/drawingml/2006/main">
-            <a:r>
-              <a:t>Trạng thái: prompt chuẩn bị, chưa gửi/chưa có output. Chọn đúng 10 wireframe đã xuất ZIP, đính kèm logo gốc. Nếu có thể, kèm ảnh UI xanh biển cũ để tham chiếu phong cách. Chỉ gửi khối dưới.</a:t>
-            </a:r>
-          </a:p>
-          <a:p xmlns:a="http://schemas.openxmlformats.org/drawingml/2006/main">
-            <a:r>
-              <a:t/>
-            </a:r>
-          </a:p>
-          <a:p xmlns:a="http://schemas.openxmlformats.org/drawingml/2006/main">
-            <a:r>
-              <a:t>```text</a:t>
             </a:r>
           </a:p>
           <a:p xmlns:a="http://schemas.openxmlformats.org/drawingml/2006/main">
@@ -1393,11 +1368,6 @@
           </a:p>
           <a:p xmlns:a="http://schemas.openxmlformats.org/drawingml/2006/main">
             <a:r>
-              <a:t>```</a:t>
-            </a:r>
-          </a:p>
-          <a:p xmlns:a="http://schemas.openxmlformats.org/drawingml/2006/main">
-            <a:r>
               <a:t/>
             </a:r>
           </a:p>
@@ -1413,12 +1383,12 @@
           </a:p>
           <a:p xmlns:a="http://schemas.openxmlformats.org/drawingml/2006/main">
             <a:r>
-              <a:t>Prompt UI01 lưu trong dự án: sources/ai/prompts/OFFICE-UI01-from-final-wireframe.md</a:t>
+              <a:t>Prompt UI01 lưu trong dự án: https://github.com/PhamQuangDuc1/PRM.POWER9/blob/aed77f1ccd9b8721816932cc7471992fbb7b7be8/ai/prompts/OFFICE-UI01-from-final-wireframe.md</a:t>
             </a:r>
           </a:p>
           <a:p xmlns:a="http://schemas.openxmlformats.org/drawingml/2006/main">
             <a:r>
-              <a:t>Brief và AI log: sources/ai/ai-design-log.md</a:t>
+              <a:t>Brief và AI log: https://github.com/PhamQuangDuc1/PRM.POWER9/blob/aed77f1ccd9b8721816932cc7471992fbb7b7be8/ai/ai-design-log.md</a:t>
             </a:r>
           </a:p>
           <a:p xmlns:a="http://schemas.openxmlformats.org/drawingml/2006/main">
@@ -1508,17 +1478,12 @@
           </a:p>
           <a:p xmlns:a="http://schemas.openxmlformats.org/drawingml/2006/main">
             <a:r>
-              <a:t>3 vòng và bộ ảnh nguồn: sources/docs/SLIDE-3-VONG-PHAN-BIEN.md</a:t>
+              <a:t>3 vòng và bộ ảnh nguồn: https://github.com/PhamQuangDuc1/PRM.POWER9/blob/aed77f1ccd9b8721816932cc7471992fbb7b7be8/docs/SLIDE-3-VONG-PHAN-BIEN.md</a:t>
             </a:r>
           </a:p>
           <a:p xmlns:a="http://schemas.openxmlformats.org/drawingml/2006/main">
             <a:r>
-              <a:t>Phản biện C01–C03: sources/ai/critiques/OFFICE-3-MAIN-CRITIQUES.md</a:t>
-            </a:r>
-          </a:p>
-          <a:p xmlns:a="http://schemas.openxmlformats.org/drawingml/2006/main">
-            <a:r>
-              <a:t>Nielsen heuristics: https://www.nngroup.com/articles/ten-usability-heuristics/</a:t>
+              <a:t>Phản biện C01–C03: https://github.com/PhamQuangDuc1/PRM.POWER9/blob/aed77f1ccd9b8721816932cc7471992fbb7b7be8/ai/critiques/OFFICE-3-MAIN-CRITIQUES.md</a:t>
             </a:r>
           </a:p>
         </p:txBody>
@@ -1588,7 +1553,7 @@
           <a:lstStyle xmlns:a="http://schemas.openxmlformats.org/drawingml/2006/main"/>
           <a:p xmlns:a="http://schemas.openxmlformats.org/drawingml/2006/main">
             <a:r>
-              <a:t>Nhóm chấp nhận sửa font để giao diện thống nhất với design system. Nhóm chấp nhận bỏ banner ngoài nhiệm vụ, vì người dùng cần xử lý một việc ngắn. Với state lỗi, nhóm điều chỉnh output AI: tên hoạt động, ngày và giờ phải được giữ nguyên. Metric như nhịp tim ước tính hoặc điểm sức khỏe bị loại vì không có nguồn dữ liệu hay tính năng đo tương ứng. Sau góp ý về nhóm 07, nhóm bổ sung mở và thu gọn cho cả chín nhóm. Quyết định dựa trên persona, tính nhất quán, khả năng kiểm soát và phục hồi lỗi.</a:t>
+              <a:t>Nhóm chấp nhận sửa font theo Nielsen 4 về tính nhất quán. Nhóm chấp nhận giảm banner và hiện đủ tên để Mai tìm hoạt động trong giờ nghỉ. Với lỗi lưu, nhóm điều chỉnh output AI để Linh không mất tên hoạt động, ngày và giờ khi bị ngắt quãng. Nhóm từ chối nhịp tim và điểm sức khỏe vì chưa có dữ liệu đo. Nhóm sửa mở và thu gọn cho cả chín nhóm Khám phá theo quyền kiểm soát và tính nhất quán. Năm phát hiện, quyết định và lý do đều có ngay trên slide.</a:t>
             </a:r>
           </a:p>
           <a:p xmlns:a="http://schemas.openxmlformats.org/drawingml/2006/main">
@@ -1603,12 +1568,12 @@
           </a:p>
           <a:p xmlns:a="http://schemas.openxmlformats.org/drawingml/2006/main">
             <a:r>
-              <a:t>Quyết định và lý do: sources/design/design-decisions.md</a:t>
+              <a:t>Quyết định và lý do: https://github.com/PhamQuangDuc1/PRM.POWER9/blob/aed77f1ccd9b8721816932cc7471992fbb7b7be8/design/design-decisions.md</a:t>
             </a:r>
           </a:p>
           <a:p xmlns:a="http://schemas.openxmlformats.org/drawingml/2006/main">
             <a:r>
-              <a:t>Review trạng thái OI03: sources/ai/critiques/OFFICE-OI03-expanded-review.md</a:t>
+              <a:t>Review trạng thái OI03: https://github.com/PhamQuangDuc1/PRM.POWER9/blob/aed77f1ccd9b8721816932cc7471992fbb7b7be8/ai/critiques/OFFICE-OI03-expanded-review.md</a:t>
             </a:r>
           </a:p>
           <a:p xmlns:a="http://schemas.openxmlformats.org/drawingml/2006/main">
@@ -1698,7 +1663,7 @@
           </a:p>
           <a:p xmlns:a="http://schemas.openxmlformats.org/drawingml/2006/main">
             <a:r>
-              <a:t>Wireframe nguồn Stitch S07: sources/evidence/WIREFRAME-S07.png</a:t>
+              <a:t>Wireframe nguồn Stitch S07: https://github.com/PhamQuangDuc1/PRM.POWER9/blob/aed77f1ccd9b8721816932cc7471992fbb7b7be8/output/presentation/Power9_Office_Lab2/sources/evidence/WIREFRAME-S07.png</a:t>
             </a:r>
           </a:p>
           <a:p xmlns:a="http://schemas.openxmlformats.org/drawingml/2006/main">
@@ -1708,7 +1673,7 @@
           </a:p>
           <a:p xmlns:a="http://schemas.openxmlformats.org/drawingml/2006/main">
             <a:r>
-              <a:t>Nguồn ảnh và node: sources/evidence-provenance.json</a:t>
+              <a:t>Nguồn ảnh và node: https://github.com/PhamQuangDuc1/PRM.POWER9/blob/aed77f1ccd9b8721816932cc7471992fbb7b7be8/output/presentation/Power9_Office_Lab2/sources/evidence-provenance.json</a:t>
             </a:r>
           </a:p>
         </p:txBody>
@@ -1803,7 +1768,7 @@
           </a:p>
           <a:p xmlns:a="http://schemas.openxmlformats.org/drawingml/2006/main">
             <a:r>
-              <a:t>Audit thư viện và accordion: sources/assets/figma/office-checkpoint.json</a:t>
+              <a:t>Audit thư viện và accordion: https://github.com/PhamQuangDuc1/PRM.POWER9/blob/aed77f1ccd9b8721816932cc7471992fbb7b7be8/assets/figma/office-checkpoint.json</a:t>
             </a:r>
           </a:p>
         </p:txBody>
@@ -1850,7 +1815,7 @@
           <p:cNvPr id="3" name="Title">
             <a:extLst xmlns:a="http://schemas.openxmlformats.org/drawingml/2006/main">
               <a:ext uri="{FF2B5EF4-FFF2-40B4-BE49-F238E27FC236}">
-                <a16:creationId xmlns:a16="http://schemas.microsoft.com/office/drawing/2014/main" id="{8A1C7DA0-57DE-445A-B2C0-9135788B7AE6}"/>
+                <a16:creationId xmlns:a16="http://schemas.microsoft.com/office/drawing/2014/main" id="{B949263B-86CE-4C25-8631-DE02D11F9481}"/>
               </a:ext>
             </a:extLst>
           </p:cNvPr>
@@ -2079,7 +2044,7 @@
           <p:cNvPr id="2" name="Subtitle">
             <a:extLst xmlns:a="http://schemas.openxmlformats.org/drawingml/2006/main">
               <a:ext uri="{FF2B5EF4-FFF2-40B4-BE49-F238E27FC236}">
-                <a16:creationId xmlns:a16="http://schemas.microsoft.com/office/drawing/2014/main" id="{97770474-FFA1-43B3-BD6C-40F411A4C76E}"/>
+                <a16:creationId xmlns:a16="http://schemas.microsoft.com/office/drawing/2014/main" id="{260F4120-B5B0-4416-BAAA-A7E0EF9230B6}"/>
               </a:ext>
             </a:extLst>
           </p:cNvPr>
@@ -2325,7 +2290,7 @@
           <p:cNvPr id="2" name="Section title">
             <a:extLst xmlns:a="http://schemas.openxmlformats.org/drawingml/2006/main">
               <a:ext uri="{FF2B5EF4-FFF2-40B4-BE49-F238E27FC236}">
-                <a16:creationId xmlns:a16="http://schemas.microsoft.com/office/drawing/2014/main" id="{B03F20E5-3984-4744-ABB5-5BE876CF1ADE}"/>
+                <a16:creationId xmlns:a16="http://schemas.microsoft.com/office/drawing/2014/main" id="{9D6E572F-B812-47AA-A7CA-E54AD8A7983D}"/>
               </a:ext>
             </a:extLst>
           </p:cNvPr>
@@ -2571,7 +2536,7 @@
           <p:cNvPr id="3" name="Title">
             <a:extLst xmlns:a="http://schemas.openxmlformats.org/drawingml/2006/main">
               <a:ext uri="{FF2B5EF4-FFF2-40B4-BE49-F238E27FC236}">
-                <a16:creationId xmlns:a16="http://schemas.microsoft.com/office/drawing/2014/main" id="{3DC9A807-3F6E-439B-89D3-F008885EB4B5}"/>
+                <a16:creationId xmlns:a16="http://schemas.microsoft.com/office/drawing/2014/main" id="{0D2A177B-4911-4CB0-AF45-2575C33D333A}"/>
               </a:ext>
             </a:extLst>
           </p:cNvPr>
@@ -2800,7 +2765,7 @@
           <p:cNvPr id="2" name="Body">
             <a:extLst xmlns:a="http://schemas.openxmlformats.org/drawingml/2006/main">
               <a:ext uri="{FF2B5EF4-FFF2-40B4-BE49-F238E27FC236}">
-                <a16:creationId xmlns:a16="http://schemas.microsoft.com/office/drawing/2014/main" id="{F7EDCB73-3773-427B-B8FC-E5110BA7CD2E}"/>
+                <a16:creationId xmlns:a16="http://schemas.microsoft.com/office/drawing/2014/main" id="{4C11A2BF-DDD7-49AD-8D6E-38EEEEAF951A}"/>
               </a:ext>
             </a:extLst>
           </p:cNvPr>
@@ -3046,7 +3011,7 @@
           <p:cNvPr id="4" name="Title">
             <a:extLst xmlns:a="http://schemas.openxmlformats.org/drawingml/2006/main">
               <a:ext uri="{FF2B5EF4-FFF2-40B4-BE49-F238E27FC236}">
-                <a16:creationId xmlns:a16="http://schemas.microsoft.com/office/drawing/2014/main" id="{185A94ED-3B7C-432B-AB79-171703BBA2D6}"/>
+                <a16:creationId xmlns:a16="http://schemas.microsoft.com/office/drawing/2014/main" id="{BD829607-F28A-4DC6-B1C1-B339454BFB00}"/>
               </a:ext>
             </a:extLst>
           </p:cNvPr>
@@ -3275,7 +3240,7 @@
           <p:cNvPr id="2" name="Left column">
             <a:extLst xmlns:a="http://schemas.openxmlformats.org/drawingml/2006/main">
               <a:ext uri="{FF2B5EF4-FFF2-40B4-BE49-F238E27FC236}">
-                <a16:creationId xmlns:a16="http://schemas.microsoft.com/office/drawing/2014/main" id="{24FC1C5D-44FD-4488-9C89-DEBF363C7179}"/>
+                <a16:creationId xmlns:a16="http://schemas.microsoft.com/office/drawing/2014/main" id="{A548D8D4-BC43-4838-BCC8-FAA60920A337}"/>
               </a:ext>
             </a:extLst>
           </p:cNvPr>
@@ -3504,7 +3469,7 @@
           <p:cNvPr id="3" name="Right column">
             <a:extLst xmlns:a="http://schemas.openxmlformats.org/drawingml/2006/main">
               <a:ext uri="{FF2B5EF4-FFF2-40B4-BE49-F238E27FC236}">
-                <a16:creationId xmlns:a16="http://schemas.microsoft.com/office/drawing/2014/main" id="{E500F963-D16C-4D6E-9889-1FCAB77EA25C}"/>
+                <a16:creationId xmlns:a16="http://schemas.microsoft.com/office/drawing/2014/main" id="{B4BBA63C-AD3F-41E1-8038-21064B2B3409}"/>
               </a:ext>
             </a:extLst>
           </p:cNvPr>
@@ -3750,7 +3715,7 @@
           <p:cNvPr id="3" name="Title">
             <a:extLst xmlns:a="http://schemas.openxmlformats.org/drawingml/2006/main">
               <a:ext uri="{FF2B5EF4-FFF2-40B4-BE49-F238E27FC236}">
-                <a16:creationId xmlns:a16="http://schemas.microsoft.com/office/drawing/2014/main" id="{BAB5484A-99C3-42BB-AE95-77D8A9F5A274}"/>
+                <a16:creationId xmlns:a16="http://schemas.microsoft.com/office/drawing/2014/main" id="{E298F7E2-90AF-4E70-A0AF-32D512140076}"/>
               </a:ext>
             </a:extLst>
           </p:cNvPr>
@@ -3979,7 +3944,7 @@
           <p:cNvPr id="2" name="Left column">
             <a:extLst xmlns:a="http://schemas.openxmlformats.org/drawingml/2006/main">
               <a:ext uri="{FF2B5EF4-FFF2-40B4-BE49-F238E27FC236}">
-                <a16:creationId xmlns:a16="http://schemas.microsoft.com/office/drawing/2014/main" id="{ABF13C04-2DE2-49C8-862A-32A2D734AA19}"/>
+                <a16:creationId xmlns:a16="http://schemas.microsoft.com/office/drawing/2014/main" id="{06E71D6F-F449-4DEA-93F0-51306CAC40A4}"/>
               </a:ext>
             </a:extLst>
           </p:cNvPr>
@@ -4246,12 +4211,12 @@
   </p:cSld>
   <p:clrMap bg1="lt1" tx1="dk1" bg2="lt2" tx2="dk2" accent1="accent1" accent2="accent2" accent3="accent3" accent4="accent4" accent5="accent5" accent6="accent6" hlink="hlink" folHlink="folHlink"/>
   <p:sldLayoutIdLst>
-    <p:sldLayoutId xmlns:r="http://schemas.openxmlformats.org/officeDocument/2006/relationships" id="2147483649" r:id="R68d4b1e9f488447f"/>
-    <p:sldLayoutId xmlns:r="http://schemas.openxmlformats.org/officeDocument/2006/relationships" id="2147483650" r:id="Red226369d5ab483d"/>
-    <p:sldLayoutId xmlns:r="http://schemas.openxmlformats.org/officeDocument/2006/relationships" id="2147483651" r:id="R4a4c1575311943aa"/>
-    <p:sldLayoutId xmlns:r="http://schemas.openxmlformats.org/officeDocument/2006/relationships" id="2147483652" r:id="R4b0095ee7d294242"/>
-    <p:sldLayoutId xmlns:r="http://schemas.openxmlformats.org/officeDocument/2006/relationships" id="2147483653" r:id="R9086d3a401854850"/>
-    <p:sldLayoutId xmlns:r="http://schemas.openxmlformats.org/officeDocument/2006/relationships" id="2147483654" r:id="R93565d019be44c53"/>
+    <p:sldLayoutId xmlns:r="http://schemas.openxmlformats.org/officeDocument/2006/relationships" id="2147483649" r:id="R35261b3fa23c4348"/>
+    <p:sldLayoutId xmlns:r="http://schemas.openxmlformats.org/officeDocument/2006/relationships" id="2147483650" r:id="Rdf501f3151fc407d"/>
+    <p:sldLayoutId xmlns:r="http://schemas.openxmlformats.org/officeDocument/2006/relationships" id="2147483651" r:id="Re65b6bb3762245a8"/>
+    <p:sldLayoutId xmlns:r="http://schemas.openxmlformats.org/officeDocument/2006/relationships" id="2147483652" r:id="R552bac15b076418d"/>
+    <p:sldLayoutId xmlns:r="http://schemas.openxmlformats.org/officeDocument/2006/relationships" id="2147483653" r:id="R3c69a92de1c54e92"/>
+    <p:sldLayoutId xmlns:r="http://schemas.openxmlformats.org/officeDocument/2006/relationships" id="2147483654" r:id="Re792a5748b8344cb"/>
   </p:sldLayoutIdLst>
   <p:txStyles>
     <p:titleStyle>
@@ -4802,7 +4767,7 @@
           <p:cNvPr id="12" name="Power9 Office Routine">
             <a:extLst xmlns:a="http://schemas.openxmlformats.org/drawingml/2006/main">
               <a:ext uri="{FF2B5EF4-FFF2-40B4-BE49-F238E27FC236}">
-                <a16:creationId xmlns:a16="http://schemas.microsoft.com/office/drawing/2014/main" id="{077556F8-BAD6-458B-B5FE-E4878C16474C}"/>
+                <a16:creationId xmlns:a16="http://schemas.microsoft.com/office/drawing/2014/main" id="{B3C5CC3F-AC14-4CD6-8DC9-FD0EEB3ED610}"/>
               </a:ext>
             </a:extLst>
           </p:cNvPr>
@@ -4960,7 +4925,7 @@
           <p:cNvPr id="2" name="PRM323 Lab 2   Thiết kế UI/UX có hỗ trợ AI">
             <a:extLst xmlns:a="http://schemas.openxmlformats.org/drawingml/2006/main">
               <a:ext uri="{FF2B5EF4-FFF2-40B4-BE49-F238E27FC236}">
-                <a16:creationId xmlns:a16="http://schemas.microsoft.com/office/drawing/2014/main" id="{B1D1A24D-424E-44C0-A057-0C23EEACB338}"/>
+                <a16:creationId xmlns:a16="http://schemas.microsoft.com/office/drawing/2014/main" id="{2D8D8447-AF9F-436F-B1FF-88CF4F3DCCB1}"/>
               </a:ext>
             </a:extLst>
           </p:cNvPr>
@@ -5118,7 +5083,7 @@
           <p:cNvPr id="3" name="01 / 12">
             <a:extLst xmlns:a="http://schemas.openxmlformats.org/drawingml/2006/main">
               <a:ext uri="{FF2B5EF4-FFF2-40B4-BE49-F238E27FC236}">
-                <a16:creationId xmlns:a16="http://schemas.microsoft.com/office/drawing/2014/main" id="{5E1AB691-7D94-4FA7-B080-D22DE2CA3D47}"/>
+                <a16:creationId xmlns:a16="http://schemas.microsoft.com/office/drawing/2014/main" id="{6BA02FE8-89F4-4A72-9781-D8CA10E352B1}"/>
               </a:ext>
             </a:extLst>
           </p:cNvPr>
@@ -5276,7 +5241,7 @@
           <p:cNvPr id="4" name="Nguồn">
             <a:extLst xmlns:a="http://schemas.openxmlformats.org/drawingml/2006/main">
               <a:ext uri="{FF2B5EF4-FFF2-40B4-BE49-F238E27FC236}">
-                <a16:creationId xmlns:a16="http://schemas.microsoft.com/office/drawing/2014/main" id="{EA7A32AE-251D-4ED9-BFE7-222A1AE3B648}"/>
+                <a16:creationId xmlns:a16="http://schemas.microsoft.com/office/drawing/2014/main" id="{1C89AC75-82FF-45F1-9C8C-0FE493D931DD}"/>
               </a:ext>
             </a:extLst>
           </p:cNvPr>
@@ -5434,7 +5399,7 @@
           <p:cNvPr id="5" name="Hướng dẫn trình bày, mục 2">
             <a:extLst xmlns:a="http://schemas.openxmlformats.org/drawingml/2006/main">
               <a:ext uri="{FF2B5EF4-FFF2-40B4-BE49-F238E27FC236}">
-                <a16:creationId xmlns:a16="http://schemas.microsoft.com/office/drawing/2014/main" id="{28E3D4E2-2F54-4F56-9D8E-F807CB4A761E}"/>
+                <a16:creationId xmlns:a16="http://schemas.microsoft.com/office/drawing/2014/main" id="{044F4AEF-C526-4C4A-A3B7-6A5DA0EA6740}"/>
               </a:ext>
             </a:extLst>
           </p:cNvPr>
@@ -5581,7 +5546,7 @@
                 <a:latin typeface="Noto Sans"/>
                 <a:ea typeface="Noto Sans"/>
                 <a:cs typeface="Noto Sans"/>
-                <a:hlinkClick xmlns:r="http://schemas.openxmlformats.org/officeDocument/2006/relationships" r:id="R67dea16a426649e1"/>
+                <a:hlinkClick xmlns:r="http://schemas.openxmlformats.org/officeDocument/2006/relationships" r:id="Rab78d61f946b4a6e"/>
               </a:rPr>
               <a:t>Hướng dẫn trình bày, mục 2</a:t>
             </a:r>
@@ -5593,7 +5558,7 @@
           <p:cNvPr id="6" name="Figma hiện hành">
             <a:extLst xmlns:a="http://schemas.openxmlformats.org/drawingml/2006/main">
               <a:ext uri="{FF2B5EF4-FFF2-40B4-BE49-F238E27FC236}">
-                <a16:creationId xmlns:a16="http://schemas.microsoft.com/office/drawing/2014/main" id="{D8EA1368-D569-4F78-9C97-D3F5D45CBD1B}"/>
+                <a16:creationId xmlns:a16="http://schemas.microsoft.com/office/drawing/2014/main" id="{CA8A4CB8-50C2-4DAE-9017-C9FC21DED3F5}"/>
               </a:ext>
             </a:extLst>
           </p:cNvPr>
@@ -5740,7 +5705,7 @@
                 <a:latin typeface="Noto Sans"/>
                 <a:ea typeface="Noto Sans"/>
                 <a:cs typeface="Noto Sans"/>
-                <a:hlinkClick xmlns:r="http://schemas.openxmlformats.org/officeDocument/2006/relationships" r:id="R47deadbec24041fd"/>
+                <a:hlinkClick xmlns:r="http://schemas.openxmlformats.org/officeDocument/2006/relationships" r:id="Rff696c116387430d"/>
               </a:rPr>
               <a:t>Figma hiện hành</a:t>
             </a:r>
@@ -5752,7 +5717,7 @@
           <p:cNvPr id="7" name="GitHub dự án">
             <a:extLst xmlns:a="http://schemas.openxmlformats.org/drawingml/2006/main">
               <a:ext uri="{FF2B5EF4-FFF2-40B4-BE49-F238E27FC236}">
-                <a16:creationId xmlns:a16="http://schemas.microsoft.com/office/drawing/2014/main" id="{7A92AFEB-9EC6-462A-A5CD-13849C72D0FB}"/>
+                <a16:creationId xmlns:a16="http://schemas.microsoft.com/office/drawing/2014/main" id="{FE5FF3F6-7F10-461C-BA7A-9C033F331011}"/>
               </a:ext>
             </a:extLst>
           </p:cNvPr>
@@ -5899,7 +5864,7 @@
                 <a:latin typeface="Noto Sans"/>
                 <a:ea typeface="Noto Sans"/>
                 <a:cs typeface="Noto Sans"/>
-                <a:hlinkClick xmlns:r="http://schemas.openxmlformats.org/officeDocument/2006/relationships" r:id="R5fb281bd57f14f78"/>
+                <a:hlinkClick xmlns:r="http://schemas.openxmlformats.org/officeDocument/2006/relationships" r:id="R921e699cda924324"/>
               </a:rPr>
               <a:t>GitHub dự án</a:t>
             </a:r>
@@ -5911,7 +5876,7 @@
           <p:cNvPr id="8" name="Thói quen ngắn&#10;trong ngày làm việc">
             <a:extLst xmlns:a="http://schemas.openxmlformats.org/drawingml/2006/main">
               <a:ext uri="{FF2B5EF4-FFF2-40B4-BE49-F238E27FC236}">
-                <a16:creationId xmlns:a16="http://schemas.microsoft.com/office/drawing/2014/main" id="{C7C75376-99B6-4887-8EB3-899D6B2FF8C8}"/>
+                <a16:creationId xmlns:a16="http://schemas.microsoft.com/office/drawing/2014/main" id="{7E5122AD-1A3F-4381-9004-F7D0AC494CE0}"/>
               </a:ext>
             </a:extLst>
           </p:cNvPr>
@@ -6092,7 +6057,7 @@
           <p:cNvPr id="9" name="Chọn hoạt động phù hợp khoảng nghỉ.&#10;Theo dõi việc tự chọn và">
             <a:extLst xmlns:a="http://schemas.openxmlformats.org/drawingml/2006/main">
               <a:ext uri="{FF2B5EF4-FFF2-40B4-BE49-F238E27FC236}">
-                <a16:creationId xmlns:a16="http://schemas.microsoft.com/office/drawing/2014/main" id="{96704CB8-1C93-4126-A1E6-CE5F87FEB7E8}"/>
+                <a16:creationId xmlns:a16="http://schemas.microsoft.com/office/drawing/2014/main" id="{26C6B16E-0035-44F1-8100-D12E4954EDAB}"/>
               </a:ext>
             </a:extLst>
           </p:cNvPr>
@@ -6273,7 +6238,7 @@
           <p:cNvPr id="10" name="Phạm Quang Đức   Văn Quang Duy&#10;Nguyễn Tống Khánh Vĩnh   Đặng">
             <a:extLst xmlns:a="http://schemas.openxmlformats.org/drawingml/2006/main">
               <a:ext uri="{FF2B5EF4-FFF2-40B4-BE49-F238E27FC236}">
-                <a16:creationId xmlns:a16="http://schemas.microsoft.com/office/drawing/2014/main" id="{7BF311F0-83C2-4614-9603-17762EF48213}"/>
+                <a16:creationId xmlns:a16="http://schemas.microsoft.com/office/drawing/2014/main" id="{5A91912D-112B-4B85-8BCE-E0EF43B4CFAC}"/>
               </a:ext>
             </a:extLst>
           </p:cNvPr>
@@ -6454,7 +6419,7 @@
           <p:cNvPr id="11" name="">
             <a:extLst xmlns:a="http://schemas.openxmlformats.org/drawingml/2006/main">
               <a:ext uri="{FF2B5EF4-FFF2-40B4-BE49-F238E27FC236}">
-                <a16:creationId xmlns:a16="http://schemas.microsoft.com/office/drawing/2014/main" id="{86F9C2BA-374E-41DD-9FB5-D665B1C3C935}"/>
+                <a16:creationId xmlns:a16="http://schemas.microsoft.com/office/drawing/2014/main" id="{3769F3B8-6926-410C-B2B1-8A752009D836}"/>
               </a:ext>
             </a:extLst>
           </p:cNvPr>
@@ -6464,7 +6429,7 @@
           <p:nvPr/>
         </p:nvPicPr>
         <p:blipFill>
-          <a:blip xmlns:r="http://schemas.openxmlformats.org/officeDocument/2006/relationships" xmlns:a="http://schemas.openxmlformats.org/drawingml/2006/main" r:embed="Rf1f952316ae549b4"/>
+          <a:blip xmlns:r="http://schemas.openxmlformats.org/officeDocument/2006/relationships" xmlns:a="http://schemas.openxmlformats.org/drawingml/2006/main" r:embed="R74fe2431b6434233"/>
           <a:stretch xmlns:a="http://schemas.openxmlformats.org/drawingml/2006/main"/>
         </p:blipFill>
         <p:spPr>
@@ -6480,7 +6445,7 @@
     </p:spTree>
     <p:extLst>
       <p:ext uri="{BB962C8B-B14F-4D97-AF65-F5344CB8AC3E}">
-        <p14:creationId xmlns:p14="http://schemas.microsoft.com/office/powerpoint/2010/main" val="840780449"/>
+        <p14:creationId xmlns:p14="http://schemas.microsoft.com/office/powerpoint/2010/main" val="1973584518"/>
       </p:ext>
     </p:extLst>
   </p:cSld>
@@ -6511,7 +6476,7 @@
           <p:cNvPr id="15" name="Accessibility và responsive">
             <a:extLst xmlns:a="http://schemas.openxmlformats.org/drawingml/2006/main">
               <a:ext uri="{FF2B5EF4-FFF2-40B4-BE49-F238E27FC236}">
-                <a16:creationId xmlns:a16="http://schemas.microsoft.com/office/drawing/2014/main" id="{4998408B-FF0B-42ED-98F8-483D7424BAB5}"/>
+                <a16:creationId xmlns:a16="http://schemas.microsoft.com/office/drawing/2014/main" id="{EAC853E1-CA40-4609-8EEF-C0521D8BA2E6}"/>
               </a:ext>
             </a:extLst>
           </p:cNvPr>
@@ -6669,7 +6634,7 @@
           <p:cNvPr id="2" name="Kiểm tra màu, chữ, vùng chạm và bố cục. Không đồng nhất kiểm">
             <a:extLst xmlns:a="http://schemas.openxmlformats.org/drawingml/2006/main">
               <a:ext uri="{FF2B5EF4-FFF2-40B4-BE49-F238E27FC236}">
-                <a16:creationId xmlns:a16="http://schemas.microsoft.com/office/drawing/2014/main" id="{30C651EA-3396-4505-8D28-688A4080ACDD}"/>
+                <a16:creationId xmlns:a16="http://schemas.microsoft.com/office/drawing/2014/main" id="{91EBAB61-2A13-467D-BBEB-806B6287ACF0}"/>
               </a:ext>
             </a:extLst>
           </p:cNvPr>
@@ -6827,7 +6792,7 @@
           <p:cNvPr id="3" name="10 / 12">
             <a:extLst xmlns:a="http://schemas.openxmlformats.org/drawingml/2006/main">
               <a:ext uri="{FF2B5EF4-FFF2-40B4-BE49-F238E27FC236}">
-                <a16:creationId xmlns:a16="http://schemas.microsoft.com/office/drawing/2014/main" id="{963814DB-7EF6-45B7-BF0A-FFB99B38593C}"/>
+                <a16:creationId xmlns:a16="http://schemas.microsoft.com/office/drawing/2014/main" id="{FFECB8B2-CF18-412C-8A9D-E92DAEEB016B}"/>
               </a:ext>
             </a:extLst>
           </p:cNvPr>
@@ -6985,7 +6950,7 @@
           <p:cNvPr id="4" name="Nguồn">
             <a:extLst xmlns:a="http://schemas.openxmlformats.org/drawingml/2006/main">
               <a:ext uri="{FF2B5EF4-FFF2-40B4-BE49-F238E27FC236}">
-                <a16:creationId xmlns:a16="http://schemas.microsoft.com/office/drawing/2014/main" id="{01900B26-8419-47D4-B2D0-9F58F58D3449}"/>
+                <a16:creationId xmlns:a16="http://schemas.microsoft.com/office/drawing/2014/main" id="{7EC3C969-2D9F-4A71-A84E-1F5688161888}"/>
               </a:ext>
             </a:extLst>
           </p:cNvPr>
@@ -7143,7 +7108,7 @@
           <p:cNvPr id="5" name="WCAG Contrast Minimum">
             <a:extLst xmlns:a="http://schemas.openxmlformats.org/drawingml/2006/main">
               <a:ext uri="{FF2B5EF4-FFF2-40B4-BE49-F238E27FC236}">
-                <a16:creationId xmlns:a16="http://schemas.microsoft.com/office/drawing/2014/main" id="{57E58F54-E0B7-4132-B16A-89F71331C1CC}"/>
+                <a16:creationId xmlns:a16="http://schemas.microsoft.com/office/drawing/2014/main" id="{A5D16C74-4FBA-4E7B-A1C9-0E3823EA0A08}"/>
               </a:ext>
             </a:extLst>
           </p:cNvPr>
@@ -7290,7 +7255,7 @@
                 <a:latin typeface="Noto Sans"/>
                 <a:ea typeface="Noto Sans"/>
                 <a:cs typeface="Noto Sans"/>
-                <a:hlinkClick xmlns:r="http://schemas.openxmlformats.org/officeDocument/2006/relationships" r:id="R0baec2571f3f433f"/>
+                <a:hlinkClick xmlns:r="http://schemas.openxmlformats.org/officeDocument/2006/relationships" r:id="R55f45c90008a4ebf"/>
               </a:rPr>
               <a:t>WCAG Contrast Minimum</a:t>
             </a:r>
@@ -7302,7 +7267,7 @@
           <p:cNvPr id="6" name="Android touch targets">
             <a:extLst xmlns:a="http://schemas.openxmlformats.org/drawingml/2006/main">
               <a:ext uri="{FF2B5EF4-FFF2-40B4-BE49-F238E27FC236}">
-                <a16:creationId xmlns:a16="http://schemas.microsoft.com/office/drawing/2014/main" id="{3D3476DE-4109-42AA-9A5E-5DBE5806AFEF}"/>
+                <a16:creationId xmlns:a16="http://schemas.microsoft.com/office/drawing/2014/main" id="{F17C2678-3F3F-42C3-A50D-0504B0B69616}"/>
               </a:ext>
             </a:extLst>
           </p:cNvPr>
@@ -7449,7 +7414,7 @@
                 <a:latin typeface="Noto Sans"/>
                 <a:ea typeface="Noto Sans"/>
                 <a:cs typeface="Noto Sans"/>
-                <a:hlinkClick xmlns:r="http://schemas.openxmlformats.org/officeDocument/2006/relationships" r:id="R9c63c8aafe334523"/>
+                <a:hlinkClick xmlns:r="http://schemas.openxmlformats.org/officeDocument/2006/relationships" r:id="R93f93ee03ca14f66"/>
               </a:rPr>
               <a:t>Android touch targets</a:t>
             </a:r>
@@ -7461,7 +7426,7 @@
           <p:cNvPr id="7" name="Audit 360 / 412">
             <a:extLst xmlns:a="http://schemas.openxmlformats.org/drawingml/2006/main">
               <a:ext uri="{FF2B5EF4-FFF2-40B4-BE49-F238E27FC236}">
-                <a16:creationId xmlns:a16="http://schemas.microsoft.com/office/drawing/2014/main" id="{7B373850-33D5-44B7-B8C7-F0D944626020}"/>
+                <a16:creationId xmlns:a16="http://schemas.microsoft.com/office/drawing/2014/main" id="{7828D375-811F-40BB-9F3A-06E50BB619C9}"/>
               </a:ext>
             </a:extLst>
           </p:cNvPr>
@@ -7608,7 +7573,7 @@
                 <a:latin typeface="Noto Sans"/>
                 <a:ea typeface="Noto Sans"/>
                 <a:cs typeface="Noto Sans"/>
-                <a:hlinkClick xmlns:r="http://schemas.openxmlformats.org/officeDocument/2006/relationships" r:id="R2575a3149c574b3b"/>
+                <a:hlinkClick xmlns:r="http://schemas.openxmlformats.org/officeDocument/2006/relationships" r:id="R0b808aa2398f42e3"/>
               </a:rPr>
               <a:t>Audit 360 / 412</a:t>
             </a:r>
@@ -7620,7 +7585,7 @@
           <p:cNvPr id="8" name="">
             <a:extLst xmlns:a="http://schemas.openxmlformats.org/drawingml/2006/main">
               <a:ext uri="{FF2B5EF4-FFF2-40B4-BE49-F238E27FC236}">
-                <a16:creationId xmlns:a16="http://schemas.microsoft.com/office/drawing/2014/main" id="{4EE3B6F6-6822-48BF-A06A-60F8E56BB1DE}"/>
+                <a16:creationId xmlns:a16="http://schemas.microsoft.com/office/drawing/2014/main" id="{424627A7-8602-44CF-84FE-CBC491B85A7B}"/>
               </a:ext>
             </a:extLst>
           </p:cNvPr>
@@ -8060,7 +8025,7 @@
           <p:cNvPr id="9" name="CTA 52 dp; header / Back ≥48 dp&#10;Body 16 sp; label ≥14 sp&#10;Trạ">
             <a:extLst xmlns:a="http://schemas.openxmlformats.org/drawingml/2006/main">
               <a:ext uri="{FF2B5EF4-FFF2-40B4-BE49-F238E27FC236}">
-                <a16:creationId xmlns:a16="http://schemas.microsoft.com/office/drawing/2014/main" id="{BEC43FC9-4373-4FDC-AE6F-864762D18082}"/>
+                <a16:creationId xmlns:a16="http://schemas.microsoft.com/office/drawing/2014/main" id="{6761CBF7-D0BB-4AE7-95AD-1F340CA78B46}"/>
               </a:ext>
             </a:extLst>
           </p:cNvPr>
@@ -8264,7 +8229,7 @@
           <p:cNvPr id="10" name="Chưa kiểm thử TalkBack và người dùng thật.">
             <a:extLst xmlns:a="http://schemas.openxmlformats.org/drawingml/2006/main">
               <a:ext uri="{FF2B5EF4-FFF2-40B4-BE49-F238E27FC236}">
-                <a16:creationId xmlns:a16="http://schemas.microsoft.com/office/drawing/2014/main" id="{9DC4A515-A842-411E-9A83-EDA19F501908}"/>
+                <a16:creationId xmlns:a16="http://schemas.microsoft.com/office/drawing/2014/main" id="{3375AE53-02CB-4B58-B045-70CB5E9577B9}"/>
               </a:ext>
             </a:extLst>
           </p:cNvPr>
@@ -8422,7 +8387,7 @@
           <p:cNvPr id="11" name="">
             <a:extLst xmlns:a="http://schemas.openxmlformats.org/drawingml/2006/main">
               <a:ext uri="{FF2B5EF4-FFF2-40B4-BE49-F238E27FC236}">
-                <a16:creationId xmlns:a16="http://schemas.microsoft.com/office/drawing/2014/main" id="{79F7A825-7CC8-44DE-8EED-B9E271182B20}"/>
+                <a16:creationId xmlns:a16="http://schemas.microsoft.com/office/drawing/2014/main" id="{3F713CB8-D7F2-45F7-BEAD-5247A9432105}"/>
               </a:ext>
             </a:extLst>
           </p:cNvPr>
@@ -8432,7 +8397,7 @@
           <p:nvPr/>
         </p:nvPicPr>
         <p:blipFill>
-          <a:blip xmlns:r="http://schemas.openxmlformats.org/officeDocument/2006/relationships" xmlns:a="http://schemas.openxmlformats.org/drawingml/2006/main" r:embed="R2818ec87e0f34b17"/>
+          <a:blip xmlns:r="http://schemas.openxmlformats.org/officeDocument/2006/relationships" xmlns:a="http://schemas.openxmlformats.org/drawingml/2006/main" r:embed="Re89d030c4f6c438c"/>
           <a:stretch xmlns:a="http://schemas.openxmlformats.org/drawingml/2006/main"/>
         </p:blipFill>
         <p:spPr>
@@ -8450,7 +8415,7 @@
           <p:cNvPr id="12" name="">
             <a:extLst xmlns:a="http://schemas.openxmlformats.org/drawingml/2006/main">
               <a:ext uri="{FF2B5EF4-FFF2-40B4-BE49-F238E27FC236}">
-                <a16:creationId xmlns:a16="http://schemas.microsoft.com/office/drawing/2014/main" id="{BADD5F00-AF81-4E63-8A2E-AF8A348C2BA0}"/>
+                <a16:creationId xmlns:a16="http://schemas.microsoft.com/office/drawing/2014/main" id="{71B8132F-1F3A-4B54-8270-4433B76D8CE0}"/>
               </a:ext>
             </a:extLst>
           </p:cNvPr>
@@ -8460,7 +8425,7 @@
           <p:nvPr/>
         </p:nvPicPr>
         <p:blipFill>
-          <a:blip xmlns:r="http://schemas.openxmlformats.org/officeDocument/2006/relationships" xmlns:a="http://schemas.openxmlformats.org/drawingml/2006/main" r:embed="R91099d1c948a482c"/>
+          <a:blip xmlns:r="http://schemas.openxmlformats.org/officeDocument/2006/relationships" xmlns:a="http://schemas.openxmlformats.org/drawingml/2006/main" r:embed="Reba70f9b3d7441d1"/>
           <a:stretch xmlns:a="http://schemas.openxmlformats.org/drawingml/2006/main"/>
         </p:blipFill>
         <p:spPr>
@@ -8478,7 +8443,7 @@
           <p:cNvPr id="13" name="360 dp">
             <a:extLst xmlns:a="http://schemas.openxmlformats.org/drawingml/2006/main">
               <a:ext uri="{FF2B5EF4-FFF2-40B4-BE49-F238E27FC236}">
-                <a16:creationId xmlns:a16="http://schemas.microsoft.com/office/drawing/2014/main" id="{BBD460DB-67A4-4068-8092-9B1841B9ACFD}"/>
+                <a16:creationId xmlns:a16="http://schemas.microsoft.com/office/drawing/2014/main" id="{E1787682-AEAA-4688-A1C1-F1FFA0549262}"/>
               </a:ext>
             </a:extLst>
           </p:cNvPr>
@@ -8636,7 +8601,7 @@
           <p:cNvPr id="14" name="412 dp (QA)">
             <a:extLst xmlns:a="http://schemas.openxmlformats.org/drawingml/2006/main">
               <a:ext uri="{FF2B5EF4-FFF2-40B4-BE49-F238E27FC236}">
-                <a16:creationId xmlns:a16="http://schemas.microsoft.com/office/drawing/2014/main" id="{29AB5642-2EB2-4A6E-B26E-19A7967F0EDF}"/>
+                <a16:creationId xmlns:a16="http://schemas.microsoft.com/office/drawing/2014/main" id="{92C46599-2927-4460-86C9-D360E948A35D}"/>
               </a:ext>
             </a:extLst>
           </p:cNvPr>
@@ -8792,7 +8757,7 @@
     </p:spTree>
     <p:extLst>
       <p:ext uri="{BB962C8B-B14F-4D97-AF65-F5344CB8AC3E}">
-        <p14:creationId xmlns:p14="http://schemas.microsoft.com/office/powerpoint/2010/main" val="228344605"/>
+        <p14:creationId xmlns:p14="http://schemas.microsoft.com/office/powerpoint/2010/main" val="1458181485"/>
       </p:ext>
     </p:extLst>
   </p:cSld>
@@ -8823,7 +8788,7 @@
           <p:cNvPr id="20" name="Prototype và demo trực tiếp">
             <a:extLst xmlns:a="http://schemas.openxmlformats.org/drawingml/2006/main">
               <a:ext uri="{FF2B5EF4-FFF2-40B4-BE49-F238E27FC236}">
-                <a16:creationId xmlns:a16="http://schemas.microsoft.com/office/drawing/2014/main" id="{FE34E579-8F05-471F-B767-077B6F83E2C1}"/>
+                <a16:creationId xmlns:a16="http://schemas.microsoft.com/office/drawing/2014/main" id="{DCBEB854-2327-4D6F-91A0-426E9000F647}"/>
               </a:ext>
             </a:extLst>
           </p:cNvPr>
@@ -8981,7 +8946,7 @@
           <p:cNvPr id="2" name="3 starting point; 323 phản ứng gồm điều hướng và accordion. ">
             <a:extLst xmlns:a="http://schemas.openxmlformats.org/drawingml/2006/main">
               <a:ext uri="{FF2B5EF4-FFF2-40B4-BE49-F238E27FC236}">
-                <a16:creationId xmlns:a16="http://schemas.microsoft.com/office/drawing/2014/main" id="{0449033A-CB14-4366-8018-95FED1E1360C}"/>
+                <a16:creationId xmlns:a16="http://schemas.microsoft.com/office/drawing/2014/main" id="{3B2A015F-C1C8-463D-99E2-6B8F498743DB}"/>
               </a:ext>
             </a:extLst>
           </p:cNvPr>
@@ -9139,7 +9104,7 @@
           <p:cNvPr id="3" name="11 / 12">
             <a:extLst xmlns:a="http://schemas.openxmlformats.org/drawingml/2006/main">
               <a:ext uri="{FF2B5EF4-FFF2-40B4-BE49-F238E27FC236}">
-                <a16:creationId xmlns:a16="http://schemas.microsoft.com/office/drawing/2014/main" id="{3E912327-EBE4-4F2E-90C8-3FFEA79DDDEE}"/>
+                <a16:creationId xmlns:a16="http://schemas.microsoft.com/office/drawing/2014/main" id="{6E028498-52A9-470E-A1FF-6A72834434ED}"/>
               </a:ext>
             </a:extLst>
           </p:cNvPr>
@@ -9297,7 +9262,7 @@
           <p:cNvPr id="4" name="Nguồn">
             <a:extLst xmlns:a="http://schemas.openxmlformats.org/drawingml/2006/main">
               <a:ext uri="{FF2B5EF4-FFF2-40B4-BE49-F238E27FC236}">
-                <a16:creationId xmlns:a16="http://schemas.microsoft.com/office/drawing/2014/main" id="{2369E604-6152-410D-A53C-4570698C25A0}"/>
+                <a16:creationId xmlns:a16="http://schemas.microsoft.com/office/drawing/2014/main" id="{23071B6C-182C-4233-A30D-EFB2799AE324}"/>
               </a:ext>
             </a:extLst>
           </p:cNvPr>
@@ -9455,7 +9420,7 @@
           <p:cNvPr id="5" name="Figma 06 Prototype">
             <a:extLst xmlns:a="http://schemas.openxmlformats.org/drawingml/2006/main">
               <a:ext uri="{FF2B5EF4-FFF2-40B4-BE49-F238E27FC236}">
-                <a16:creationId xmlns:a16="http://schemas.microsoft.com/office/drawing/2014/main" id="{12F5E613-EEB6-42D0-BCCD-C86877BDA12A}"/>
+                <a16:creationId xmlns:a16="http://schemas.microsoft.com/office/drawing/2014/main" id="{04B3FB9F-B8F0-4C48-BC8D-1F09A7DBE557}"/>
               </a:ext>
             </a:extLst>
           </p:cNvPr>
@@ -9602,7 +9567,7 @@
                 <a:latin typeface="Noto Sans"/>
                 <a:ea typeface="Noto Sans"/>
                 <a:cs typeface="Noto Sans"/>
-                <a:hlinkClick xmlns:r="http://schemas.openxmlformats.org/officeDocument/2006/relationships" r:id="R2d0dce5dbda3453c"/>
+                <a:hlinkClick xmlns:r="http://schemas.openxmlformats.org/officeDocument/2006/relationships" r:id="R0257dc3f2ba04828"/>
               </a:rPr>
               <a:t>Figma 06 Prototype</a:t>
             </a:r>
@@ -9614,7 +9579,7 @@
           <p:cNvPr id="6" name="Kiểm tra dữ liệu flow">
             <a:extLst xmlns:a="http://schemas.openxmlformats.org/drawingml/2006/main">
               <a:ext uri="{FF2B5EF4-FFF2-40B4-BE49-F238E27FC236}">
-                <a16:creationId xmlns:a16="http://schemas.microsoft.com/office/drawing/2014/main" id="{B54F85F3-2B1A-4EF8-9B90-176B22D34575}"/>
+                <a16:creationId xmlns:a16="http://schemas.microsoft.com/office/drawing/2014/main" id="{BF4BE1E9-0099-40AB-9C06-166BE6B4CC73}"/>
               </a:ext>
             </a:extLst>
           </p:cNvPr>
@@ -9761,7 +9726,7 @@
                 <a:latin typeface="Noto Sans"/>
                 <a:ea typeface="Noto Sans"/>
                 <a:cs typeface="Noto Sans"/>
-                <a:hlinkClick xmlns:r="http://schemas.openxmlformats.org/officeDocument/2006/relationships" r:id="R464a5e43de4347bc"/>
+                <a:hlinkClick xmlns:r="http://schemas.openxmlformats.org/officeDocument/2006/relationships" r:id="R6163758d6fbd455d"/>
               </a:rPr>
               <a:t>Kiểm tra dữ liệu flow</a:t>
             </a:r>
@@ -9773,7 +9738,7 @@
           <p:cNvPr id="7" name="Kiểm tra accordion">
             <a:extLst xmlns:a="http://schemas.openxmlformats.org/drawingml/2006/main">
               <a:ext uri="{FF2B5EF4-FFF2-40B4-BE49-F238E27FC236}">
-                <a16:creationId xmlns:a16="http://schemas.microsoft.com/office/drawing/2014/main" id="{EA56280C-6F91-419A-B51D-1322687EC082}"/>
+                <a16:creationId xmlns:a16="http://schemas.microsoft.com/office/drawing/2014/main" id="{E9F5E002-D7B2-4EE8-AAE5-517F52354CE9}"/>
               </a:ext>
             </a:extLst>
           </p:cNvPr>
@@ -9920,7 +9885,7 @@
                 <a:latin typeface="Noto Sans"/>
                 <a:ea typeface="Noto Sans"/>
                 <a:cs typeface="Noto Sans"/>
-                <a:hlinkClick xmlns:r="http://schemas.openxmlformats.org/officeDocument/2006/relationships" r:id="R83478390d8e84e78"/>
+                <a:hlinkClick xmlns:r="http://schemas.openxmlformats.org/officeDocument/2006/relationships" r:id="Re1d9f448fdb04b6e"/>
               </a:rPr>
               <a:t>Kiểm tra accordion</a:t>
             </a:r>
@@ -9932,7 +9897,7 @@
           <p:cNvPr id="8" name="F01  Mai   Mở demo">
             <a:extLst xmlns:a="http://schemas.openxmlformats.org/drawingml/2006/main">
               <a:ext uri="{FF2B5EF4-FFF2-40B4-BE49-F238E27FC236}">
-                <a16:creationId xmlns:a16="http://schemas.microsoft.com/office/drawing/2014/main" id="{1B2D049B-BB69-41C5-AF94-B4F1424E7611}"/>
+                <a16:creationId xmlns:a16="http://schemas.microsoft.com/office/drawing/2014/main" id="{E63785E9-18A8-459D-B4EB-BB52BF5675BD}"/>
               </a:ext>
             </a:extLst>
           </p:cNvPr>
@@ -10079,7 +10044,7 @@
                 <a:latin typeface="Noto Sans"/>
                 <a:ea typeface="Noto Sans"/>
                 <a:cs typeface="Noto Sans"/>
-                <a:hlinkClick xmlns:r="http://schemas.openxmlformats.org/officeDocument/2006/relationships" r:id="Ra6abbafb0a994767"/>
+                <a:hlinkClick xmlns:r="http://schemas.openxmlformats.org/officeDocument/2006/relationships" r:id="R3924efb0345d4707"/>
               </a:rPr>
               <a:t>F01  Mai   Mở demo</a:t>
             </a:r>
@@ -10091,7 +10056,7 @@
           <p:cNvPr id="9" name="Tìm và thêm hoạt động&#10;≤5 phút, lỗi lưu và Thử lại.">
             <a:extLst xmlns:a="http://schemas.openxmlformats.org/drawingml/2006/main">
               <a:ext uri="{FF2B5EF4-FFF2-40B4-BE49-F238E27FC236}">
-                <a16:creationId xmlns:a16="http://schemas.microsoft.com/office/drawing/2014/main" id="{24A0DA54-D000-4713-8E83-F9E5ABCAB309}"/>
+                <a16:creationId xmlns:a16="http://schemas.microsoft.com/office/drawing/2014/main" id="{3D5FCBA0-B519-4056-A55F-8571F99602C3}"/>
               </a:ext>
             </a:extLst>
           </p:cNvPr>
@@ -10272,7 +10237,7 @@
           <p:cNvPr id="10" name="Home 1/4, tiến độ 25%">
             <a:extLst xmlns:a="http://schemas.openxmlformats.org/drawingml/2006/main">
               <a:ext uri="{FF2B5EF4-FFF2-40B4-BE49-F238E27FC236}">
-                <a16:creationId xmlns:a16="http://schemas.microsoft.com/office/drawing/2014/main" id="{DEE9E853-B060-4A57-AAEB-FD29F668449B}"/>
+                <a16:creationId xmlns:a16="http://schemas.microsoft.com/office/drawing/2014/main" id="{BEB6B5BB-0548-4686-9EAE-25115E36428A}"/>
               </a:ext>
             </a:extLst>
           </p:cNvPr>
@@ -10430,7 +10395,7 @@
           <p:cNvPr id="11" name="F02  Huy   Mở demo">
             <a:extLst xmlns:a="http://schemas.openxmlformats.org/drawingml/2006/main">
               <a:ext uri="{FF2B5EF4-FFF2-40B4-BE49-F238E27FC236}">
-                <a16:creationId xmlns:a16="http://schemas.microsoft.com/office/drawing/2014/main" id="{E008F57E-4438-457F-B2F6-A4C04DCB358F}"/>
+                <a16:creationId xmlns:a16="http://schemas.microsoft.com/office/drawing/2014/main" id="{24482F50-FE3D-426D-B075-5055AC10A964}"/>
               </a:ext>
             </a:extLst>
           </p:cNvPr>
@@ -10577,7 +10542,7 @@
                 <a:latin typeface="Noto Sans"/>
                 <a:ea typeface="Noto Sans"/>
                 <a:cs typeface="Noto Sans"/>
-                <a:hlinkClick xmlns:r="http://schemas.openxmlformats.org/officeDocument/2006/relationships" r:id="R53eec51d5fea47f9"/>
+                <a:hlinkClick xmlns:r="http://schemas.openxmlformats.org/officeDocument/2006/relationships" r:id="R4b3d66724dfc49f5"/>
               </a:rPr>
               <a:t>F02  Huy   Mở demo</a:t>
             </a:r>
@@ -10589,7 +10554,7 @@
           <p:cNvPr id="12" name="Nghỉ, tạm dừng, overlay&#10;và ghi nhận kết thúc sớm.">
             <a:extLst xmlns:a="http://schemas.openxmlformats.org/drawingml/2006/main">
               <a:ext uri="{FF2B5EF4-FFF2-40B4-BE49-F238E27FC236}">
-                <a16:creationId xmlns:a16="http://schemas.microsoft.com/office/drawing/2014/main" id="{1C00FD6B-868E-4F73-9D98-1503F4F3F91A}"/>
+                <a16:creationId xmlns:a16="http://schemas.microsoft.com/office/drawing/2014/main" id="{EBC29842-2C32-41AF-BCDF-1958AA41FEBD}"/>
               </a:ext>
             </a:extLst>
           </p:cNvPr>
@@ -10770,7 +10735,7 @@
           <p:cNvPr id="13" name="Tiến độ 2/4, bản ghi 45 giây">
             <a:extLst xmlns:a="http://schemas.openxmlformats.org/drawingml/2006/main">
               <a:ext uri="{FF2B5EF4-FFF2-40B4-BE49-F238E27FC236}">
-                <a16:creationId xmlns:a16="http://schemas.microsoft.com/office/drawing/2014/main" id="{61E8C7D7-9EE5-4A8C-9737-AB18219976FF}"/>
+                <a16:creationId xmlns:a16="http://schemas.microsoft.com/office/drawing/2014/main" id="{E74D678D-9EA4-4658-AE80-B1925085CFA0}"/>
               </a:ext>
             </a:extLst>
           </p:cNvPr>
@@ -10928,7 +10893,7 @@
           <p:cNvPr id="14" name="F03  Linh   Mở demo">
             <a:extLst xmlns:a="http://schemas.openxmlformats.org/drawingml/2006/main">
               <a:ext uri="{FF2B5EF4-FFF2-40B4-BE49-F238E27FC236}">
-                <a16:creationId xmlns:a16="http://schemas.microsoft.com/office/drawing/2014/main" id="{19642741-5C26-40CB-A684-04A8FBF311B5}"/>
+                <a16:creationId xmlns:a16="http://schemas.microsoft.com/office/drawing/2014/main" id="{8A767DA7-744A-45AE-B8DC-C13CDC89D01D}"/>
               </a:ext>
             </a:extLst>
           </p:cNvPr>
@@ -11075,7 +11040,7 @@
                 <a:latin typeface="Noto Sans"/>
                 <a:ea typeface="Noto Sans"/>
                 <a:cs typeface="Noto Sans"/>
-                <a:hlinkClick xmlns:r="http://schemas.openxmlformats.org/officeDocument/2006/relationships" r:id="Rba704bc5e9d04167"/>
+                <a:hlinkClick xmlns:r="http://schemas.openxmlformats.org/officeDocument/2006/relationships" r:id="R97ebedc3439e4930"/>
               </a:rPr>
               <a:t>F03  Linh   Mở demo</a:t>
             </a:r>
@@ -11087,7 +11052,7 @@
           <p:cNvPr id="15" name="Đổi lịch 17:30 sang 18:00.&#10;Lỗi giữ form, Hủy giữ giờ cũ.">
             <a:extLst xmlns:a="http://schemas.openxmlformats.org/drawingml/2006/main">
               <a:ext uri="{FF2B5EF4-FFF2-40B4-BE49-F238E27FC236}">
-                <a16:creationId xmlns:a16="http://schemas.microsoft.com/office/drawing/2014/main" id="{E292406D-FC7B-4B4E-90B6-4335195E3834}"/>
+                <a16:creationId xmlns:a16="http://schemas.microsoft.com/office/drawing/2014/main" id="{6983D1A5-2AEF-4B4E-BC63-2DE4B035CAD3}"/>
               </a:ext>
             </a:extLst>
           </p:cNvPr>
@@ -11268,7 +11233,7 @@
           <p:cNvPr id="16" name="Home có giờ mới, vẫn 1/3">
             <a:extLst xmlns:a="http://schemas.openxmlformats.org/drawingml/2006/main">
               <a:ext uri="{FF2B5EF4-FFF2-40B4-BE49-F238E27FC236}">
-                <a16:creationId xmlns:a16="http://schemas.microsoft.com/office/drawing/2014/main" id="{3CD56B8F-9054-4F05-B8DE-A112692206DF}"/>
+                <a16:creationId xmlns:a16="http://schemas.microsoft.com/office/drawing/2014/main" id="{8A9D96C8-74DA-4963-AAF1-659319542BEF}"/>
               </a:ext>
             </a:extLst>
           </p:cNvPr>
@@ -11426,7 +11391,7 @@
           <p:cNvPr id="17" name="">
             <a:extLst xmlns:a="http://schemas.openxmlformats.org/drawingml/2006/main">
               <a:ext uri="{FF2B5EF4-FFF2-40B4-BE49-F238E27FC236}">
-                <a16:creationId xmlns:a16="http://schemas.microsoft.com/office/drawing/2014/main" id="{9C5C16B3-6BB0-418F-851C-F25170AC2B71}"/>
+                <a16:creationId xmlns:a16="http://schemas.microsoft.com/office/drawing/2014/main" id="{7A8AA402-C388-40D3-B1BB-EFBEF762CE28}"/>
               </a:ext>
             </a:extLst>
           </p:cNvPr>
@@ -11436,7 +11401,7 @@
           <p:nvPr/>
         </p:nvPicPr>
         <p:blipFill>
-          <a:blip xmlns:r="http://schemas.openxmlformats.org/officeDocument/2006/relationships" xmlns:a="http://schemas.openxmlformats.org/drawingml/2006/main" r:embed="R9f348ffe5c774b1d"/>
+          <a:blip xmlns:r="http://schemas.openxmlformats.org/officeDocument/2006/relationships" xmlns:a="http://schemas.openxmlformats.org/drawingml/2006/main" r:embed="R32e6d0ee475c4e1f"/>
           <a:stretch xmlns:a="http://schemas.openxmlformats.org/drawingml/2006/main"/>
         </p:blipFill>
         <p:spPr>
@@ -11454,7 +11419,7 @@
           <p:cNvPr id="18" name="9 nhóm mở/thu gọn được">
             <a:extLst xmlns:a="http://schemas.openxmlformats.org/drawingml/2006/main">
               <a:ext uri="{FF2B5EF4-FFF2-40B4-BE49-F238E27FC236}">
-                <a16:creationId xmlns:a16="http://schemas.microsoft.com/office/drawing/2014/main" id="{69114456-EA76-4E47-BBF9-93780489C7E8}"/>
+                <a16:creationId xmlns:a16="http://schemas.microsoft.com/office/drawing/2014/main" id="{C1EE9B5E-9331-49E1-B82F-0F890BC06EC5}"/>
               </a:ext>
             </a:extLst>
           </p:cNvPr>
@@ -11612,7 +11577,7 @@
           <p:cNvPr id="19" name="Timer mô phỏng các mốc thời gian.">
             <a:extLst xmlns:a="http://schemas.openxmlformats.org/drawingml/2006/main">
               <a:ext uri="{FF2B5EF4-FFF2-40B4-BE49-F238E27FC236}">
-                <a16:creationId xmlns:a16="http://schemas.microsoft.com/office/drawing/2014/main" id="{462B58A1-423B-4359-99B6-2EB0DFD602F0}"/>
+                <a16:creationId xmlns:a16="http://schemas.microsoft.com/office/drawing/2014/main" id="{C9EAF8AB-EB31-4A3F-8D38-59A1F0074A65}"/>
               </a:ext>
             </a:extLst>
           </p:cNvPr>
@@ -11768,7 +11733,7 @@
     </p:spTree>
     <p:extLst>
       <p:ext uri="{BB962C8B-B14F-4D97-AF65-F5344CB8AC3E}">
-        <p14:creationId xmlns:p14="http://schemas.microsoft.com/office/powerpoint/2010/main" val="1190853769"/>
+        <p14:creationId xmlns:p14="http://schemas.microsoft.com/office/powerpoint/2010/main" val="1293324632"/>
       </p:ext>
     </p:extLst>
   </p:cSld>
@@ -11799,7 +11764,7 @@
           <p:cNvPr id="13" name="Flutter handoff và kết luận">
             <a:extLst xmlns:a="http://schemas.openxmlformats.org/drawingml/2006/main">
               <a:ext uri="{FF2B5EF4-FFF2-40B4-BE49-F238E27FC236}">
-                <a16:creationId xmlns:a16="http://schemas.microsoft.com/office/drawing/2014/main" id="{269AE7A8-FA6C-43AE-960B-7A1CD584F332}"/>
+                <a16:creationId xmlns:a16="http://schemas.microsoft.com/office/drawing/2014/main" id="{FB54DA5F-A272-4B6D-A2CC-054526FEDF4F}"/>
               </a:ext>
             </a:extLst>
           </p:cNvPr>
@@ -11957,7 +11922,7 @@
           <p:cNvPr id="2" name="Bàn giao thiết kế, dữ liệu mẫu và quy tắc hành vi. Lab 2 chư">
             <a:extLst xmlns:a="http://schemas.openxmlformats.org/drawingml/2006/main">
               <a:ext uri="{FF2B5EF4-FFF2-40B4-BE49-F238E27FC236}">
-                <a16:creationId xmlns:a16="http://schemas.microsoft.com/office/drawing/2014/main" id="{00AC82AA-A11F-436D-8DB4-414B44A6A27C}"/>
+                <a16:creationId xmlns:a16="http://schemas.microsoft.com/office/drawing/2014/main" id="{7E12560B-1C19-47E1-90D9-3B2682970D39}"/>
               </a:ext>
             </a:extLst>
           </p:cNvPr>
@@ -12115,7 +12080,7 @@
           <p:cNvPr id="3" name="12 / 12">
             <a:extLst xmlns:a="http://schemas.openxmlformats.org/drawingml/2006/main">
               <a:ext uri="{FF2B5EF4-FFF2-40B4-BE49-F238E27FC236}">
-                <a16:creationId xmlns:a16="http://schemas.microsoft.com/office/drawing/2014/main" id="{75594707-F32D-466B-AA3A-44B377B52D18}"/>
+                <a16:creationId xmlns:a16="http://schemas.microsoft.com/office/drawing/2014/main" id="{591D8D4E-E632-4AEF-88A7-62AAFA58BA17}"/>
               </a:ext>
             </a:extLst>
           </p:cNvPr>
@@ -12273,7 +12238,7 @@
           <p:cNvPr id="4" name="Nguồn">
             <a:extLst xmlns:a="http://schemas.openxmlformats.org/drawingml/2006/main">
               <a:ext uri="{FF2B5EF4-FFF2-40B4-BE49-F238E27FC236}">
-                <a16:creationId xmlns:a16="http://schemas.microsoft.com/office/drawing/2014/main" id="{0B5FABB1-A98D-4762-88F7-9170A3645EB8}"/>
+                <a16:creationId xmlns:a16="http://schemas.microsoft.com/office/drawing/2014/main" id="{B2B94CD0-846E-454E-BD74-940AE53045FE}"/>
               </a:ext>
             </a:extLst>
           </p:cNvPr>
@@ -12431,7 +12396,7 @@
           <p:cNvPr id="5" name="Handoff 10 màn, 6 mục/màn">
             <a:extLst xmlns:a="http://schemas.openxmlformats.org/drawingml/2006/main">
               <a:ext uri="{FF2B5EF4-FFF2-40B4-BE49-F238E27FC236}">
-                <a16:creationId xmlns:a16="http://schemas.microsoft.com/office/drawing/2014/main" id="{A1E7369B-C82C-4A16-ADC1-8288811EA0BE}"/>
+                <a16:creationId xmlns:a16="http://schemas.microsoft.com/office/drawing/2014/main" id="{66F641A0-899E-4F22-B4BB-FE77D6B355BB}"/>
               </a:ext>
             </a:extLst>
           </p:cNvPr>
@@ -12578,7 +12543,7 @@
                 <a:latin typeface="Noto Sans"/>
                 <a:ea typeface="Noto Sans"/>
                 <a:cs typeface="Noto Sans"/>
-                <a:hlinkClick xmlns:r="http://schemas.openxmlformats.org/officeDocument/2006/relationships" r:id="R32d7f33de4bd4583"/>
+                <a:hlinkClick xmlns:r="http://schemas.openxmlformats.org/officeDocument/2006/relationships" r:id="R662cbfd4affd4410"/>
               </a:rPr>
               <a:t>Handoff 10 màn, 6 mục/màn</a:t>
             </a:r>
@@ -12590,7 +12555,7 @@
           <p:cNvPr id="6" name="Flutter ThemeData">
             <a:extLst xmlns:a="http://schemas.openxmlformats.org/drawingml/2006/main">
               <a:ext uri="{FF2B5EF4-FFF2-40B4-BE49-F238E27FC236}">
-                <a16:creationId xmlns:a16="http://schemas.microsoft.com/office/drawing/2014/main" id="{1471A8FF-064C-4C81-A0AF-4214DDF7B222}"/>
+                <a16:creationId xmlns:a16="http://schemas.microsoft.com/office/drawing/2014/main" id="{7068B40B-FC66-407F-808F-097C827ECBD9}"/>
               </a:ext>
             </a:extLst>
           </p:cNvPr>
@@ -12737,7 +12702,7 @@
                 <a:latin typeface="Noto Sans"/>
                 <a:ea typeface="Noto Sans"/>
                 <a:cs typeface="Noto Sans"/>
-                <a:hlinkClick xmlns:r="http://schemas.openxmlformats.org/officeDocument/2006/relationships" r:id="R5255c3347edf4401"/>
+                <a:hlinkClick xmlns:r="http://schemas.openxmlformats.org/officeDocument/2006/relationships" r:id="R9821f255b3a34ee0"/>
               </a:rPr>
               <a:t>Flutter ThemeData</a:t>
             </a:r>
@@ -12746,10 +12711,10 @@
       </p:sp>
       <p:sp>
         <p:nvSpPr>
-          <p:cNvPr id="7" name="Repo và Figma">
+          <p:cNvPr id="7" name="GitHub dự án">
             <a:extLst xmlns:a="http://schemas.openxmlformats.org/drawingml/2006/main">
               <a:ext uri="{FF2B5EF4-FFF2-40B4-BE49-F238E27FC236}">
-                <a16:creationId xmlns:a16="http://schemas.microsoft.com/office/drawing/2014/main" id="{52163B45-EB9A-47C3-B46A-E6F493AE6B46}"/>
+                <a16:creationId xmlns:a16="http://schemas.microsoft.com/office/drawing/2014/main" id="{D0EDEA5A-A200-499A-81E6-D1A96B3CCB4D}"/>
               </a:ext>
             </a:extLst>
           </p:cNvPr>
@@ -12896,9 +12861,9 @@
                 <a:latin typeface="Noto Sans"/>
                 <a:ea typeface="Noto Sans"/>
                 <a:cs typeface="Noto Sans"/>
-                <a:hlinkClick xmlns:r="http://schemas.openxmlformats.org/officeDocument/2006/relationships" r:id="Rf77666f24d644462"/>
+                <a:hlinkClick xmlns:r="http://schemas.openxmlformats.org/officeDocument/2006/relationships" r:id="R50e9e0dd18e54f70"/>
               </a:rPr>
-              <a:t>Repo và Figma</a:t>
+              <a:t>GitHub dự án</a:t>
             </a:r>
           </a:p>
         </p:txBody>
@@ -12908,7 +12873,7 @@
           <p:cNvPr id="8" name="6 mục cho mỗi màn">
             <a:extLst xmlns:a="http://schemas.openxmlformats.org/drawingml/2006/main">
               <a:ext uri="{FF2B5EF4-FFF2-40B4-BE49-F238E27FC236}">
-                <a16:creationId xmlns:a16="http://schemas.microsoft.com/office/drawing/2014/main" id="{28739C2E-FFC0-411B-8135-6CFE588D9375}"/>
+                <a16:creationId xmlns:a16="http://schemas.microsoft.com/office/drawing/2014/main" id="{1F257FF3-E9F0-4B51-9036-0D720E4682FE}"/>
               </a:ext>
             </a:extLst>
           </p:cNvPr>
@@ -13066,7 +13031,7 @@
           <p:cNvPr id="9" name="Layout và vùng cuộn&#10;Component và variant&#10;State áp dụng&#10;Tương">
             <a:extLst xmlns:a="http://schemas.openxmlformats.org/drawingml/2006/main">
               <a:ext uri="{FF2B5EF4-FFF2-40B4-BE49-F238E27FC236}">
-                <a16:creationId xmlns:a16="http://schemas.microsoft.com/office/drawing/2014/main" id="{F08A6596-60B6-47C5-94CE-3A0161AB31A0}"/>
+                <a16:creationId xmlns:a16="http://schemas.microsoft.com/office/drawing/2014/main" id="{73A77C58-ABB5-4CE1-9F04-A8E87D7204A4}"/>
               </a:ext>
             </a:extLst>
           </p:cNvPr>
@@ -13339,7 +13304,7 @@
           <p:cNvPr id="10" name="">
             <a:extLst xmlns:a="http://schemas.openxmlformats.org/drawingml/2006/main">
               <a:ext uri="{FF2B5EF4-FFF2-40B4-BE49-F238E27FC236}">
-                <a16:creationId xmlns:a16="http://schemas.microsoft.com/office/drawing/2014/main" id="{76746D32-DFEA-4DAE-A107-230CF29A500A}"/>
+                <a16:creationId xmlns:a16="http://schemas.microsoft.com/office/drawing/2014/main" id="{470D0640-CF5C-4715-BADD-D4F6EF77E0F8}"/>
               </a:ext>
             </a:extLst>
           </p:cNvPr>
@@ -13859,7 +13824,7 @@
           <p:cNvPr id="11" name="Đã có 10 màn, 3 flow và bằng chứng nguồn.">
             <a:extLst xmlns:a="http://schemas.openxmlformats.org/drawingml/2006/main">
               <a:ext uri="{FF2B5EF4-FFF2-40B4-BE49-F238E27FC236}">
-                <a16:creationId xmlns:a16="http://schemas.microsoft.com/office/drawing/2014/main" id="{CEDC6A82-64A4-47ED-A5D6-85434B3AF8A1}"/>
+                <a16:creationId xmlns:a16="http://schemas.microsoft.com/office/drawing/2014/main" id="{559D3C00-1089-41F5-84F1-3FD440FD254E}"/>
               </a:ext>
             </a:extLst>
           </p:cNvPr>
@@ -14014,10 +13979,10 @@
       </p:sp>
       <p:sp>
         <p:nvSpPr>
-          <p:cNvPr id="12" name="Còn xác nhận prompt thực gửi, quyền xem link và kiểm thử với">
+          <p:cNvPr id="12" name="Bước tiếp theo: kiểm tra quyền Figma, tập demo và thử với ng">
             <a:extLst xmlns:a="http://schemas.openxmlformats.org/drawingml/2006/main">
               <a:ext uri="{FF2B5EF4-FFF2-40B4-BE49-F238E27FC236}">
-                <a16:creationId xmlns:a16="http://schemas.microsoft.com/office/drawing/2014/main" id="{0AD0A243-E764-4EEE-AB39-DC0C696CA78B}"/>
+                <a16:creationId xmlns:a16="http://schemas.microsoft.com/office/drawing/2014/main" id="{B968A4FC-AEE5-4B0E-97A0-C2134EF4BCB8}"/>
               </a:ext>
             </a:extLst>
           </p:cNvPr>
@@ -14165,7 +14130,7 @@
                 <a:ea typeface="Noto Sans"/>
                 <a:cs typeface="Noto Sans"/>
               </a:rPr>
-              <a:t>Còn xác nhận prompt thực gửi, quyền xem link và kiểm thử với người dùng.</a:t>
+              <a:t>Bước tiếp theo: kiểm tra quyền Figma, tập demo và thử với người dùng.</a:t>
             </a:r>
           </a:p>
         </p:txBody>
@@ -14173,7 +14138,7 @@
     </p:spTree>
     <p:extLst>
       <p:ext uri="{BB962C8B-B14F-4D97-AF65-F5344CB8AC3E}">
-        <p14:creationId xmlns:p14="http://schemas.microsoft.com/office/powerpoint/2010/main" val="2097066606"/>
+        <p14:creationId xmlns:p14="http://schemas.microsoft.com/office/powerpoint/2010/main" val="2064174528"/>
       </p:ext>
     </p:extLst>
   </p:cSld>
@@ -14204,7 +14169,7 @@
           <p:cNvPr id="22" name="Vấn đề và ba persona">
             <a:extLst xmlns:a="http://schemas.openxmlformats.org/drawingml/2006/main">
               <a:ext uri="{FF2B5EF4-FFF2-40B4-BE49-F238E27FC236}">
-                <a16:creationId xmlns:a16="http://schemas.microsoft.com/office/drawing/2014/main" id="{BB4598F1-2868-4076-A4A2-6DC73CE7CFF8}"/>
+                <a16:creationId xmlns:a16="http://schemas.microsoft.com/office/drawing/2014/main" id="{16C9AAD4-965F-4BA1-B27D-4AC8313D7C66}"/>
               </a:ext>
             </a:extLst>
           </p:cNvPr>
@@ -14362,7 +14327,7 @@
           <p:cNvPr id="2" name="Một ứng dụng chung cho nhân viên văn phòng 23–45 tuổi. Perso">
             <a:extLst xmlns:a="http://schemas.openxmlformats.org/drawingml/2006/main">
               <a:ext uri="{FF2B5EF4-FFF2-40B4-BE49-F238E27FC236}">
-                <a16:creationId xmlns:a16="http://schemas.microsoft.com/office/drawing/2014/main" id="{F8B46348-0879-4F5B-A8EE-CA3E2972A2F8}"/>
+                <a16:creationId xmlns:a16="http://schemas.microsoft.com/office/drawing/2014/main" id="{67ABEA33-9149-42DC-B785-017B11E343D3}"/>
               </a:ext>
             </a:extLst>
           </p:cNvPr>
@@ -14520,7 +14485,7 @@
           <p:cNvPr id="3" name="02 / 12">
             <a:extLst xmlns:a="http://schemas.openxmlformats.org/drawingml/2006/main">
               <a:ext uri="{FF2B5EF4-FFF2-40B4-BE49-F238E27FC236}">
-                <a16:creationId xmlns:a16="http://schemas.microsoft.com/office/drawing/2014/main" id="{2AD9A3DF-1885-4F40-8DFD-A63E17CBB16C}"/>
+                <a16:creationId xmlns:a16="http://schemas.microsoft.com/office/drawing/2014/main" id="{59B1E70F-81A5-46F3-BBC8-841BFEF1FFAC}"/>
               </a:ext>
             </a:extLst>
           </p:cNvPr>
@@ -14678,7 +14643,7 @@
           <p:cNvPr id="4" name="Nguồn">
             <a:extLst xmlns:a="http://schemas.openxmlformats.org/drawingml/2006/main">
               <a:ext uri="{FF2B5EF4-FFF2-40B4-BE49-F238E27FC236}">
-                <a16:creationId xmlns:a16="http://schemas.microsoft.com/office/drawing/2014/main" id="{E2800BB3-DB35-4E1C-B225-598776D343CC}"/>
+                <a16:creationId xmlns:a16="http://schemas.microsoft.com/office/drawing/2014/main" id="{E9CE254A-567B-4A4A-AA38-415FB89E140D}"/>
               </a:ext>
             </a:extLst>
           </p:cNvPr>
@@ -14836,7 +14801,7 @@
           <p:cNvPr id="5" name="Ba persona và nhu cầu">
             <a:extLst xmlns:a="http://schemas.openxmlformats.org/drawingml/2006/main">
               <a:ext uri="{FF2B5EF4-FFF2-40B4-BE49-F238E27FC236}">
-                <a16:creationId xmlns:a16="http://schemas.microsoft.com/office/drawing/2014/main" id="{95394BA1-1AC1-4693-81F4-3E2224CA3A32}"/>
+                <a16:creationId xmlns:a16="http://schemas.microsoft.com/office/drawing/2014/main" id="{7C9CE96E-C92C-4567-8120-4B0D5391B64E}"/>
               </a:ext>
             </a:extLst>
           </p:cNvPr>
@@ -14983,7 +14948,7 @@
                 <a:latin typeface="Noto Sans"/>
                 <a:ea typeface="Noto Sans"/>
                 <a:cs typeface="Noto Sans"/>
-                <a:hlinkClick xmlns:r="http://schemas.openxmlformats.org/officeDocument/2006/relationships" r:id="Rb2b220db4bb04280"/>
+                <a:hlinkClick xmlns:r="http://schemas.openxmlformats.org/officeDocument/2006/relationships" r:id="R5439d1383ac84b94"/>
               </a:rPr>
               <a:t>Ba persona và nhu cầu</a:t>
             </a:r>
@@ -14992,10 +14957,10 @@
       </p:sp>
       <p:sp>
         <p:nvSpPr>
-          <p:cNvPr id="6" name="Phạm vi và tiêu chí Lab 2">
+          <p:cNvPr id="6" name="Phạm vi thiết kế Office">
             <a:extLst xmlns:a="http://schemas.openxmlformats.org/drawingml/2006/main">
               <a:ext uri="{FF2B5EF4-FFF2-40B4-BE49-F238E27FC236}">
-                <a16:creationId xmlns:a16="http://schemas.microsoft.com/office/drawing/2014/main" id="{422FF682-738F-4359-AFFD-1D8F21B8AC53}"/>
+                <a16:creationId xmlns:a16="http://schemas.microsoft.com/office/drawing/2014/main" id="{8101437E-7D84-4A5E-AC12-3CB137B3EC5F}"/>
               </a:ext>
             </a:extLst>
           </p:cNvPr>
@@ -15142,9 +15107,9 @@
                 <a:latin typeface="Noto Sans"/>
                 <a:ea typeface="Noto Sans"/>
                 <a:cs typeface="Noto Sans"/>
-                <a:hlinkClick xmlns:r="http://schemas.openxmlformats.org/officeDocument/2006/relationships" r:id="R317ffdcd5e594b33"/>
+                <a:hlinkClick xmlns:r="http://schemas.openxmlformats.org/officeDocument/2006/relationships" r:id="R7a89af63787c4a06"/>
               </a:rPr>
-              <a:t>Phạm vi và tiêu chí Lab 2</a:t>
+              <a:t>Phạm vi thiết kế Office</a:t>
             </a:r>
           </a:p>
         </p:txBody>
@@ -15154,7 +15119,7 @@
           <p:cNvPr id="7" name="Huy, 28 tuổi">
             <a:extLst xmlns:a="http://schemas.openxmlformats.org/drawingml/2006/main">
               <a:ext uri="{FF2B5EF4-FFF2-40B4-BE49-F238E27FC236}">
-                <a16:creationId xmlns:a16="http://schemas.microsoft.com/office/drawing/2014/main" id="{9674EFC7-0650-48CE-A337-5228EA11CC48}"/>
+                <a16:creationId xmlns:a16="http://schemas.microsoft.com/office/drawing/2014/main" id="{A041E552-6522-4D6F-9F49-2C738E8829C0}"/>
               </a:ext>
             </a:extLst>
           </p:cNvPr>
@@ -15312,7 +15277,7 @@
           <p:cNvPr id="8" name="Lập trình viên">
             <a:extLst xmlns:a="http://schemas.openxmlformats.org/drawingml/2006/main">
               <a:ext uri="{FF2B5EF4-FFF2-40B4-BE49-F238E27FC236}">
-                <a16:creationId xmlns:a16="http://schemas.microsoft.com/office/drawing/2014/main" id="{B67BD1BD-CD74-45A9-B56D-AB71E256ACE9}"/>
+                <a16:creationId xmlns:a16="http://schemas.microsoft.com/office/drawing/2014/main" id="{81C2A205-147F-4FA4-9866-17849D910CC0}"/>
               </a:ext>
             </a:extLst>
           </p:cNvPr>
@@ -15470,7 +15435,7 @@
           <p:cNvPr id="9" name="Ngồi lâu, quên nghỉ khi tập trung.">
             <a:extLst xmlns:a="http://schemas.openxmlformats.org/drawingml/2006/main">
               <a:ext uri="{FF2B5EF4-FFF2-40B4-BE49-F238E27FC236}">
-                <a16:creationId xmlns:a16="http://schemas.microsoft.com/office/drawing/2014/main" id="{99B5CE9E-F15B-4318-846D-FA7A2B536AED}"/>
+                <a16:creationId xmlns:a16="http://schemas.microsoft.com/office/drawing/2014/main" id="{B362413C-F438-479E-8CE9-F742F5BDCF88}"/>
               </a:ext>
             </a:extLst>
           </p:cNvPr>
@@ -15628,7 +15593,7 @@
           <p:cNvPr id="10" name="Vận động, tư thế, góc làm việc.">
             <a:extLst xmlns:a="http://schemas.openxmlformats.org/drawingml/2006/main">
               <a:ext uri="{FF2B5EF4-FFF2-40B4-BE49-F238E27FC236}">
-                <a16:creationId xmlns:a16="http://schemas.microsoft.com/office/drawing/2014/main" id="{87917ABF-5327-4F31-AD74-FDDA34E1F956}"/>
+                <a16:creationId xmlns:a16="http://schemas.microsoft.com/office/drawing/2014/main" id="{26D0BFF3-F47A-4A49-BE83-52A7C812B7AB}"/>
               </a:ext>
             </a:extLst>
           </p:cNvPr>
@@ -15786,7 +15751,7 @@
           <p:cNvPr id="11" name="Check-in ≤3 thao tác; đổi lịch &lt;30 giây.">
             <a:extLst xmlns:a="http://schemas.openxmlformats.org/drawingml/2006/main">
               <a:ext uri="{FF2B5EF4-FFF2-40B4-BE49-F238E27FC236}">
-                <a16:creationId xmlns:a16="http://schemas.microsoft.com/office/drawing/2014/main" id="{655E37F0-EE86-46CC-B69D-73C19BAED7B6}"/>
+                <a16:creationId xmlns:a16="http://schemas.microsoft.com/office/drawing/2014/main" id="{0D433619-3036-48A7-8944-38E54EA927D6}"/>
               </a:ext>
             </a:extLst>
           </p:cNvPr>
@@ -15944,7 +15909,7 @@
           <p:cNvPr id="12" name="Mai, 24 tuổi">
             <a:extLst xmlns:a="http://schemas.openxmlformats.org/drawingml/2006/main">
               <a:ext uri="{FF2B5EF4-FFF2-40B4-BE49-F238E27FC236}">
-                <a16:creationId xmlns:a16="http://schemas.microsoft.com/office/drawing/2014/main" id="{8F7B793C-1398-44DE-AB73-8A8079D5B2CB}"/>
+                <a16:creationId xmlns:a16="http://schemas.microsoft.com/office/drawing/2014/main" id="{135F5BB7-C7AB-4FE3-8987-F9B2AEAA89FA}"/>
               </a:ext>
             </a:extLst>
           </p:cNvPr>
@@ -16102,7 +16067,7 @@
           <p:cNvPr id="13" name="Nhân viên marketing mới">
             <a:extLst xmlns:a="http://schemas.openxmlformats.org/drawingml/2006/main">
               <a:ext uri="{FF2B5EF4-FFF2-40B4-BE49-F238E27FC236}">
-                <a16:creationId xmlns:a16="http://schemas.microsoft.com/office/drawing/2014/main" id="{BD385324-ECD3-433E-B6A8-80932DE94C58}"/>
+                <a16:creationId xmlns:a16="http://schemas.microsoft.com/office/drawing/2014/main" id="{F2ACDA28-EF40-4C0A-A3B0-D6035EC0B75F}"/>
               </a:ext>
             </a:extLst>
           </p:cNvPr>
@@ -16260,7 +16225,7 @@
           <p:cNvPr id="14" name="Ăn vội, căng thẳng, ít quen đồng nghiệp.">
             <a:extLst xmlns:a="http://schemas.openxmlformats.org/drawingml/2006/main">
               <a:ext uri="{FF2B5EF4-FFF2-40B4-BE49-F238E27FC236}">
-                <a16:creationId xmlns:a16="http://schemas.microsoft.com/office/drawing/2014/main" id="{9BCDC05F-AC3C-4B0E-A383-652E2CE79105}"/>
+                <a16:creationId xmlns:a16="http://schemas.microsoft.com/office/drawing/2014/main" id="{831B8BEF-15AD-4788-B85A-91C709678BF7}"/>
               </a:ext>
             </a:extLst>
           </p:cNvPr>
@@ -16418,7 +16383,7 @@
           <p:cNvPr id="15" name="Ăn uống, nghỉ ngắn, kết nối tự nguyện.">
             <a:extLst xmlns:a="http://schemas.openxmlformats.org/drawingml/2006/main">
               <a:ext uri="{FF2B5EF4-FFF2-40B4-BE49-F238E27FC236}">
-                <a16:creationId xmlns:a16="http://schemas.microsoft.com/office/drawing/2014/main" id="{2CEABBDC-4403-448E-882D-E7DF517D7AD8}"/>
+                <a16:creationId xmlns:a16="http://schemas.microsoft.com/office/drawing/2014/main" id="{55FECF90-5E17-4609-B9AB-CD11B1764F71}"/>
               </a:ext>
             </a:extLst>
           </p:cNvPr>
@@ -16576,7 +16541,7 @@
           <p:cNvPr id="16" name="Tìm và thêm hoạt động &lt;60 giây.">
             <a:extLst xmlns:a="http://schemas.openxmlformats.org/drawingml/2006/main">
               <a:ext uri="{FF2B5EF4-FFF2-40B4-BE49-F238E27FC236}">
-                <a16:creationId xmlns:a16="http://schemas.microsoft.com/office/drawing/2014/main" id="{F8132065-6047-4B11-8993-79328934FFB3}"/>
+                <a16:creationId xmlns:a16="http://schemas.microsoft.com/office/drawing/2014/main" id="{AB3CDFB5-B6E2-4994-A367-4A7492180B59}"/>
               </a:ext>
             </a:extLst>
           </p:cNvPr>
@@ -16734,7 +16699,7 @@
           <p:cNvPr id="17" name="Linh, 39 tuổi">
             <a:extLst xmlns:a="http://schemas.openxmlformats.org/drawingml/2006/main">
               <a:ext uri="{FF2B5EF4-FFF2-40B4-BE49-F238E27FC236}">
-                <a16:creationId xmlns:a16="http://schemas.microsoft.com/office/drawing/2014/main" id="{414174A9-803C-4810-B403-1C469E64BBCF}"/>
+                <a16:creationId xmlns:a16="http://schemas.microsoft.com/office/drawing/2014/main" id="{B09613A8-F1D2-409D-85FC-67639A3DEEDF}"/>
               </a:ext>
             </a:extLst>
           </p:cNvPr>
@@ -16892,7 +16857,7 @@
           <p:cNvPr id="18" name="Trưởng nhóm hành chính">
             <a:extLst xmlns:a="http://schemas.openxmlformats.org/drawingml/2006/main">
               <a:ext uri="{FF2B5EF4-FFF2-40B4-BE49-F238E27FC236}">
-                <a16:creationId xmlns:a16="http://schemas.microsoft.com/office/drawing/2014/main" id="{69C86BDB-4931-4A08-A520-8F72CCACF68C}"/>
+                <a16:creationId xmlns:a16="http://schemas.microsoft.com/office/drawing/2014/main" id="{EF98ABC9-81E6-4D2B-9041-968CF0345AA2}"/>
               </a:ext>
             </a:extLst>
           </p:cNvPr>
@@ -17050,7 +17015,7 @@
           <p:cNvPr id="19" name="Lịch họp thay đổi, công việc kéo dài ngoài giờ.">
             <a:extLst xmlns:a="http://schemas.openxmlformats.org/drawingml/2006/main">
               <a:ext uri="{FF2B5EF4-FFF2-40B4-BE49-F238E27FC236}">
-                <a16:creationId xmlns:a16="http://schemas.microsoft.com/office/drawing/2014/main" id="{657C7682-9AF8-454F-B11D-1798FC026F7C}"/>
+                <a16:creationId xmlns:a16="http://schemas.microsoft.com/office/drawing/2014/main" id="{B1ABE73D-A580-48AB-8DC8-36BC1FC64B97}"/>
               </a:ext>
             </a:extLst>
           </p:cNvPr>
@@ -17208,7 +17173,7 @@
           <p:cNvPr id="20" name="Phục hồi, mục tiêu ngày, giờ yên lặng.">
             <a:extLst xmlns:a="http://schemas.openxmlformats.org/drawingml/2006/main">
               <a:ext uri="{FF2B5EF4-FFF2-40B4-BE49-F238E27FC236}">
-                <a16:creationId xmlns:a16="http://schemas.microsoft.com/office/drawing/2014/main" id="{48D614A4-91AD-44EE-AF2A-76CAC1A27A6B}"/>
+                <a16:creationId xmlns:a16="http://schemas.microsoft.com/office/drawing/2014/main" id="{7BDB24AE-5B4A-4CC5-B6C2-58EB44C9696C}"/>
               </a:ext>
             </a:extLst>
           </p:cNvPr>
@@ -17366,7 +17331,7 @@
           <p:cNvPr id="21" name="Đặt lịch và giờ yên lặng &lt;60 giây.">
             <a:extLst xmlns:a="http://schemas.openxmlformats.org/drawingml/2006/main">
               <a:ext uri="{FF2B5EF4-FFF2-40B4-BE49-F238E27FC236}">
-                <a16:creationId xmlns:a16="http://schemas.microsoft.com/office/drawing/2014/main" id="{D275456B-37EB-4334-B51D-BDDE35E8827F}"/>
+                <a16:creationId xmlns:a16="http://schemas.microsoft.com/office/drawing/2014/main" id="{A0AFBFE8-3D1B-45CB-A042-90DE0CAFF9DF}"/>
               </a:ext>
             </a:extLst>
           </p:cNvPr>
@@ -17522,7 +17487,7 @@
     </p:spTree>
     <p:extLst>
       <p:ext uri="{BB962C8B-B14F-4D97-AF65-F5344CB8AC3E}">
-        <p14:creationId xmlns:p14="http://schemas.microsoft.com/office/powerpoint/2010/main" val="646339010"/>
+        <p14:creationId xmlns:p14="http://schemas.microsoft.com/office/powerpoint/2010/main" val="619667572"/>
       </p:ext>
     </p:extLst>
   </p:cSld>
@@ -17553,7 +17518,7 @@
           <p:cNvPr id="17" name="">
             <a:extLst xmlns:a="http://schemas.openxmlformats.org/drawingml/2006/main">
               <a:ext uri="{FF2B5EF4-FFF2-40B4-BE49-F238E27FC236}">
-                <a16:creationId xmlns:a16="http://schemas.microsoft.com/office/drawing/2014/main" id="{407DF1E3-E498-400C-9945-D92BD0D01C3B}"/>
+                <a16:creationId xmlns:a16="http://schemas.microsoft.com/office/drawing/2014/main" id="{EB7DCE6C-87AA-4039-AF89-C70B9C4F4870}"/>
               </a:ext>
             </a:extLst>
           </p:cNvPr>
@@ -17584,7 +17549,7 @@
           <p:cNvPr id="16" name="">
             <a:extLst xmlns:a="http://schemas.openxmlformats.org/drawingml/2006/main">
               <a:ext uri="{FF2B5EF4-FFF2-40B4-BE49-F238E27FC236}">
-                <a16:creationId xmlns:a16="http://schemas.microsoft.com/office/drawing/2014/main" id="{5DDBA7F1-1A0B-4F11-9B7D-6BEBFD63271A}"/>
+                <a16:creationId xmlns:a16="http://schemas.microsoft.com/office/drawing/2014/main" id="{16569C1A-29FA-4EBC-BE47-5E23182C0E62}"/>
               </a:ext>
             </a:extLst>
           </p:cNvPr>
@@ -17615,7 +17580,7 @@
           <p:cNvPr id="24" name="Kiến trúc thông tin">
             <a:extLst xmlns:a="http://schemas.openxmlformats.org/drawingml/2006/main">
               <a:ext uri="{FF2B5EF4-FFF2-40B4-BE49-F238E27FC236}">
-                <a16:creationId xmlns:a16="http://schemas.microsoft.com/office/drawing/2014/main" id="{FF8F5931-F161-4EB6-9DFC-D29B283C88EB}"/>
+                <a16:creationId xmlns:a16="http://schemas.microsoft.com/office/drawing/2014/main" id="{3E1F11F0-F31F-44B6-887F-C9987C424C2A}"/>
               </a:ext>
             </a:extLst>
           </p:cNvPr>
@@ -17773,7 +17738,7 @@
           <p:cNvPr id="2" name="4 tab cấp cao, 6 màn cấp con. Dialog và state không tính thê">
             <a:extLst xmlns:a="http://schemas.openxmlformats.org/drawingml/2006/main">
               <a:ext uri="{FF2B5EF4-FFF2-40B4-BE49-F238E27FC236}">
-                <a16:creationId xmlns:a16="http://schemas.microsoft.com/office/drawing/2014/main" id="{02B4AD26-D9B5-4132-8F51-EC32D04DFC3C}"/>
+                <a16:creationId xmlns:a16="http://schemas.microsoft.com/office/drawing/2014/main" id="{DB8ED523-04AF-4BB7-A1F8-31523AA6E46D}"/>
               </a:ext>
             </a:extLst>
           </p:cNvPr>
@@ -17931,7 +17896,7 @@
           <p:cNvPr id="3" name="03 / 12">
             <a:extLst xmlns:a="http://schemas.openxmlformats.org/drawingml/2006/main">
               <a:ext uri="{FF2B5EF4-FFF2-40B4-BE49-F238E27FC236}">
-                <a16:creationId xmlns:a16="http://schemas.microsoft.com/office/drawing/2014/main" id="{20AACFC2-73DB-4306-A28A-D9788F2E04C1}"/>
+                <a16:creationId xmlns:a16="http://schemas.microsoft.com/office/drawing/2014/main" id="{6E6D1935-D030-4255-8F12-A33D1E3A5ED9}"/>
               </a:ext>
             </a:extLst>
           </p:cNvPr>
@@ -18089,7 +18054,7 @@
           <p:cNvPr id="4" name="Nguồn">
             <a:extLst xmlns:a="http://schemas.openxmlformats.org/drawingml/2006/main">
               <a:ext uri="{FF2B5EF4-FFF2-40B4-BE49-F238E27FC236}">
-                <a16:creationId xmlns:a16="http://schemas.microsoft.com/office/drawing/2014/main" id="{39AEF0FE-10BF-487C-A678-496B1174F303}"/>
+                <a16:creationId xmlns:a16="http://schemas.microsoft.com/office/drawing/2014/main" id="{FE2B028A-28DB-4ECC-985F-CCCFEAC3DFF9}"/>
               </a:ext>
             </a:extLst>
           </p:cNvPr>
@@ -18247,7 +18212,7 @@
           <p:cNvPr id="5" name="IA và mapping flow">
             <a:extLst xmlns:a="http://schemas.openxmlformats.org/drawingml/2006/main">
               <a:ext uri="{FF2B5EF4-FFF2-40B4-BE49-F238E27FC236}">
-                <a16:creationId xmlns:a16="http://schemas.microsoft.com/office/drawing/2014/main" id="{E44F3C1A-7D12-4832-AC57-0A68AC85E8B7}"/>
+                <a16:creationId xmlns:a16="http://schemas.microsoft.com/office/drawing/2014/main" id="{8E0D0274-EAE9-43CF-A0AF-CF88863315E4}"/>
               </a:ext>
             </a:extLst>
           </p:cNvPr>
@@ -18394,7 +18359,7 @@
                 <a:latin typeface="Noto Sans"/>
                 <a:ea typeface="Noto Sans"/>
                 <a:cs typeface="Noto Sans"/>
-                <a:hlinkClick xmlns:r="http://schemas.openxmlformats.org/officeDocument/2006/relationships" r:id="R96920fb4cbb64e45"/>
+                <a:hlinkClick xmlns:r="http://schemas.openxmlformats.org/officeDocument/2006/relationships" r:id="R5843e5f5236a4cfd"/>
               </a:rPr>
               <a:t>IA và mapping flow</a:t>
             </a:r>
@@ -18406,7 +18371,7 @@
           <p:cNvPr id="6" name="Figma 01 User Flow">
             <a:extLst xmlns:a="http://schemas.openxmlformats.org/drawingml/2006/main">
               <a:ext uri="{FF2B5EF4-FFF2-40B4-BE49-F238E27FC236}">
-                <a16:creationId xmlns:a16="http://schemas.microsoft.com/office/drawing/2014/main" id="{01407E72-3090-4B98-821D-E0E2E7FC9D4F}"/>
+                <a16:creationId xmlns:a16="http://schemas.microsoft.com/office/drawing/2014/main" id="{35CBD38D-4C73-4A6D-82DC-42B69D695410}"/>
               </a:ext>
             </a:extLst>
           </p:cNvPr>
@@ -18553,7 +18518,7 @@
                 <a:latin typeface="Noto Sans"/>
                 <a:ea typeface="Noto Sans"/>
                 <a:cs typeface="Noto Sans"/>
-                <a:hlinkClick xmlns:r="http://schemas.openxmlformats.org/officeDocument/2006/relationships" r:id="Ra5d0d29888a4407c"/>
+                <a:hlinkClick xmlns:r="http://schemas.openxmlformats.org/officeDocument/2006/relationships" r:id="R79350a6366ec4a46"/>
               </a:rPr>
               <a:t>Figma 01 User Flow</a:t>
             </a:r>
@@ -18565,7 +18530,7 @@
           <p:cNvPr id="7" name="S01  Hôm nay">
             <a:extLst xmlns:a="http://schemas.openxmlformats.org/drawingml/2006/main">
               <a:ext uri="{FF2B5EF4-FFF2-40B4-BE49-F238E27FC236}">
-                <a16:creationId xmlns:a16="http://schemas.microsoft.com/office/drawing/2014/main" id="{33FD97F7-5F20-4706-B55D-FF28DAEFE2DF}"/>
+                <a16:creationId xmlns:a16="http://schemas.microsoft.com/office/drawing/2014/main" id="{739D9A4A-4B32-49CB-B670-11CB44A8FF84}"/>
               </a:ext>
             </a:extLst>
           </p:cNvPr>
@@ -18727,7 +18692,7 @@
           <p:cNvPr id="8" name="S02  Ăn uống">
             <a:extLst xmlns:a="http://schemas.openxmlformats.org/drawingml/2006/main">
               <a:ext uri="{FF2B5EF4-FFF2-40B4-BE49-F238E27FC236}">
-                <a16:creationId xmlns:a16="http://schemas.microsoft.com/office/drawing/2014/main" id="{0B168046-F9B5-4F40-9933-7C0832E9C8C2}"/>
+                <a16:creationId xmlns:a16="http://schemas.microsoft.com/office/drawing/2014/main" id="{F287E099-15FF-4995-AA3D-DDF869CC1EB1}"/>
               </a:ext>
             </a:extLst>
           </p:cNvPr>
@@ -18889,7 +18854,7 @@
           <p:cNvPr id="9" name="S03  Thư giãn">
             <a:extLst xmlns:a="http://schemas.openxmlformats.org/drawingml/2006/main">
               <a:ext uri="{FF2B5EF4-FFF2-40B4-BE49-F238E27FC236}">
-                <a16:creationId xmlns:a16="http://schemas.microsoft.com/office/drawing/2014/main" id="{14BB26B7-E6AE-4B37-A37E-D42E3D11EFB5}"/>
+                <a16:creationId xmlns:a16="http://schemas.microsoft.com/office/drawing/2014/main" id="{0CAD9079-24F5-4808-A178-67A81C00D711}"/>
               </a:ext>
             </a:extLst>
           </p:cNvPr>
@@ -19051,7 +19016,7 @@
           <p:cNvPr id="10" name="S04  Kết nối">
             <a:extLst xmlns:a="http://schemas.openxmlformats.org/drawingml/2006/main">
               <a:ext uri="{FF2B5EF4-FFF2-40B4-BE49-F238E27FC236}">
-                <a16:creationId xmlns:a16="http://schemas.microsoft.com/office/drawing/2014/main" id="{983BF15F-EA3F-4510-89BE-A5937EC4E375}"/>
+                <a16:creationId xmlns:a16="http://schemas.microsoft.com/office/drawing/2014/main" id="{790854AF-BD7E-4E43-BA20-CC9D06898C6D}"/>
               </a:ext>
             </a:extLst>
           </p:cNvPr>
@@ -19213,7 +19178,7 @@
           <p:cNvPr id="11" name="Từ Hôm nay">
             <a:extLst xmlns:a="http://schemas.openxmlformats.org/drawingml/2006/main">
               <a:ext uri="{FF2B5EF4-FFF2-40B4-BE49-F238E27FC236}">
-                <a16:creationId xmlns:a16="http://schemas.microsoft.com/office/drawing/2014/main" id="{98F07D7D-4A55-4F63-B39F-4E9A1784E07F}"/>
+                <a16:creationId xmlns:a16="http://schemas.microsoft.com/office/drawing/2014/main" id="{B87E453B-4AA1-4FAF-9C6A-E8F105694588}"/>
               </a:ext>
             </a:extLst>
           </p:cNvPr>
@@ -19371,7 +19336,7 @@
           <p:cNvPr id="12" name="S05  Khám phá">
             <a:extLst xmlns:a="http://schemas.openxmlformats.org/drawingml/2006/main">
               <a:ext uri="{FF2B5EF4-FFF2-40B4-BE49-F238E27FC236}">
-                <a16:creationId xmlns:a16="http://schemas.microsoft.com/office/drawing/2014/main" id="{27FD7B51-BC63-4BA8-91B0-A068D490F56A}"/>
+                <a16:creationId xmlns:a16="http://schemas.microsoft.com/office/drawing/2014/main" id="{0562CB10-5765-4571-B6C2-3FB83BDA47DE}"/>
               </a:ext>
             </a:extLst>
           </p:cNvPr>
@@ -19533,7 +19498,7 @@
           <p:cNvPr id="13" name="S08  Tiến độ">
             <a:extLst xmlns:a="http://schemas.openxmlformats.org/drawingml/2006/main">
               <a:ext uri="{FF2B5EF4-FFF2-40B4-BE49-F238E27FC236}">
-                <a16:creationId xmlns:a16="http://schemas.microsoft.com/office/drawing/2014/main" id="{8B309892-E57D-43F5-B1C5-1C06F5B438AB}"/>
+                <a16:creationId xmlns:a16="http://schemas.microsoft.com/office/drawing/2014/main" id="{FC3E2594-386D-44B3-8C5A-265BDE794265}"/>
               </a:ext>
             </a:extLst>
           </p:cNvPr>
@@ -19695,7 +19660,7 @@
           <p:cNvPr id="14" name="S06  Chi tiết">
             <a:extLst xmlns:a="http://schemas.openxmlformats.org/drawingml/2006/main">
               <a:ext uri="{FF2B5EF4-FFF2-40B4-BE49-F238E27FC236}">
-                <a16:creationId xmlns:a16="http://schemas.microsoft.com/office/drawing/2014/main" id="{8831BA44-289F-4BB7-B6DE-5DD82FFCBA76}"/>
+                <a16:creationId xmlns:a16="http://schemas.microsoft.com/office/drawing/2014/main" id="{098782FC-B620-4349-8B75-0CFE9BB208C4}"/>
               </a:ext>
             </a:extLst>
           </p:cNvPr>
@@ -19857,7 +19822,7 @@
           <p:cNvPr id="15" name="S07  Lịch">
             <a:extLst xmlns:a="http://schemas.openxmlformats.org/drawingml/2006/main">
               <a:ext uri="{FF2B5EF4-FFF2-40B4-BE49-F238E27FC236}">
-                <a16:creationId xmlns:a16="http://schemas.microsoft.com/office/drawing/2014/main" id="{E9055958-5544-476F-BD19-2C6C8BBB0BC7}"/>
+                <a16:creationId xmlns:a16="http://schemas.microsoft.com/office/drawing/2014/main" id="{FA69B76B-EC8B-4D80-8D49-CA807E4221F7}"/>
               </a:ext>
             </a:extLst>
           </p:cNvPr>
@@ -20019,7 +19984,7 @@
           <p:cNvPr id="18" name="Các nhóm nội dung trong Khám phá">
             <a:extLst xmlns:a="http://schemas.openxmlformats.org/drawingml/2006/main">
               <a:ext uri="{FF2B5EF4-FFF2-40B4-BE49-F238E27FC236}">
-                <a16:creationId xmlns:a16="http://schemas.microsoft.com/office/drawing/2014/main" id="{9E21F461-6093-431F-BFB1-02E37B23B1A8}"/>
+                <a16:creationId xmlns:a16="http://schemas.microsoft.com/office/drawing/2014/main" id="{DD495EDF-B540-41D4-99C6-E253ABD1E83D}"/>
               </a:ext>
             </a:extLst>
           </p:cNvPr>
@@ -20177,7 +20142,7 @@
           <p:cNvPr id="19" name="S09  Góc làm việc">
             <a:extLst xmlns:a="http://schemas.openxmlformats.org/drawingml/2006/main">
               <a:ext uri="{FF2B5EF4-FFF2-40B4-BE49-F238E27FC236}">
-                <a16:creationId xmlns:a16="http://schemas.microsoft.com/office/drawing/2014/main" id="{EF389472-D630-47CC-97AD-34E9BF6C082B}"/>
+                <a16:creationId xmlns:a16="http://schemas.microsoft.com/office/drawing/2014/main" id="{A6B051EC-CC2C-4395-873E-2FE22A52589B}"/>
               </a:ext>
             </a:extLst>
           </p:cNvPr>
@@ -20339,7 +20304,7 @@
           <p:cNvPr id="20" name="S10  Ngủ &amp; phục hồi">
             <a:extLst xmlns:a="http://schemas.openxmlformats.org/drawingml/2006/main">
               <a:ext uri="{FF2B5EF4-FFF2-40B4-BE49-F238E27FC236}">
-                <a16:creationId xmlns:a16="http://schemas.microsoft.com/office/drawing/2014/main" id="{E7BC4C06-B85B-4136-BD75-D3D665D2ED21}"/>
+                <a16:creationId xmlns:a16="http://schemas.microsoft.com/office/drawing/2014/main" id="{B40B05D5-D92A-4F24-BCC1-17A8051AC94F}"/>
               </a:ext>
             </a:extLst>
           </p:cNvPr>
@@ -20501,7 +20466,7 @@
           <p:cNvPr id="21" name="Tư thế và không gian làm việc">
             <a:extLst xmlns:a="http://schemas.openxmlformats.org/drawingml/2006/main">
               <a:ext uri="{FF2B5EF4-FFF2-40B4-BE49-F238E27FC236}">
-                <a16:creationId xmlns:a16="http://schemas.microsoft.com/office/drawing/2014/main" id="{66257498-FAC0-4188-980B-5E3E540CF02A}"/>
+                <a16:creationId xmlns:a16="http://schemas.microsoft.com/office/drawing/2014/main" id="{B7CD0ED1-7EEB-4311-894A-066638CEAC0D}"/>
               </a:ext>
             </a:extLst>
           </p:cNvPr>
@@ -20659,7 +20624,7 @@
           <p:cNvPr id="22" name="Có thể mở form giờ nhắc">
             <a:extLst xmlns:a="http://schemas.openxmlformats.org/drawingml/2006/main">
               <a:ext uri="{FF2B5EF4-FFF2-40B4-BE49-F238E27FC236}">
-                <a16:creationId xmlns:a16="http://schemas.microsoft.com/office/drawing/2014/main" id="{306C786F-5619-4C0A-B90D-64B8A03E023F}"/>
+                <a16:creationId xmlns:a16="http://schemas.microsoft.com/office/drawing/2014/main" id="{E0032D63-320F-4C95-A980-B15E8BF0EA07}"/>
               </a:ext>
             </a:extLst>
           </p:cNvPr>
@@ -20817,7 +20782,7 @@
           <p:cNvPr id="23" name="S05 chứa 9 nhóm; mỗi nhóm mở/thu gọn và có thẻ hoạt động.">
             <a:extLst xmlns:a="http://schemas.openxmlformats.org/drawingml/2006/main">
               <a:ext uri="{FF2B5EF4-FFF2-40B4-BE49-F238E27FC236}">
-                <a16:creationId xmlns:a16="http://schemas.microsoft.com/office/drawing/2014/main" id="{EBDB9B25-E3B9-483A-BCD5-7307D082445C}"/>
+                <a16:creationId xmlns:a16="http://schemas.microsoft.com/office/drawing/2014/main" id="{B2559013-5BDC-4202-8891-F2DC3AFAA6FF}"/>
               </a:ext>
             </a:extLst>
           </p:cNvPr>
@@ -20973,7 +20938,7 @@
     </p:spTree>
     <p:extLst>
       <p:ext uri="{BB962C8B-B14F-4D97-AF65-F5344CB8AC3E}">
-        <p14:creationId xmlns:p14="http://schemas.microsoft.com/office/powerpoint/2010/main" val="477817617"/>
+        <p14:creationId xmlns:p14="http://schemas.microsoft.com/office/powerpoint/2010/main" val="1136249381"/>
       </p:ext>
     </p:extLst>
   </p:cSld>
@@ -21004,7 +20969,7 @@
           <p:cNvPr id="44" name="">
             <a:extLst xmlns:a="http://schemas.openxmlformats.org/drawingml/2006/main">
               <a:ext uri="{FF2B5EF4-FFF2-40B4-BE49-F238E27FC236}">
-                <a16:creationId xmlns:a16="http://schemas.microsoft.com/office/drawing/2014/main" id="{E5AE9903-8CE8-49DD-B887-C3EE3BE36993}"/>
+                <a16:creationId xmlns:a16="http://schemas.microsoft.com/office/drawing/2014/main" id="{040E9D7F-776E-46E0-AB90-491CF99C3C33}"/>
               </a:ext>
             </a:extLst>
           </p:cNvPr>
@@ -21035,7 +21000,7 @@
           <p:cNvPr id="43" name="">
             <a:extLst xmlns:a="http://schemas.openxmlformats.org/drawingml/2006/main">
               <a:ext uri="{FF2B5EF4-FFF2-40B4-BE49-F238E27FC236}">
-                <a16:creationId xmlns:a16="http://schemas.microsoft.com/office/drawing/2014/main" id="{0D580B87-FB06-4D34-9FF7-C1F290CA0C7A}"/>
+                <a16:creationId xmlns:a16="http://schemas.microsoft.com/office/drawing/2014/main" id="{9D03C330-AA6D-46F2-B0F4-59ED67E0087F}"/>
               </a:ext>
             </a:extLst>
           </p:cNvPr>
@@ -21066,7 +21031,7 @@
           <p:cNvPr id="42" name="">
             <a:extLst xmlns:a="http://schemas.openxmlformats.org/drawingml/2006/main">
               <a:ext uri="{FF2B5EF4-FFF2-40B4-BE49-F238E27FC236}">
-                <a16:creationId xmlns:a16="http://schemas.microsoft.com/office/drawing/2014/main" id="{6E72BEC7-FA30-4DC5-B874-E741A5D8C92B}"/>
+                <a16:creationId xmlns:a16="http://schemas.microsoft.com/office/drawing/2014/main" id="{12BB5AC9-3B7D-42C6-9176-BD281002A0BE}"/>
               </a:ext>
             </a:extLst>
           </p:cNvPr>
@@ -21097,7 +21062,7 @@
           <p:cNvPr id="41" name="">
             <a:extLst xmlns:a="http://schemas.openxmlformats.org/drawingml/2006/main">
               <a:ext uri="{FF2B5EF4-FFF2-40B4-BE49-F238E27FC236}">
-                <a16:creationId xmlns:a16="http://schemas.microsoft.com/office/drawing/2014/main" id="{7140E152-31A7-4585-BB90-797403A253C4}"/>
+                <a16:creationId xmlns:a16="http://schemas.microsoft.com/office/drawing/2014/main" id="{F291DA5E-2EF9-4F58-8BD2-0AC5CD24A90C}"/>
               </a:ext>
             </a:extLst>
           </p:cNvPr>
@@ -21128,7 +21093,7 @@
           <p:cNvPr id="40" name="">
             <a:extLst xmlns:a="http://schemas.openxmlformats.org/drawingml/2006/main">
               <a:ext uri="{FF2B5EF4-FFF2-40B4-BE49-F238E27FC236}">
-                <a16:creationId xmlns:a16="http://schemas.microsoft.com/office/drawing/2014/main" id="{00D396B4-3E81-452B-9A4A-6AB197F96F07}"/>
+                <a16:creationId xmlns:a16="http://schemas.microsoft.com/office/drawing/2014/main" id="{B711DE2F-EAC8-4CBC-8C84-A11590A6647A}"/>
               </a:ext>
             </a:extLst>
           </p:cNvPr>
@@ -21159,7 +21124,7 @@
           <p:cNvPr id="31" name="">
             <a:extLst xmlns:a="http://schemas.openxmlformats.org/drawingml/2006/main">
               <a:ext uri="{FF2B5EF4-FFF2-40B4-BE49-F238E27FC236}">
-                <a16:creationId xmlns:a16="http://schemas.microsoft.com/office/drawing/2014/main" id="{164863B0-8F12-4F90-B47D-FBF7ACAFD5BB}"/>
+                <a16:creationId xmlns:a16="http://schemas.microsoft.com/office/drawing/2014/main" id="{482C7C02-DF27-4471-8989-39ACE0BD7751}"/>
               </a:ext>
             </a:extLst>
           </p:cNvPr>
@@ -21190,7 +21155,7 @@
           <p:cNvPr id="30" name="">
             <a:extLst xmlns:a="http://schemas.openxmlformats.org/drawingml/2006/main">
               <a:ext uri="{FF2B5EF4-FFF2-40B4-BE49-F238E27FC236}">
-                <a16:creationId xmlns:a16="http://schemas.microsoft.com/office/drawing/2014/main" id="{37D87EEC-A884-422F-AE74-0ACDDD6CCC56}"/>
+                <a16:creationId xmlns:a16="http://schemas.microsoft.com/office/drawing/2014/main" id="{C69A015E-E0FD-4241-94C3-F657BCA77AD0}"/>
               </a:ext>
             </a:extLst>
           </p:cNvPr>
@@ -21221,7 +21186,7 @@
           <p:cNvPr id="29" name="">
             <a:extLst xmlns:a="http://schemas.openxmlformats.org/drawingml/2006/main">
               <a:ext uri="{FF2B5EF4-FFF2-40B4-BE49-F238E27FC236}">
-                <a16:creationId xmlns:a16="http://schemas.microsoft.com/office/drawing/2014/main" id="{728C9751-3AAF-46AD-A549-CCFF5781FB44}"/>
+                <a16:creationId xmlns:a16="http://schemas.microsoft.com/office/drawing/2014/main" id="{F8205AEE-4023-465D-86B0-3BC38D907D0F}"/>
               </a:ext>
             </a:extLst>
           </p:cNvPr>
@@ -21252,7 +21217,7 @@
           <p:cNvPr id="28" name="">
             <a:extLst xmlns:a="http://schemas.openxmlformats.org/drawingml/2006/main">
               <a:ext uri="{FF2B5EF4-FFF2-40B4-BE49-F238E27FC236}">
-                <a16:creationId xmlns:a16="http://schemas.microsoft.com/office/drawing/2014/main" id="{210EBDE5-7721-42D5-BDB5-14C0676DFB8C}"/>
+                <a16:creationId xmlns:a16="http://schemas.microsoft.com/office/drawing/2014/main" id="{94A1F0A9-8AC6-41E1-9024-70F6895793AB}"/>
               </a:ext>
             </a:extLst>
           </p:cNvPr>
@@ -21283,7 +21248,7 @@
           <p:cNvPr id="27" name="">
             <a:extLst xmlns:a="http://schemas.openxmlformats.org/drawingml/2006/main">
               <a:ext uri="{FF2B5EF4-FFF2-40B4-BE49-F238E27FC236}">
-                <a16:creationId xmlns:a16="http://schemas.microsoft.com/office/drawing/2014/main" id="{F360E47E-4BBE-4A59-BC76-78D44CA31E41}"/>
+                <a16:creationId xmlns:a16="http://schemas.microsoft.com/office/drawing/2014/main" id="{CD90FF40-CD5A-4EEF-A137-6108318D621E}"/>
               </a:ext>
             </a:extLst>
           </p:cNvPr>
@@ -21314,7 +21279,7 @@
           <p:cNvPr id="18" name="">
             <a:extLst xmlns:a="http://schemas.openxmlformats.org/drawingml/2006/main">
               <a:ext uri="{FF2B5EF4-FFF2-40B4-BE49-F238E27FC236}">
-                <a16:creationId xmlns:a16="http://schemas.microsoft.com/office/drawing/2014/main" id="{2932BF22-BB5A-4F71-BA47-193DE8655AF5}"/>
+                <a16:creationId xmlns:a16="http://schemas.microsoft.com/office/drawing/2014/main" id="{73B8BDE2-F890-42D1-A031-403D0A88E45E}"/>
               </a:ext>
             </a:extLst>
           </p:cNvPr>
@@ -21345,7 +21310,7 @@
           <p:cNvPr id="17" name="">
             <a:extLst xmlns:a="http://schemas.openxmlformats.org/drawingml/2006/main">
               <a:ext uri="{FF2B5EF4-FFF2-40B4-BE49-F238E27FC236}">
-                <a16:creationId xmlns:a16="http://schemas.microsoft.com/office/drawing/2014/main" id="{3771D940-37F6-4FB0-BA94-1822A05F82D8}"/>
+                <a16:creationId xmlns:a16="http://schemas.microsoft.com/office/drawing/2014/main" id="{53BE1777-346E-481E-AE82-AB4AEA054AD4}"/>
               </a:ext>
             </a:extLst>
           </p:cNvPr>
@@ -21376,7 +21341,7 @@
           <p:cNvPr id="16" name="">
             <a:extLst xmlns:a="http://schemas.openxmlformats.org/drawingml/2006/main">
               <a:ext uri="{FF2B5EF4-FFF2-40B4-BE49-F238E27FC236}">
-                <a16:creationId xmlns:a16="http://schemas.microsoft.com/office/drawing/2014/main" id="{215C8EF1-9DED-4A17-9996-CE9D8B7C5A8F}"/>
+                <a16:creationId xmlns:a16="http://schemas.microsoft.com/office/drawing/2014/main" id="{A9D5E538-44CB-4958-80C2-590B35342A79}"/>
               </a:ext>
             </a:extLst>
           </p:cNvPr>
@@ -21407,7 +21372,7 @@
           <p:cNvPr id="15" name="">
             <a:extLst xmlns:a="http://schemas.openxmlformats.org/drawingml/2006/main">
               <a:ext uri="{FF2B5EF4-FFF2-40B4-BE49-F238E27FC236}">
-                <a16:creationId xmlns:a16="http://schemas.microsoft.com/office/drawing/2014/main" id="{6E800C34-A4DE-471B-922F-BF09EE232991}"/>
+                <a16:creationId xmlns:a16="http://schemas.microsoft.com/office/drawing/2014/main" id="{517DCA77-E41F-4682-A788-82C178172C5E}"/>
               </a:ext>
             </a:extLst>
           </p:cNvPr>
@@ -21438,7 +21403,7 @@
           <p:cNvPr id="14" name="">
             <a:extLst xmlns:a="http://schemas.openxmlformats.org/drawingml/2006/main">
               <a:ext uri="{FF2B5EF4-FFF2-40B4-BE49-F238E27FC236}">
-                <a16:creationId xmlns:a16="http://schemas.microsoft.com/office/drawing/2014/main" id="{C5E1D866-F3A0-4CB9-AAE4-89869A7837AE}"/>
+                <a16:creationId xmlns:a16="http://schemas.microsoft.com/office/drawing/2014/main" id="{622E907C-EC61-437E-8D40-A3D64EA27574}"/>
               </a:ext>
             </a:extLst>
           </p:cNvPr>
@@ -21469,7 +21434,7 @@
           <p:cNvPr id="46" name="Ba luồng người dùng">
             <a:extLst xmlns:a="http://schemas.openxmlformats.org/drawingml/2006/main">
               <a:ext uri="{FF2B5EF4-FFF2-40B4-BE49-F238E27FC236}">
-                <a16:creationId xmlns:a16="http://schemas.microsoft.com/office/drawing/2014/main" id="{AF6AB0FC-A414-496E-89E6-8F278BE6FC44}"/>
+                <a16:creationId xmlns:a16="http://schemas.microsoft.com/office/drawing/2014/main" id="{64626D8A-064E-4B59-9564-33B1D58BCCCF}"/>
               </a:ext>
             </a:extLst>
           </p:cNvPr>
@@ -21627,7 +21592,7 @@
           <p:cNvPr id="2" name="Mỗi luồng có điểm bắt đầu, đích hoàn thành và nhánh thay thế">
             <a:extLst xmlns:a="http://schemas.openxmlformats.org/drawingml/2006/main">
               <a:ext uri="{FF2B5EF4-FFF2-40B4-BE49-F238E27FC236}">
-                <a16:creationId xmlns:a16="http://schemas.microsoft.com/office/drawing/2014/main" id="{054B4C69-5E33-4723-8AEC-11E034FDA249}"/>
+                <a16:creationId xmlns:a16="http://schemas.microsoft.com/office/drawing/2014/main" id="{13F5E9A1-79CF-4394-8666-5A1F9AC2A5FD}"/>
               </a:ext>
             </a:extLst>
           </p:cNvPr>
@@ -21785,7 +21750,7 @@
           <p:cNvPr id="3" name="04 / 12">
             <a:extLst xmlns:a="http://schemas.openxmlformats.org/drawingml/2006/main">
               <a:ext uri="{FF2B5EF4-FFF2-40B4-BE49-F238E27FC236}">
-                <a16:creationId xmlns:a16="http://schemas.microsoft.com/office/drawing/2014/main" id="{F2F83A83-A587-464C-9378-399E8C1ADD04}"/>
+                <a16:creationId xmlns:a16="http://schemas.microsoft.com/office/drawing/2014/main" id="{41BCBC3E-6E40-4602-A6B1-B54EE816FCCB}"/>
               </a:ext>
             </a:extLst>
           </p:cNvPr>
@@ -21943,7 +21908,7 @@
           <p:cNvPr id="4" name="Nguồn">
             <a:extLst xmlns:a="http://schemas.openxmlformats.org/drawingml/2006/main">
               <a:ext uri="{FF2B5EF4-FFF2-40B4-BE49-F238E27FC236}">
-                <a16:creationId xmlns:a16="http://schemas.microsoft.com/office/drawing/2014/main" id="{EE9D096C-6F85-4DB9-9B55-1DAA36F0881B}"/>
+                <a16:creationId xmlns:a16="http://schemas.microsoft.com/office/drawing/2014/main" id="{B74009B7-2B0D-4A03-9875-60A9AC112573}"/>
               </a:ext>
             </a:extLst>
           </p:cNvPr>
@@ -22101,7 +22066,7 @@
           <p:cNvPr id="5" name="Đặc tả ba flow">
             <a:extLst xmlns:a="http://schemas.openxmlformats.org/drawingml/2006/main">
               <a:ext uri="{FF2B5EF4-FFF2-40B4-BE49-F238E27FC236}">
-                <a16:creationId xmlns:a16="http://schemas.microsoft.com/office/drawing/2014/main" id="{8B210B92-6717-4326-A118-24172A22F693}"/>
+                <a16:creationId xmlns:a16="http://schemas.microsoft.com/office/drawing/2014/main" id="{6406C478-14A9-4CBF-B5F9-1D82B591B778}"/>
               </a:ext>
             </a:extLst>
           </p:cNvPr>
@@ -22248,7 +22213,7 @@
                 <a:latin typeface="Noto Sans"/>
                 <a:ea typeface="Noto Sans"/>
                 <a:cs typeface="Noto Sans"/>
-                <a:hlinkClick xmlns:r="http://schemas.openxmlformats.org/officeDocument/2006/relationships" r:id="R6216840925404e9a"/>
+                <a:hlinkClick xmlns:r="http://schemas.openxmlformats.org/officeDocument/2006/relationships" r:id="R86cded2b8638479e"/>
               </a:rPr>
               <a:t>Đặc tả ba flow</a:t>
             </a:r>
@@ -22260,7 +22225,7 @@
           <p:cNvPr id="6" name="Figma 06 Prototype">
             <a:extLst xmlns:a="http://schemas.openxmlformats.org/drawingml/2006/main">
               <a:ext uri="{FF2B5EF4-FFF2-40B4-BE49-F238E27FC236}">
-                <a16:creationId xmlns:a16="http://schemas.microsoft.com/office/drawing/2014/main" id="{9F32DF9F-5032-424B-AA1C-5CDA11271C03}"/>
+                <a16:creationId xmlns:a16="http://schemas.microsoft.com/office/drawing/2014/main" id="{EA6AB748-7EEC-450D-9B59-AC69B3A1A1F7}"/>
               </a:ext>
             </a:extLst>
           </p:cNvPr>
@@ -22407,7 +22372,7 @@
                 <a:latin typeface="Noto Sans"/>
                 <a:ea typeface="Noto Sans"/>
                 <a:cs typeface="Noto Sans"/>
-                <a:hlinkClick xmlns:r="http://schemas.openxmlformats.org/officeDocument/2006/relationships" r:id="Rf697db577cf44661"/>
+                <a:hlinkClick xmlns:r="http://schemas.openxmlformats.org/officeDocument/2006/relationships" r:id="R2449ed4ab85d4add"/>
               </a:rPr>
               <a:t>Figma 06 Prototype</a:t>
             </a:r>
@@ -22419,7 +22384,7 @@
           <p:cNvPr id="7" name="F01  Mai">
             <a:extLst xmlns:a="http://schemas.openxmlformats.org/drawingml/2006/main">
               <a:ext uri="{FF2B5EF4-FFF2-40B4-BE49-F238E27FC236}">
-                <a16:creationId xmlns:a16="http://schemas.microsoft.com/office/drawing/2014/main" id="{B1D171E8-DABC-4C2F-982E-E98DEA2A6274}"/>
+                <a16:creationId xmlns:a16="http://schemas.microsoft.com/office/drawing/2014/main" id="{E741477A-3C63-44FE-9009-205A3788088D}"/>
               </a:ext>
             </a:extLst>
           </p:cNvPr>
@@ -22577,7 +22542,7 @@
           <p:cNvPr id="8" name="Hôm nay">
             <a:extLst xmlns:a="http://schemas.openxmlformats.org/drawingml/2006/main">
               <a:ext uri="{FF2B5EF4-FFF2-40B4-BE49-F238E27FC236}">
-                <a16:creationId xmlns:a16="http://schemas.microsoft.com/office/drawing/2014/main" id="{8677EE6F-9533-4DEE-B4DA-087A3F9BE15E}"/>
+                <a16:creationId xmlns:a16="http://schemas.microsoft.com/office/drawing/2014/main" id="{ACBC8996-B00F-450D-BAC7-25CA63D512F7}"/>
               </a:ext>
             </a:extLst>
           </p:cNvPr>
@@ -22739,7 +22704,7 @@
           <p:cNvPr id="9" name="Khám phá ≤5 phút">
             <a:extLst xmlns:a="http://schemas.openxmlformats.org/drawingml/2006/main">
               <a:ext uri="{FF2B5EF4-FFF2-40B4-BE49-F238E27FC236}">
-                <a16:creationId xmlns:a16="http://schemas.microsoft.com/office/drawing/2014/main" id="{F49C0593-9B20-40D3-B1CD-3E8D9F9852EA}"/>
+                <a16:creationId xmlns:a16="http://schemas.microsoft.com/office/drawing/2014/main" id="{5DF46367-994C-45C8-BF34-76D22BE0BE48}"/>
               </a:ext>
             </a:extLst>
           </p:cNvPr>
@@ -22901,7 +22866,7 @@
           <p:cNvPr id="10" name="Chi tiết">
             <a:extLst xmlns:a="http://schemas.openxmlformats.org/drawingml/2006/main">
               <a:ext uri="{FF2B5EF4-FFF2-40B4-BE49-F238E27FC236}">
-                <a16:creationId xmlns:a16="http://schemas.microsoft.com/office/drawing/2014/main" id="{2C315805-8CFF-45A4-9BB6-79672C13B597}"/>
+                <a16:creationId xmlns:a16="http://schemas.microsoft.com/office/drawing/2014/main" id="{C09B6F2D-80EE-41F7-A5B7-11D854722D2E}"/>
               </a:ext>
             </a:extLst>
           </p:cNvPr>
@@ -23063,7 +23028,7 @@
           <p:cNvPr id="11" name="Lịch 12:00">
             <a:extLst xmlns:a="http://schemas.openxmlformats.org/drawingml/2006/main">
               <a:ext uri="{FF2B5EF4-FFF2-40B4-BE49-F238E27FC236}">
-                <a16:creationId xmlns:a16="http://schemas.microsoft.com/office/drawing/2014/main" id="{7931036D-50C3-427B-841A-8CB4A88E3B57}"/>
+                <a16:creationId xmlns:a16="http://schemas.microsoft.com/office/drawing/2014/main" id="{EDE9F4FD-DAAC-4798-A8BA-EF71DC611D6D}"/>
               </a:ext>
             </a:extLst>
           </p:cNvPr>
@@ -23225,7 +23190,7 @@
           <p:cNvPr id="12" name="Lỗi / Thử lại">
             <a:extLst xmlns:a="http://schemas.openxmlformats.org/drawingml/2006/main">
               <a:ext uri="{FF2B5EF4-FFF2-40B4-BE49-F238E27FC236}">
-                <a16:creationId xmlns:a16="http://schemas.microsoft.com/office/drawing/2014/main" id="{696D9047-655B-46C9-8B7F-2755EC773F3E}"/>
+                <a16:creationId xmlns:a16="http://schemas.microsoft.com/office/drawing/2014/main" id="{6C0EEADB-8485-46D7-A550-EC291F9F35CB}"/>
               </a:ext>
             </a:extLst>
           </p:cNvPr>
@@ -23387,7 +23352,7 @@
           <p:cNvPr id="13" name="Home 1/4">
             <a:extLst xmlns:a="http://schemas.openxmlformats.org/drawingml/2006/main">
               <a:ext uri="{FF2B5EF4-FFF2-40B4-BE49-F238E27FC236}">
-                <a16:creationId xmlns:a16="http://schemas.microsoft.com/office/drawing/2014/main" id="{69D57602-8E55-40A9-97AA-1DDE420B11D8}"/>
+                <a16:creationId xmlns:a16="http://schemas.microsoft.com/office/drawing/2014/main" id="{ACE329B8-8A31-4F05-862C-8BE371FEF248}"/>
               </a:ext>
             </a:extLst>
           </p:cNvPr>
@@ -23549,7 +23514,7 @@
           <p:cNvPr id="19" name="Hủy giữ nguyên dữ liệu. Back từ chi tiết giữ bộ lọc.">
             <a:extLst xmlns:a="http://schemas.openxmlformats.org/drawingml/2006/main">
               <a:ext uri="{FF2B5EF4-FFF2-40B4-BE49-F238E27FC236}">
-                <a16:creationId xmlns:a16="http://schemas.microsoft.com/office/drawing/2014/main" id="{121D8C7B-1DFA-4486-864A-CDCDF9B7FE95}"/>
+                <a16:creationId xmlns:a16="http://schemas.microsoft.com/office/drawing/2014/main" id="{67C38A87-3E27-44F1-892E-EF57221DEBAD}"/>
               </a:ext>
             </a:extLst>
           </p:cNvPr>
@@ -23707,7 +23672,7 @@
           <p:cNvPr id="20" name="F02  Huy">
             <a:extLst xmlns:a="http://schemas.openxmlformats.org/drawingml/2006/main">
               <a:ext uri="{FF2B5EF4-FFF2-40B4-BE49-F238E27FC236}">
-                <a16:creationId xmlns:a16="http://schemas.microsoft.com/office/drawing/2014/main" id="{1DBAC292-06E1-4BF4-BCBB-194DB6C43E9F}"/>
+                <a16:creationId xmlns:a16="http://schemas.microsoft.com/office/drawing/2014/main" id="{C5F22B34-B07A-4F4A-B077-C84D0C530EEC}"/>
               </a:ext>
             </a:extLst>
           </p:cNvPr>
@@ -23865,7 +23830,7 @@
           <p:cNvPr id="21" name="Hôm nay">
             <a:extLst xmlns:a="http://schemas.openxmlformats.org/drawingml/2006/main">
               <a:ext uri="{FF2B5EF4-FFF2-40B4-BE49-F238E27FC236}">
-                <a16:creationId xmlns:a16="http://schemas.microsoft.com/office/drawing/2014/main" id="{71A23D55-D62B-426F-886E-5F92B8A904A6}"/>
+                <a16:creationId xmlns:a16="http://schemas.microsoft.com/office/drawing/2014/main" id="{834FCE4B-45C0-413D-B9CB-E57B5DA6CD06}"/>
               </a:ext>
             </a:extLst>
           </p:cNvPr>
@@ -24027,7 +23992,7 @@
           <p:cNvPr id="22" name="Thư giãn">
             <a:extLst xmlns:a="http://schemas.openxmlformats.org/drawingml/2006/main">
               <a:ext uri="{FF2B5EF4-FFF2-40B4-BE49-F238E27FC236}">
-                <a16:creationId xmlns:a16="http://schemas.microsoft.com/office/drawing/2014/main" id="{A98F9314-7CF1-451C-87F2-EB2F11C24F0E}"/>
+                <a16:creationId xmlns:a16="http://schemas.microsoft.com/office/drawing/2014/main" id="{C5D6DAF3-2EB8-4F52-8635-4F684FE46B9D}"/>
               </a:ext>
             </a:extLst>
           </p:cNvPr>
@@ -24189,7 +24154,7 @@
           <p:cNvPr id="23" name="Đang nghỉ">
             <a:extLst xmlns:a="http://schemas.openxmlformats.org/drawingml/2006/main">
               <a:ext uri="{FF2B5EF4-FFF2-40B4-BE49-F238E27FC236}">
-                <a16:creationId xmlns:a16="http://schemas.microsoft.com/office/drawing/2014/main" id="{BE487EC4-B19C-4DC9-8045-C1E9B1377071}"/>
+                <a16:creationId xmlns:a16="http://schemas.microsoft.com/office/drawing/2014/main" id="{0AE76867-6DA1-4D8E-ABF4-89090EACB8C9}"/>
               </a:ext>
             </a:extLst>
           </p:cNvPr>
@@ -24351,7 +24316,7 @@
           <p:cNvPr id="24" name="Tạm dừng">
             <a:extLst xmlns:a="http://schemas.openxmlformats.org/drawingml/2006/main">
               <a:ext uri="{FF2B5EF4-FFF2-40B4-BE49-F238E27FC236}">
-                <a16:creationId xmlns:a16="http://schemas.microsoft.com/office/drawing/2014/main" id="{75F81DBB-DAF8-49DA-9559-0557D83BC574}"/>
+                <a16:creationId xmlns:a16="http://schemas.microsoft.com/office/drawing/2014/main" id="{AB9028B4-2C57-48E3-A211-117610267755}"/>
               </a:ext>
             </a:extLst>
           </p:cNvPr>
@@ -24513,7 +24478,7 @@
           <p:cNvPr id="25" name="Kết thúc / ghi nhận">
             <a:extLst xmlns:a="http://schemas.openxmlformats.org/drawingml/2006/main">
               <a:ext uri="{FF2B5EF4-FFF2-40B4-BE49-F238E27FC236}">
-                <a16:creationId xmlns:a16="http://schemas.microsoft.com/office/drawing/2014/main" id="{CB145BE8-DFE1-4EA3-A442-4D8C56B3A377}"/>
+                <a16:creationId xmlns:a16="http://schemas.microsoft.com/office/drawing/2014/main" id="{12205AF3-B83A-428E-BC33-D681E0CAF2B8}"/>
               </a:ext>
             </a:extLst>
           </p:cNvPr>
@@ -24675,7 +24640,7 @@
           <p:cNvPr id="26" name="Tiến độ 2/4">
             <a:extLst xmlns:a="http://schemas.openxmlformats.org/drawingml/2006/main">
               <a:ext uri="{FF2B5EF4-FFF2-40B4-BE49-F238E27FC236}">
-                <a16:creationId xmlns:a16="http://schemas.microsoft.com/office/drawing/2014/main" id="{25D9C6CD-D6A4-4ABB-BB17-B8C5EEFF8136}"/>
+                <a16:creationId xmlns:a16="http://schemas.microsoft.com/office/drawing/2014/main" id="{3979B2B9-E3BC-4F04-8249-763767514F94}"/>
               </a:ext>
             </a:extLst>
           </p:cNvPr>
@@ -24837,7 +24802,7 @@
           <p:cNvPr id="32" name="Overlay rời phiên; ở lại phục hồi paused. Check-in có Hoàn t">
             <a:extLst xmlns:a="http://schemas.openxmlformats.org/drawingml/2006/main">
               <a:ext uri="{FF2B5EF4-FFF2-40B4-BE49-F238E27FC236}">
-                <a16:creationId xmlns:a16="http://schemas.microsoft.com/office/drawing/2014/main" id="{B2D4A454-65D7-4C2E-A9AA-FDC62AE70A88}"/>
+                <a16:creationId xmlns:a16="http://schemas.microsoft.com/office/drawing/2014/main" id="{015988E3-673D-4ECF-A008-2EC181BBBD34}"/>
               </a:ext>
             </a:extLst>
           </p:cNvPr>
@@ -24995,7 +24960,7 @@
           <p:cNvPr id="33" name="F03  Linh">
             <a:extLst xmlns:a="http://schemas.openxmlformats.org/drawingml/2006/main">
               <a:ext uri="{FF2B5EF4-FFF2-40B4-BE49-F238E27FC236}">
-                <a16:creationId xmlns:a16="http://schemas.microsoft.com/office/drawing/2014/main" id="{8A706CEC-9FC3-4B27-A84F-9D35FC81E799}"/>
+                <a16:creationId xmlns:a16="http://schemas.microsoft.com/office/drawing/2014/main" id="{4C1E4E89-C03A-4412-86BF-8674A5EBD289}"/>
               </a:ext>
             </a:extLst>
           </p:cNvPr>
@@ -25153,7 +25118,7 @@
           <p:cNvPr id="34" name="Home 17:30">
             <a:extLst xmlns:a="http://schemas.openxmlformats.org/drawingml/2006/main">
               <a:ext uri="{FF2B5EF4-FFF2-40B4-BE49-F238E27FC236}">
-                <a16:creationId xmlns:a16="http://schemas.microsoft.com/office/drawing/2014/main" id="{38E2A1BE-36B0-4887-9A7E-3C3A3D8E0414}"/>
+                <a16:creationId xmlns:a16="http://schemas.microsoft.com/office/drawing/2014/main" id="{7569A8AA-C088-45C9-BAF5-00E724D7F2F7}"/>
               </a:ext>
             </a:extLst>
           </p:cNvPr>
@@ -25315,7 +25280,7 @@
           <p:cNvPr id="35" name="Chi tiết đã thêm">
             <a:extLst xmlns:a="http://schemas.openxmlformats.org/drawingml/2006/main">
               <a:ext uri="{FF2B5EF4-FFF2-40B4-BE49-F238E27FC236}">
-                <a16:creationId xmlns:a16="http://schemas.microsoft.com/office/drawing/2014/main" id="{D89E6451-7441-4F57-94AF-1E3E6C34D1D0}"/>
+                <a16:creationId xmlns:a16="http://schemas.microsoft.com/office/drawing/2014/main" id="{4E1EC4E5-623D-4FE4-A5D3-C31D2BB673A5}"/>
               </a:ext>
             </a:extLst>
           </p:cNvPr>
@@ -25477,7 +25442,7 @@
           <p:cNvPr id="36" name="Đổi lịch 18:00">
             <a:extLst xmlns:a="http://schemas.openxmlformats.org/drawingml/2006/main">
               <a:ext uri="{FF2B5EF4-FFF2-40B4-BE49-F238E27FC236}">
-                <a16:creationId xmlns:a16="http://schemas.microsoft.com/office/drawing/2014/main" id="{C22A51D8-70C0-4DE1-BA5C-15DEE28FABF3}"/>
+                <a16:creationId xmlns:a16="http://schemas.microsoft.com/office/drawing/2014/main" id="{C4DA642A-847D-4E37-84DC-EA073CD7978C}"/>
               </a:ext>
             </a:extLst>
           </p:cNvPr>
@@ -25639,7 +25604,7 @@
           <p:cNvPr id="37" name="Đang lưu">
             <a:extLst xmlns:a="http://schemas.openxmlformats.org/drawingml/2006/main">
               <a:ext uri="{FF2B5EF4-FFF2-40B4-BE49-F238E27FC236}">
-                <a16:creationId xmlns:a16="http://schemas.microsoft.com/office/drawing/2014/main" id="{4085FCCF-E485-4F0F-AC63-4E87DEFF827D}"/>
+                <a16:creationId xmlns:a16="http://schemas.microsoft.com/office/drawing/2014/main" id="{62B75869-4E31-4B26-958F-B5DD7638E12A}"/>
               </a:ext>
             </a:extLst>
           </p:cNvPr>
@@ -25801,7 +25766,7 @@
           <p:cNvPr id="38" name="Lỗi / Thử lại">
             <a:extLst xmlns:a="http://schemas.openxmlformats.org/drawingml/2006/main">
               <a:ext uri="{FF2B5EF4-FFF2-40B4-BE49-F238E27FC236}">
-                <a16:creationId xmlns:a16="http://schemas.microsoft.com/office/drawing/2014/main" id="{561AA567-AD3E-4AF3-BA9C-2933FF04FB02}"/>
+                <a16:creationId xmlns:a16="http://schemas.microsoft.com/office/drawing/2014/main" id="{2CC22DD1-DD18-49F4-94FA-C4D17F5E004D}"/>
               </a:ext>
             </a:extLst>
           </p:cNvPr>
@@ -25963,7 +25928,7 @@
           <p:cNvPr id="39" name="Home 18:00">
             <a:extLst xmlns:a="http://schemas.openxmlformats.org/drawingml/2006/main">
               <a:ext uri="{FF2B5EF4-FFF2-40B4-BE49-F238E27FC236}">
-                <a16:creationId xmlns:a16="http://schemas.microsoft.com/office/drawing/2014/main" id="{66F3C162-3EF9-42E0-A8EB-BDC593A3F1E1}"/>
+                <a16:creationId xmlns:a16="http://schemas.microsoft.com/office/drawing/2014/main" id="{259C21EE-46FA-4051-B054-73C964A578B6}"/>
               </a:ext>
             </a:extLst>
           </p:cNvPr>
@@ -26125,7 +26090,7 @@
           <p:cNvPr id="45" name="Không tạo bản sao hoạt động. Giờ yên lặng chỉ tắt thông báo.">
             <a:extLst xmlns:a="http://schemas.openxmlformats.org/drawingml/2006/main">
               <a:ext uri="{FF2B5EF4-FFF2-40B4-BE49-F238E27FC236}">
-                <a16:creationId xmlns:a16="http://schemas.microsoft.com/office/drawing/2014/main" id="{0F38B3A0-69F4-4AF6-8AD2-BE2545C85E6E}"/>
+                <a16:creationId xmlns:a16="http://schemas.microsoft.com/office/drawing/2014/main" id="{F3F212F0-F8CF-47AC-8482-488DC360C9B2}"/>
               </a:ext>
             </a:extLst>
           </p:cNvPr>
@@ -26281,7 +26246,7 @@
     </p:spTree>
     <p:extLst>
       <p:ext uri="{BB962C8B-B14F-4D97-AF65-F5344CB8AC3E}">
-        <p14:creationId xmlns:p14="http://schemas.microsoft.com/office/powerpoint/2010/main" val="2087939468"/>
+        <p14:creationId xmlns:p14="http://schemas.microsoft.com/office/powerpoint/2010/main" val="1097686347"/>
       </p:ext>
     </p:extLst>
   </p:cSld>
@@ -26312,7 +26277,7 @@
           <p:cNvPr id="15" name="Tạo UI bằng Google Stitch">
             <a:extLst xmlns:a="http://schemas.openxmlformats.org/drawingml/2006/main">
               <a:ext uri="{FF2B5EF4-FFF2-40B4-BE49-F238E27FC236}">
-                <a16:creationId xmlns:a16="http://schemas.microsoft.com/office/drawing/2014/main" id="{87B37B0C-0229-47CC-B1CC-167100BEAA1D}"/>
+                <a16:creationId xmlns:a16="http://schemas.microsoft.com/office/drawing/2014/main" id="{F478D72F-35D6-40BB-8E2F-104FB160C0C6}"/>
               </a:ext>
             </a:extLst>
           </p:cNvPr>
@@ -26470,7 +26435,7 @@
           <p:cNvPr id="2" name="Đầu vào gồm persona, nhiệm vụ Android, wireframe, phong cách">
             <a:extLst xmlns:a="http://schemas.openxmlformats.org/drawingml/2006/main">
               <a:ext uri="{FF2B5EF4-FFF2-40B4-BE49-F238E27FC236}">
-                <a16:creationId xmlns:a16="http://schemas.microsoft.com/office/drawing/2014/main" id="{DAD6A7C7-96C8-4AF5-BBD8-29E609AC9EF4}"/>
+                <a16:creationId xmlns:a16="http://schemas.microsoft.com/office/drawing/2014/main" id="{269A8D25-DFFC-4F37-8713-21C7BD426BEB}"/>
               </a:ext>
             </a:extLst>
           </p:cNvPr>
@@ -26628,7 +26593,7 @@
           <p:cNvPr id="3" name="05 / 12">
             <a:extLst xmlns:a="http://schemas.openxmlformats.org/drawingml/2006/main">
               <a:ext uri="{FF2B5EF4-FFF2-40B4-BE49-F238E27FC236}">
-                <a16:creationId xmlns:a16="http://schemas.microsoft.com/office/drawing/2014/main" id="{44D45E82-F199-48E8-AA18-C74005342077}"/>
+                <a16:creationId xmlns:a16="http://schemas.microsoft.com/office/drawing/2014/main" id="{E637C0E3-446F-40D5-986A-57F9EA441D36}"/>
               </a:ext>
             </a:extLst>
           </p:cNvPr>
@@ -26786,7 +26751,7 @@
           <p:cNvPr id="4" name="Nguồn">
             <a:extLst xmlns:a="http://schemas.openxmlformats.org/drawingml/2006/main">
               <a:ext uri="{FF2B5EF4-FFF2-40B4-BE49-F238E27FC236}">
-                <a16:creationId xmlns:a16="http://schemas.microsoft.com/office/drawing/2014/main" id="{1BB3E202-6DE3-4B93-98DA-6380DD6C1C93}"/>
+                <a16:creationId xmlns:a16="http://schemas.microsoft.com/office/drawing/2014/main" id="{FD527819-60D8-4F5C-8EFB-6B932D6C922D}"/>
               </a:ext>
             </a:extLst>
           </p:cNvPr>
@@ -26944,7 +26909,7 @@
           <p:cNvPr id="5" name="Prompt UI01 lưu trong dự án">
             <a:extLst xmlns:a="http://schemas.openxmlformats.org/drawingml/2006/main">
               <a:ext uri="{FF2B5EF4-FFF2-40B4-BE49-F238E27FC236}">
-                <a16:creationId xmlns:a16="http://schemas.microsoft.com/office/drawing/2014/main" id="{CDC0B7FC-F7A0-4538-AA58-3CAFA844E94D}"/>
+                <a16:creationId xmlns:a16="http://schemas.microsoft.com/office/drawing/2014/main" id="{A3C2961E-59CC-49BB-8A8A-624AEFBEAB66}"/>
               </a:ext>
             </a:extLst>
           </p:cNvPr>
@@ -27091,7 +27056,7 @@
                 <a:latin typeface="Noto Sans"/>
                 <a:ea typeface="Noto Sans"/>
                 <a:cs typeface="Noto Sans"/>
-                <a:hlinkClick xmlns:r="http://schemas.openxmlformats.org/officeDocument/2006/relationships" r:id="R4fa0d8d5cccb401b"/>
+                <a:hlinkClick xmlns:r="http://schemas.openxmlformats.org/officeDocument/2006/relationships" r:id="R55043144ac7b4877"/>
               </a:rPr>
               <a:t>Prompt UI01 lưu trong dự án</a:t>
             </a:r>
@@ -27103,7 +27068,7 @@
           <p:cNvPr id="6" name="Brief và AI log">
             <a:extLst xmlns:a="http://schemas.openxmlformats.org/drawingml/2006/main">
               <a:ext uri="{FF2B5EF4-FFF2-40B4-BE49-F238E27FC236}">
-                <a16:creationId xmlns:a16="http://schemas.microsoft.com/office/drawing/2014/main" id="{D9C16A04-64DC-43EA-83AB-ACC2F420A2DD}"/>
+                <a16:creationId xmlns:a16="http://schemas.microsoft.com/office/drawing/2014/main" id="{D911DA6C-AE28-40B0-8FDD-053E6F3DA171}"/>
               </a:ext>
             </a:extLst>
           </p:cNvPr>
@@ -27250,7 +27215,7 @@
                 <a:latin typeface="Noto Sans"/>
                 <a:ea typeface="Noto Sans"/>
                 <a:cs typeface="Noto Sans"/>
-                <a:hlinkClick xmlns:r="http://schemas.openxmlformats.org/officeDocument/2006/relationships" r:id="Rb6081448c2544348"/>
+                <a:hlinkClick xmlns:r="http://schemas.openxmlformats.org/officeDocument/2006/relationships" r:id="R6bbd2a8c7a2f483d"/>
               </a:rPr>
               <a:t>Brief và AI log</a:t>
             </a:r>
@@ -27262,7 +27227,7 @@
           <p:cNvPr id="7" name="Dự án Stitch">
             <a:extLst xmlns:a="http://schemas.openxmlformats.org/drawingml/2006/main">
               <a:ext uri="{FF2B5EF4-FFF2-40B4-BE49-F238E27FC236}">
-                <a16:creationId xmlns:a16="http://schemas.microsoft.com/office/drawing/2014/main" id="{9D07CD37-ADDD-4685-9740-449396081283}"/>
+                <a16:creationId xmlns:a16="http://schemas.microsoft.com/office/drawing/2014/main" id="{B06DF5B3-6D99-4985-AD6A-688E52602D7A}"/>
               </a:ext>
             </a:extLst>
           </p:cNvPr>
@@ -27409,7 +27374,7 @@
                 <a:latin typeface="Noto Sans"/>
                 <a:ea typeface="Noto Sans"/>
                 <a:cs typeface="Noto Sans"/>
-                <a:hlinkClick xmlns:r="http://schemas.openxmlformats.org/officeDocument/2006/relationships" r:id="Rf98644e79a354b28"/>
+                <a:hlinkClick xmlns:r="http://schemas.openxmlformats.org/officeDocument/2006/relationships" r:id="Raa07111ee41240ed"/>
               </a:rPr>
               <a:t>Dự án Stitch</a:t>
             </a:r>
@@ -27418,10 +27383,10 @@
       </p:sp>
       <p:sp>
         <p:nvSpPr>
-          <p:cNvPr id="8" name="Trích nguyên văn bản lưu">
+          <p:cNvPr id="8" name="Trích prompt đã gửi trên Stitch">
             <a:extLst xmlns:a="http://schemas.openxmlformats.org/drawingml/2006/main">
               <a:ext uri="{FF2B5EF4-FFF2-40B4-BE49-F238E27FC236}">
-                <a16:creationId xmlns:a16="http://schemas.microsoft.com/office/drawing/2014/main" id="{1E8742AC-E470-41D6-BEF0-4ABC842A6E15}"/>
+                <a16:creationId xmlns:a16="http://schemas.microsoft.com/office/drawing/2014/main" id="{CF987C56-3482-43E6-BC64-CDB2912E92C8}"/>
               </a:ext>
             </a:extLst>
           </p:cNvPr>
@@ -27569,7 +27534,7 @@
                 <a:ea typeface="Noto Sans"/>
                 <a:cs typeface="Noto Sans"/>
               </a:rPr>
-              <a:t>Trích nguyên văn bản lưu</a:t>
+              <a:t>Trích prompt đã gửi trên Stitch</a:t>
             </a:r>
           </a:p>
         </p:txBody>
@@ -27579,7 +27544,7 @@
           <p:cNvPr id="9" name="“Từ đúng 10 wireframe Power9 Office Routine đang chọn, tạo 1">
             <a:extLst xmlns:a="http://schemas.openxmlformats.org/drawingml/2006/main">
               <a:ext uri="{FF2B5EF4-FFF2-40B4-BE49-F238E27FC236}">
-                <a16:creationId xmlns:a16="http://schemas.microsoft.com/office/drawing/2014/main" id="{4ACA2ABB-90E0-4FE2-9C74-795E0A6659BA}"/>
+                <a16:creationId xmlns:a16="http://schemas.microsoft.com/office/drawing/2014/main" id="{ADFBEE8B-BAFC-490D-B493-1DBAAE111D6E}"/>
               </a:ext>
             </a:extLst>
           </p:cNvPr>
@@ -27737,7 +27702,7 @@
           <p:cNvPr id="10" name="“Font Be Vietnam Pro, Roboto fallback; title 24/32, heading ">
             <a:extLst xmlns:a="http://schemas.openxmlformats.org/drawingml/2006/main">
               <a:ext uri="{FF2B5EF4-FFF2-40B4-BE49-F238E27FC236}">
-                <a16:creationId xmlns:a16="http://schemas.microsoft.com/office/drawing/2014/main" id="{70C6CB24-AAB5-45D0-983C-08088230F60B}"/>
+                <a16:creationId xmlns:a16="http://schemas.microsoft.com/office/drawing/2014/main" id="{4BF55648-2288-4C0E-A5F5-1284207721F4}"/>
               </a:ext>
             </a:extLst>
           </p:cNvPr>
@@ -27895,7 +27860,7 @@
           <p:cNvPr id="11" name="“Frame gốc 360×800 cho cả 10”&#10;“kiểm tra thêm rộng 412.”">
             <a:extLst xmlns:a="http://schemas.openxmlformats.org/drawingml/2006/main">
               <a:ext uri="{FF2B5EF4-FFF2-40B4-BE49-F238E27FC236}">
-                <a16:creationId xmlns:a16="http://schemas.microsoft.com/office/drawing/2014/main" id="{6A0861F9-60F4-4F8E-8145-35C10FA0FCD5}"/>
+                <a16:creationId xmlns:a16="http://schemas.microsoft.com/office/drawing/2014/main" id="{8FE902A3-EE2C-4214-93D9-BE585C932001}"/>
               </a:ext>
             </a:extLst>
           </p:cNvPr>
@@ -28076,7 +28041,7 @@
           <p:cNvPr id="12" name="">
             <a:extLst xmlns:a="http://schemas.openxmlformats.org/drawingml/2006/main">
               <a:ext uri="{FF2B5EF4-FFF2-40B4-BE49-F238E27FC236}">
-                <a16:creationId xmlns:a16="http://schemas.microsoft.com/office/drawing/2014/main" id="{EBAE6029-613B-43A5-833F-AE8B2A4B3AC8}"/>
+                <a16:creationId xmlns:a16="http://schemas.microsoft.com/office/drawing/2014/main" id="{02EEE365-180B-44CF-B7F3-8FDD36261CE0}"/>
               </a:ext>
             </a:extLst>
           </p:cNvPr>
@@ -28086,7 +28051,7 @@
           <p:nvPr/>
         </p:nvPicPr>
         <p:blipFill>
-          <a:blip xmlns:r="http://schemas.openxmlformats.org/officeDocument/2006/relationships" xmlns:a="http://schemas.openxmlformats.org/drawingml/2006/main" r:embed="Rd797403ee7774f52"/>
+          <a:blip xmlns:r="http://schemas.openxmlformats.org/officeDocument/2006/relationships" xmlns:a="http://schemas.openxmlformats.org/drawingml/2006/main" r:embed="Rf15d31aaa4904fa9"/>
           <a:stretch xmlns:a="http://schemas.openxmlformats.org/drawingml/2006/main"/>
         </p:blipFill>
         <p:spPr>
@@ -28104,7 +28069,7 @@
           <p:cNvPr id="13" name="Output Stitch UI01 gốc">
             <a:extLst xmlns:a="http://schemas.openxmlformats.org/drawingml/2006/main">
               <a:ext uri="{FF2B5EF4-FFF2-40B4-BE49-F238E27FC236}">
-                <a16:creationId xmlns:a16="http://schemas.microsoft.com/office/drawing/2014/main" id="{19DFA9DC-1370-42D9-8ABB-A735AE2C6239}"/>
+                <a16:creationId xmlns:a16="http://schemas.microsoft.com/office/drawing/2014/main" id="{F00270B7-6219-40A6-B01E-7FEF1C97F689}"/>
               </a:ext>
             </a:extLst>
           </p:cNvPr>
@@ -28259,10 +28224,10 @@
       </p:sp>
       <p:sp>
         <p:nvSpPr>
-          <p:cNvPr id="14" name="Toàn văn nằm trong nguồn và notes. Chưa đối chiếu đủ log cha">
+          <p:cNvPr id="14" name="Đã xác nhận gửi nguyên văn 100%. Toàn văn có trong nguồn và ">
             <a:extLst xmlns:a="http://schemas.openxmlformats.org/drawingml/2006/main">
               <a:ext uri="{FF2B5EF4-FFF2-40B4-BE49-F238E27FC236}">
-                <a16:creationId xmlns:a16="http://schemas.microsoft.com/office/drawing/2014/main" id="{9E058C6A-F20A-4AFC-A5EA-D3557557B42A}"/>
+                <a16:creationId xmlns:a16="http://schemas.microsoft.com/office/drawing/2014/main" id="{D3FEE501-A497-49B0-9023-C78738E3B8B7}"/>
               </a:ext>
             </a:extLst>
           </p:cNvPr>
@@ -28410,7 +28375,7 @@
                 <a:ea typeface="Noto Sans"/>
                 <a:cs typeface="Noto Sans"/>
               </a:rPr>
-              <a:t>Toàn văn nằm trong nguồn và notes. Chưa đối chiếu đủ log chat thực gửi.</a:t>
+              <a:t>Đã xác nhận gửi nguyên văn 100%. Toàn văn có trong nguồn và notes.</a:t>
             </a:r>
           </a:p>
         </p:txBody>
@@ -28418,7 +28383,7 @@
     </p:spTree>
     <p:extLst>
       <p:ext uri="{BB962C8B-B14F-4D97-AF65-F5344CB8AC3E}">
-        <p14:creationId xmlns:p14="http://schemas.microsoft.com/office/powerpoint/2010/main" val="282602209"/>
+        <p14:creationId xmlns:p14="http://schemas.microsoft.com/office/powerpoint/2010/main" val="1099619718"/>
       </p:ext>
     </p:extLst>
   </p:cSld>
@@ -28446,10 +28411,10 @@
       </p:grpSpPr>
       <p:sp>
         <p:nvSpPr>
-          <p:cNvPr id="29" name="Ba vòng cải tiến có mục tiêu khác nhau">
+          <p:cNvPr id="28" name="Ba vòng cải tiến có mục tiêu khác nhau">
             <a:extLst xmlns:a="http://schemas.openxmlformats.org/drawingml/2006/main">
               <a:ext uri="{FF2B5EF4-FFF2-40B4-BE49-F238E27FC236}">
-                <a16:creationId xmlns:a16="http://schemas.microsoft.com/office/drawing/2014/main" id="{4EA6B9E6-35CE-4F3D-AFD7-770D68FB1F21}"/>
+                <a16:creationId xmlns:a16="http://schemas.microsoft.com/office/drawing/2014/main" id="{2654EF1A-6D82-4681-9861-FB3900D66A36}"/>
               </a:ext>
             </a:extLst>
           </p:cNvPr>
@@ -28607,7 +28572,7 @@
           <p:cNvPr id="2" name="Mỗi vòng giữ ảnh trước/sau và chỉ kết luận theo bằng chứng q">
             <a:extLst xmlns:a="http://schemas.openxmlformats.org/drawingml/2006/main">
               <a:ext uri="{FF2B5EF4-FFF2-40B4-BE49-F238E27FC236}">
-                <a16:creationId xmlns:a16="http://schemas.microsoft.com/office/drawing/2014/main" id="{3B1294B7-09F4-4374-AEA3-1700E766B2FF}"/>
+                <a16:creationId xmlns:a16="http://schemas.microsoft.com/office/drawing/2014/main" id="{C6AFF2F6-7C17-4D1E-B6B8-963FE564C6D0}"/>
               </a:ext>
             </a:extLst>
           </p:cNvPr>
@@ -28765,7 +28730,7 @@
           <p:cNvPr id="3" name="06 / 12">
             <a:extLst xmlns:a="http://schemas.openxmlformats.org/drawingml/2006/main">
               <a:ext uri="{FF2B5EF4-FFF2-40B4-BE49-F238E27FC236}">
-                <a16:creationId xmlns:a16="http://schemas.microsoft.com/office/drawing/2014/main" id="{1E1486A4-EF3E-4BF8-9BC9-549D580795BD}"/>
+                <a16:creationId xmlns:a16="http://schemas.microsoft.com/office/drawing/2014/main" id="{EB258D58-5AC1-475A-BA80-D481FB01C19E}"/>
               </a:ext>
             </a:extLst>
           </p:cNvPr>
@@ -28923,7 +28888,7 @@
           <p:cNvPr id="4" name="Nguồn">
             <a:extLst xmlns:a="http://schemas.openxmlformats.org/drawingml/2006/main">
               <a:ext uri="{FF2B5EF4-FFF2-40B4-BE49-F238E27FC236}">
-                <a16:creationId xmlns:a16="http://schemas.microsoft.com/office/drawing/2014/main" id="{1AA5716A-A57B-4B48-A384-B70DCF28A9AD}"/>
+                <a16:creationId xmlns:a16="http://schemas.microsoft.com/office/drawing/2014/main" id="{DA781F78-BD6C-4801-ADB6-1E9474E03BBD}"/>
               </a:ext>
             </a:extLst>
           </p:cNvPr>
@@ -29081,7 +29046,7 @@
           <p:cNvPr id="5" name="3 vòng và bộ ảnh nguồn">
             <a:extLst xmlns:a="http://schemas.openxmlformats.org/drawingml/2006/main">
               <a:ext uri="{FF2B5EF4-FFF2-40B4-BE49-F238E27FC236}">
-                <a16:creationId xmlns:a16="http://schemas.microsoft.com/office/drawing/2014/main" id="{C954C25A-B2DC-41DC-A06F-C95FC8683BF7}"/>
+                <a16:creationId xmlns:a16="http://schemas.microsoft.com/office/drawing/2014/main" id="{72D115FE-11C9-4FA4-B832-947B36671907}"/>
               </a:ext>
             </a:extLst>
           </p:cNvPr>
@@ -29228,7 +29193,7 @@
                 <a:latin typeface="Noto Sans"/>
                 <a:ea typeface="Noto Sans"/>
                 <a:cs typeface="Noto Sans"/>
-                <a:hlinkClick xmlns:r="http://schemas.openxmlformats.org/officeDocument/2006/relationships" r:id="Raed5c0107b1f4723"/>
+                <a:hlinkClick xmlns:r="http://schemas.openxmlformats.org/officeDocument/2006/relationships" r:id="Rd77e4384286a4d75"/>
               </a:rPr>
               <a:t>3 vòng và bộ ảnh nguồn</a:t>
             </a:r>
@@ -29240,7 +29205,7 @@
           <p:cNvPr id="6" name="Phản biện C01–C03">
             <a:extLst xmlns:a="http://schemas.openxmlformats.org/drawingml/2006/main">
               <a:ext uri="{FF2B5EF4-FFF2-40B4-BE49-F238E27FC236}">
-                <a16:creationId xmlns:a16="http://schemas.microsoft.com/office/drawing/2014/main" id="{794B94A2-45C5-4601-AC7E-6236CF6C1476}"/>
+                <a16:creationId xmlns:a16="http://schemas.microsoft.com/office/drawing/2014/main" id="{9E02DB89-7AFB-456C-98A0-23F59F1C68C1}"/>
               </a:ext>
             </a:extLst>
           </p:cNvPr>
@@ -29387,7 +29352,7 @@
                 <a:latin typeface="Noto Sans"/>
                 <a:ea typeface="Noto Sans"/>
                 <a:cs typeface="Noto Sans"/>
-                <a:hlinkClick xmlns:r="http://schemas.openxmlformats.org/officeDocument/2006/relationships" r:id="Rcb3d82dffdfd4da6"/>
+                <a:hlinkClick xmlns:r="http://schemas.openxmlformats.org/officeDocument/2006/relationships" r:id="R6ebe18139ebe4ded"/>
               </a:rPr>
               <a:t>Phản biện C01–C03</a:t>
             </a:r>
@@ -29396,169 +29361,10 @@
       </p:sp>
       <p:sp>
         <p:nvSpPr>
-          <p:cNvPr id="7" name="Nielsen heuristics">
+          <p:cNvPr id="7" name="1  Typography nhất quán">
             <a:extLst xmlns:a="http://schemas.openxmlformats.org/drawingml/2006/main">
               <a:ext uri="{FF2B5EF4-FFF2-40B4-BE49-F238E27FC236}">
-                <a16:creationId xmlns:a16="http://schemas.microsoft.com/office/drawing/2014/main" id="{62BCDC7B-3AE0-4E18-A49F-17873E8E18A2}"/>
-              </a:ext>
-            </a:extLst>
-          </p:cNvPr>
-          <p:cNvSpPr>
-            <a:spLocks xmlns:a="http://schemas.openxmlformats.org/drawingml/2006/main" noGrp="1"/>
-          </p:cNvSpPr>
-          <p:nvPr/>
-        </p:nvSpPr>
-        <p:spPr>
-          <a:xfrm xmlns:a="http://schemas.openxmlformats.org/drawingml/2006/main">
-            <a:off x="12334875" y="9467850"/>
-            <a:ext cx="5000625" cy="361950"/>
-          </a:xfrm>
-          <a:prstGeom xmlns:a="http://schemas.openxmlformats.org/drawingml/2006/main" prst="rect">
-            <a:avLst/>
-          </a:prstGeom>
-          <a:noFill xmlns:a="http://schemas.openxmlformats.org/drawingml/2006/main"/>
-          <a:ln xmlns:a="http://schemas.openxmlformats.org/drawingml/2006/main" w="0">
-            <a:noFill/>
-          </a:ln>
-        </p:spPr>
-        <p:txBody>
-          <a:bodyPr xmlns:a="http://schemas.openxmlformats.org/drawingml/2006/main" lIns="0" tIns="0" rIns="0" bIns="0">
-            <a:noAutofit/>
-          </a:bodyPr>
-          <a:lstStyle xmlns:a="http://schemas.openxmlformats.org/drawingml/2006/main">
-            <a:defPPr>
-              <a:defRPr sz="1650" b="0">
-                <a:solidFill>
-                  <a:srgbClr val="1E5AA8"/>
-                </a:solidFill>
-                <a:latin typeface="Noto Sans"/>
-                <a:ea typeface="Noto Sans"/>
-                <a:cs typeface="Noto Sans"/>
-              </a:defRPr>
-            </a:defPPr>
-            <a:lvl1pPr>
-              <a:defRPr sz="1650" b="0">
-                <a:solidFill>
-                  <a:srgbClr val="1E5AA8"/>
-                </a:solidFill>
-                <a:latin typeface="Noto Sans"/>
-                <a:ea typeface="Noto Sans"/>
-                <a:cs typeface="Noto Sans"/>
-              </a:defRPr>
-            </a:lvl1pPr>
-            <a:lvl2pPr>
-              <a:defRPr sz="1650" b="0">
-                <a:solidFill>
-                  <a:srgbClr val="1E5AA8"/>
-                </a:solidFill>
-                <a:latin typeface="Noto Sans"/>
-                <a:ea typeface="Noto Sans"/>
-                <a:cs typeface="Noto Sans"/>
-              </a:defRPr>
-            </a:lvl2pPr>
-            <a:lvl3pPr>
-              <a:defRPr sz="1650" b="0">
-                <a:solidFill>
-                  <a:srgbClr val="1E5AA8"/>
-                </a:solidFill>
-                <a:latin typeface="Noto Sans"/>
-                <a:ea typeface="Noto Sans"/>
-                <a:cs typeface="Noto Sans"/>
-              </a:defRPr>
-            </a:lvl3pPr>
-            <a:lvl4pPr>
-              <a:defRPr sz="1650" b="0">
-                <a:solidFill>
-                  <a:srgbClr val="1E5AA8"/>
-                </a:solidFill>
-                <a:latin typeface="Noto Sans"/>
-                <a:ea typeface="Noto Sans"/>
-                <a:cs typeface="Noto Sans"/>
-              </a:defRPr>
-            </a:lvl4pPr>
-            <a:lvl5pPr>
-              <a:defRPr sz="1650" b="0">
-                <a:solidFill>
-                  <a:srgbClr val="1E5AA8"/>
-                </a:solidFill>
-                <a:latin typeface="Noto Sans"/>
-                <a:ea typeface="Noto Sans"/>
-                <a:cs typeface="Noto Sans"/>
-              </a:defRPr>
-            </a:lvl5pPr>
-            <a:lvl6pPr>
-              <a:defRPr sz="1650" b="0">
-                <a:solidFill>
-                  <a:srgbClr val="1E5AA8"/>
-                </a:solidFill>
-                <a:latin typeface="Noto Sans"/>
-                <a:ea typeface="Noto Sans"/>
-                <a:cs typeface="Noto Sans"/>
-              </a:defRPr>
-            </a:lvl6pPr>
-            <a:lvl7pPr>
-              <a:defRPr sz="1650" b="0">
-                <a:solidFill>
-                  <a:srgbClr val="1E5AA8"/>
-                </a:solidFill>
-                <a:latin typeface="Noto Sans"/>
-                <a:ea typeface="Noto Sans"/>
-                <a:cs typeface="Noto Sans"/>
-              </a:defRPr>
-            </a:lvl7pPr>
-            <a:lvl8pPr>
-              <a:defRPr sz="1650" b="0">
-                <a:solidFill>
-                  <a:srgbClr val="1E5AA8"/>
-                </a:solidFill>
-                <a:latin typeface="Noto Sans"/>
-                <a:ea typeface="Noto Sans"/>
-                <a:cs typeface="Noto Sans"/>
-              </a:defRPr>
-            </a:lvl8pPr>
-            <a:lvl9pPr>
-              <a:defRPr sz="1650" b="0">
-                <a:solidFill>
-                  <a:srgbClr val="1E5AA8"/>
-                </a:solidFill>
-                <a:latin typeface="Noto Sans"/>
-                <a:ea typeface="Noto Sans"/>
-                <a:cs typeface="Noto Sans"/>
-              </a:defRPr>
-            </a:lvl9pPr>
-          </a:lstStyle>
-          <a:p xmlns:a="http://schemas.openxmlformats.org/drawingml/2006/main">
-            <a:pPr>
-              <a:defRPr sz="1650" b="0">
-                <a:solidFill>
-                  <a:srgbClr val="1E5AA8"/>
-                </a:solidFill>
-                <a:latin typeface="Noto Sans"/>
-                <a:ea typeface="Noto Sans"/>
-                <a:cs typeface="Noto Sans"/>
-              </a:defRPr>
-            </a:pPr>
-            <a:r>
-              <a:rPr sz="1650" b="0">
-                <a:solidFill>
-                  <a:srgbClr val="1E5AA8"/>
-                </a:solidFill>
-                <a:latin typeface="Noto Sans"/>
-                <a:ea typeface="Noto Sans"/>
-                <a:cs typeface="Noto Sans"/>
-                <a:hlinkClick xmlns:r="http://schemas.openxmlformats.org/officeDocument/2006/relationships" r:id="R93a86cc729764983"/>
-              </a:rPr>
-              <a:t>Nielsen heuristics</a:t>
-            </a:r>
-          </a:p>
-        </p:txBody>
-      </p:sp>
-      <p:sp>
-        <p:nvSpPr>
-          <p:cNvPr id="8" name="1  Typography nhất quán">
-            <a:extLst xmlns:a="http://schemas.openxmlformats.org/drawingml/2006/main">
-              <a:ext uri="{FF2B5EF4-FFF2-40B4-BE49-F238E27FC236}">
-                <a16:creationId xmlns:a16="http://schemas.microsoft.com/office/drawing/2014/main" id="{49164CF1-491C-44BF-A29A-E518E1FD1AEA}"/>
+                <a16:creationId xmlns:a16="http://schemas.microsoft.com/office/drawing/2014/main" id="{1AF048A6-DFE2-4C3A-9785-B364CD7F285C}"/>
               </a:ext>
             </a:extLst>
           </p:cNvPr>
@@ -29713,10 +29519,10 @@
       </p:sp>
       <p:sp>
         <p:nvSpPr>
-          <p:cNvPr id="9" name="S07: serif khác brief.&#10;Sửa cấu hình font fallback.">
+          <p:cNvPr id="8" name="S07: serif khác brief.&#10;Sửa cấu hình font fallback.">
             <a:extLst xmlns:a="http://schemas.openxmlformats.org/drawingml/2006/main">
               <a:ext uri="{FF2B5EF4-FFF2-40B4-BE49-F238E27FC236}">
-                <a16:creationId xmlns:a16="http://schemas.microsoft.com/office/drawing/2014/main" id="{4472B164-CAD8-4CE1-B9C5-5462A4D6B0BD}"/>
+                <a16:creationId xmlns:a16="http://schemas.microsoft.com/office/drawing/2014/main" id="{72EECCC5-9684-4D77-8251-B674145E3A9D}"/>
               </a:ext>
             </a:extLst>
           </p:cNvPr>
@@ -29894,10 +29700,10 @@
       </p:sp>
       <p:sp>
         <p:nvSpPr>
-          <p:cNvPr id="10" name="TRƯỚC">
+          <p:cNvPr id="9" name="TRƯỚC">
             <a:extLst xmlns:a="http://schemas.openxmlformats.org/drawingml/2006/main">
               <a:ext uri="{FF2B5EF4-FFF2-40B4-BE49-F238E27FC236}">
-                <a16:creationId xmlns:a16="http://schemas.microsoft.com/office/drawing/2014/main" id="{2C5C9BF7-4E78-4BA0-8D32-645F32E530B4}"/>
+                <a16:creationId xmlns:a16="http://schemas.microsoft.com/office/drawing/2014/main" id="{CD9ED78F-D7B1-4617-9033-3DDDA32DDAC1}"/>
               </a:ext>
             </a:extLst>
           </p:cNvPr>
@@ -30052,10 +29858,10 @@
       </p:sp>
       <p:sp>
         <p:nvSpPr>
-          <p:cNvPr id="11" name="SAU">
+          <p:cNvPr id="10" name="SAU">
             <a:extLst xmlns:a="http://schemas.openxmlformats.org/drawingml/2006/main">
               <a:ext uri="{FF2B5EF4-FFF2-40B4-BE49-F238E27FC236}">
-                <a16:creationId xmlns:a16="http://schemas.microsoft.com/office/drawing/2014/main" id="{09A03C5C-AFA1-4166-99B8-20A3E6057861}"/>
+                <a16:creationId xmlns:a16="http://schemas.microsoft.com/office/drawing/2014/main" id="{A42A84A9-29FA-4722-9588-6D44E9AE3468}"/>
               </a:ext>
             </a:extLst>
           </p:cNvPr>
@@ -30210,10 +30016,10 @@
       </p:sp>
       <p:pic>
         <p:nvPicPr>
-          <p:cNvPr id="12" name="">
+          <p:cNvPr id="11" name="">
             <a:extLst xmlns:a="http://schemas.openxmlformats.org/drawingml/2006/main">
               <a:ext uri="{FF2B5EF4-FFF2-40B4-BE49-F238E27FC236}">
-                <a16:creationId xmlns:a16="http://schemas.microsoft.com/office/drawing/2014/main" id="{7159FBCA-1639-4068-9A48-21985CC6AE38}"/>
+                <a16:creationId xmlns:a16="http://schemas.microsoft.com/office/drawing/2014/main" id="{956D366F-94FB-4373-B75B-8F1DB9585D6D}"/>
               </a:ext>
             </a:extLst>
           </p:cNvPr>
@@ -30223,14 +30029,13 @@
           <p:nvPr/>
         </p:nvPicPr>
         <p:blipFill>
-          <a:blip xmlns:r="http://schemas.openxmlformats.org/officeDocument/2006/relationships" xmlns:a="http://schemas.openxmlformats.org/drawingml/2006/main" r:embed="R31129a83af5a423c"/>
-          <a:srcRect xmlns:a="http://schemas.openxmlformats.org/drawingml/2006/main" l="0" t="0" r="0" b="84000"/>
+          <a:blip xmlns:r="http://schemas.openxmlformats.org/officeDocument/2006/relationships" xmlns:a="http://schemas.openxmlformats.org/drawingml/2006/main" r:embed="Rc0b9ddc5dc1e4333"/>
           <a:stretch xmlns:a="http://schemas.openxmlformats.org/drawingml/2006/main"/>
         </p:blipFill>
         <p:spPr>
           <a:xfrm xmlns:a="http://schemas.openxmlformats.org/drawingml/2006/main">
-            <a:off x="7524750" y="3048000"/>
-            <a:ext cx="4381500" cy="1428750"/>
+            <a:off x="8166253" y="3048000"/>
+            <a:ext cx="3098494" cy="1428750"/>
           </a:xfrm>
           <a:prstGeom xmlns:a="http://schemas.openxmlformats.org/drawingml/2006/main" prst="rect">
             <a:avLst/>
@@ -30239,10 +30044,10 @@
       </p:pic>
       <p:pic>
         <p:nvPicPr>
-          <p:cNvPr id="13" name="">
+          <p:cNvPr id="12" name="">
             <a:extLst xmlns:a="http://schemas.openxmlformats.org/drawingml/2006/main">
               <a:ext uri="{FF2B5EF4-FFF2-40B4-BE49-F238E27FC236}">
-                <a16:creationId xmlns:a16="http://schemas.microsoft.com/office/drawing/2014/main" id="{41BEEADE-338D-4426-B1B4-5C950F44C9E5}"/>
+                <a16:creationId xmlns:a16="http://schemas.microsoft.com/office/drawing/2014/main" id="{68767882-EEC0-499C-A0FF-A419CA88B30A}"/>
               </a:ext>
             </a:extLst>
           </p:cNvPr>
@@ -30252,14 +30057,13 @@
           <p:nvPr/>
         </p:nvPicPr>
         <p:blipFill>
-          <a:blip xmlns:r="http://schemas.openxmlformats.org/officeDocument/2006/relationships" xmlns:a="http://schemas.openxmlformats.org/drawingml/2006/main" r:embed="R46b0652ee6cd4d0f"/>
-          <a:srcRect xmlns:a="http://schemas.openxmlformats.org/drawingml/2006/main" l="0" t="0" r="0" b="84000"/>
+          <a:blip xmlns:r="http://schemas.openxmlformats.org/officeDocument/2006/relationships" xmlns:a="http://schemas.openxmlformats.org/drawingml/2006/main" r:embed="R8c74290d42f145ca"/>
           <a:stretch xmlns:a="http://schemas.openxmlformats.org/drawingml/2006/main"/>
         </p:blipFill>
         <p:spPr>
           <a:xfrm xmlns:a="http://schemas.openxmlformats.org/drawingml/2006/main">
-            <a:off x="12382500" y="3048000"/>
-            <a:ext cx="4381500" cy="1428750"/>
+            <a:off x="13024003" y="3048000"/>
+            <a:ext cx="3098494" cy="1428750"/>
           </a:xfrm>
           <a:prstGeom xmlns:a="http://schemas.openxmlformats.org/drawingml/2006/main" prst="rect">
             <a:avLst/>
@@ -30268,10 +30072,10 @@
       </p:pic>
       <p:sp>
         <p:nvSpPr>
-          <p:cNvPr id="14" name="Kiểm chứng Chrome cục bộ">
+          <p:cNvPr id="13" name="Kiểm chứng Chrome cục bộ">
             <a:extLst xmlns:a="http://schemas.openxmlformats.org/drawingml/2006/main">
               <a:ext uri="{FF2B5EF4-FFF2-40B4-BE49-F238E27FC236}">
-                <a16:creationId xmlns:a16="http://schemas.microsoft.com/office/drawing/2014/main" id="{45DB0F15-A8C6-4E65-9169-F7CEDD8E13D0}"/>
+                <a16:creationId xmlns:a16="http://schemas.microsoft.com/office/drawing/2014/main" id="{AD6A3FB0-9317-43CB-8246-24E68C3C3886}"/>
               </a:ext>
             </a:extLst>
           </p:cNvPr>
@@ -30426,10 +30230,10 @@
       </p:sp>
       <p:sp>
         <p:nvSpPr>
-          <p:cNvPr id="15" name="2  Giảm nội dung phụ">
+          <p:cNvPr id="14" name="2  Giảm nội dung phụ">
             <a:extLst xmlns:a="http://schemas.openxmlformats.org/drawingml/2006/main">
               <a:ext uri="{FF2B5EF4-FFF2-40B4-BE49-F238E27FC236}">
-                <a16:creationId xmlns:a16="http://schemas.microsoft.com/office/drawing/2014/main" id="{893F9320-027F-4B66-8FA3-3224ECD63255}"/>
+                <a16:creationId xmlns:a16="http://schemas.microsoft.com/office/drawing/2014/main" id="{15922A55-243E-4BEB-A965-8236EECD8E36}"/>
               </a:ext>
             </a:extLst>
           </p:cNvPr>
@@ -30584,10 +30388,10 @@
       </p:sp>
       <p:sp>
         <p:nvSpPr>
-          <p:cNvPr id="16" name="S07: banner chiếm chỗ, tên bị cắt.&#10;Giữ tên và hành động chín">
+          <p:cNvPr id="15" name="S07: banner chiếm chỗ, tên bị cắt.&#10;Giữ tên và hành động chín">
             <a:extLst xmlns:a="http://schemas.openxmlformats.org/drawingml/2006/main">
               <a:ext uri="{FF2B5EF4-FFF2-40B4-BE49-F238E27FC236}">
-                <a16:creationId xmlns:a16="http://schemas.microsoft.com/office/drawing/2014/main" id="{974B7A97-4C79-4B10-A1A7-A08ED4E0C8CF}"/>
+                <a16:creationId xmlns:a16="http://schemas.microsoft.com/office/drawing/2014/main" id="{226E158B-68BE-4CCD-AD96-3AEDF59E9F4C}"/>
               </a:ext>
             </a:extLst>
           </p:cNvPr>
@@ -30765,10 +30569,10 @@
       </p:sp>
       <p:sp>
         <p:nvSpPr>
-          <p:cNvPr id="17" name="TRƯỚC">
+          <p:cNvPr id="16" name="TRƯỚC">
             <a:extLst xmlns:a="http://schemas.openxmlformats.org/drawingml/2006/main">
               <a:ext uri="{FF2B5EF4-FFF2-40B4-BE49-F238E27FC236}">
-                <a16:creationId xmlns:a16="http://schemas.microsoft.com/office/drawing/2014/main" id="{873BE9C1-63E9-46A1-9619-C699C7AE6274}"/>
+                <a16:creationId xmlns:a16="http://schemas.microsoft.com/office/drawing/2014/main" id="{30B81441-2E64-463A-942D-5FA77C86EA57}"/>
               </a:ext>
             </a:extLst>
           </p:cNvPr>
@@ -30923,10 +30727,10 @@
       </p:sp>
       <p:sp>
         <p:nvSpPr>
-          <p:cNvPr id="18" name="SAU">
+          <p:cNvPr id="17" name="SAU">
             <a:extLst xmlns:a="http://schemas.openxmlformats.org/drawingml/2006/main">
               <a:ext uri="{FF2B5EF4-FFF2-40B4-BE49-F238E27FC236}">
-                <a16:creationId xmlns:a16="http://schemas.microsoft.com/office/drawing/2014/main" id="{FA33C647-68C6-4D71-89A3-DB792B8D78FD}"/>
+                <a16:creationId xmlns:a16="http://schemas.microsoft.com/office/drawing/2014/main" id="{77D13B43-868A-4F0F-8F3E-AFA7055C66D5}"/>
               </a:ext>
             </a:extLst>
           </p:cNvPr>
@@ -31081,10 +30885,10 @@
       </p:sp>
       <p:pic>
         <p:nvPicPr>
-          <p:cNvPr id="19" name="">
+          <p:cNvPr id="18" name="">
             <a:extLst xmlns:a="http://schemas.openxmlformats.org/drawingml/2006/main">
               <a:ext uri="{FF2B5EF4-FFF2-40B4-BE49-F238E27FC236}">
-                <a16:creationId xmlns:a16="http://schemas.microsoft.com/office/drawing/2014/main" id="{5D912C03-946F-47F3-92AC-AA6139307DD3}"/>
+                <a16:creationId xmlns:a16="http://schemas.microsoft.com/office/drawing/2014/main" id="{0B4D0AE6-CA0F-4CC8-A018-6D03F9BE2264}"/>
               </a:ext>
             </a:extLst>
           </p:cNvPr>
@@ -31094,14 +30898,13 @@
           <p:nvPr/>
         </p:nvPicPr>
         <p:blipFill>
-          <a:blip xmlns:r="http://schemas.openxmlformats.org/officeDocument/2006/relationships" xmlns:a="http://schemas.openxmlformats.org/drawingml/2006/main" r:embed="Rde431408d6654639"/>
-          <a:srcRect xmlns:a="http://schemas.openxmlformats.org/drawingml/2006/main" l="0" t="18000" r="0" b="65000"/>
+          <a:blip xmlns:r="http://schemas.openxmlformats.org/officeDocument/2006/relationships" xmlns:a="http://schemas.openxmlformats.org/drawingml/2006/main" r:embed="Rc34194ea6a8e4d52"/>
           <a:stretch xmlns:a="http://schemas.openxmlformats.org/drawingml/2006/main"/>
         </p:blipFill>
         <p:spPr>
           <a:xfrm xmlns:a="http://schemas.openxmlformats.org/drawingml/2006/main">
-            <a:off x="7524750" y="5191125"/>
-            <a:ext cx="4381500" cy="1428750"/>
+            <a:off x="8262534" y="5191125"/>
+            <a:ext cx="2905932" cy="1428750"/>
           </a:xfrm>
           <a:prstGeom xmlns:a="http://schemas.openxmlformats.org/drawingml/2006/main" prst="rect">
             <a:avLst/>
@@ -31110,10 +30913,10 @@
       </p:pic>
       <p:pic>
         <p:nvPicPr>
-          <p:cNvPr id="20" name="">
+          <p:cNvPr id="19" name="">
             <a:extLst xmlns:a="http://schemas.openxmlformats.org/drawingml/2006/main">
               <a:ext uri="{FF2B5EF4-FFF2-40B4-BE49-F238E27FC236}">
-                <a16:creationId xmlns:a16="http://schemas.microsoft.com/office/drawing/2014/main" id="{6650BA58-E6D7-4A10-A9B5-DF0291F63536}"/>
+                <a16:creationId xmlns:a16="http://schemas.microsoft.com/office/drawing/2014/main" id="{D70B2DE2-B11F-44F6-AF10-BAED35518C60}"/>
               </a:ext>
             </a:extLst>
           </p:cNvPr>
@@ -31123,14 +30926,13 @@
           <p:nvPr/>
         </p:nvPicPr>
         <p:blipFill>
-          <a:blip xmlns:r="http://schemas.openxmlformats.org/officeDocument/2006/relationships" xmlns:a="http://schemas.openxmlformats.org/drawingml/2006/main" r:embed="R7d88219692fc494b"/>
-          <a:srcRect xmlns:a="http://schemas.openxmlformats.org/drawingml/2006/main" l="0" t="9500" r="0" b="72000"/>
+          <a:blip xmlns:r="http://schemas.openxmlformats.org/officeDocument/2006/relationships" xmlns:a="http://schemas.openxmlformats.org/drawingml/2006/main" r:embed="R7663c7d0220f4fbf"/>
           <a:stretch xmlns:a="http://schemas.openxmlformats.org/drawingml/2006/main"/>
         </p:blipFill>
         <p:spPr>
           <a:xfrm xmlns:a="http://schemas.openxmlformats.org/drawingml/2006/main">
-            <a:off x="12382500" y="5191125"/>
-            <a:ext cx="4381500" cy="1428750"/>
+            <a:off x="12869369" y="5191125"/>
+            <a:ext cx="3407762" cy="1428750"/>
           </a:xfrm>
           <a:prstGeom xmlns:a="http://schemas.openxmlformats.org/drawingml/2006/main" prst="rect">
             <a:avLst/>
@@ -31139,10 +30941,10 @@
       </p:pic>
       <p:sp>
         <p:nvSpPr>
-          <p:cNvPr id="21" name="Trước OI01 / Sau Stitch OI02">
+          <p:cNvPr id="20" name="Trước OI01 / Sau Stitch OI02">
             <a:extLst xmlns:a="http://schemas.openxmlformats.org/drawingml/2006/main">
               <a:ext uri="{FF2B5EF4-FFF2-40B4-BE49-F238E27FC236}">
-                <a16:creationId xmlns:a16="http://schemas.microsoft.com/office/drawing/2014/main" id="{A483E2BA-5381-4029-BCE5-B9A6516E4931}"/>
+                <a16:creationId xmlns:a16="http://schemas.microsoft.com/office/drawing/2014/main" id="{B9307AB7-DD37-494D-A7B7-A921D854371E}"/>
               </a:ext>
             </a:extLst>
           </p:cNvPr>
@@ -31297,10 +31099,10 @@
       </p:sp>
       <p:sp>
         <p:nvSpPr>
-          <p:cNvPr id="22" name="3  Giữ ngữ cảnh khi lỗi">
+          <p:cNvPr id="21" name="3  Giữ ngữ cảnh khi lỗi">
             <a:extLst xmlns:a="http://schemas.openxmlformats.org/drawingml/2006/main">
               <a:ext uri="{FF2B5EF4-FFF2-40B4-BE49-F238E27FC236}">
-                <a16:creationId xmlns:a16="http://schemas.microsoft.com/office/drawing/2014/main" id="{9BFA3F4C-4D12-4850-9888-255487752126}"/>
+                <a16:creationId xmlns:a16="http://schemas.microsoft.com/office/drawing/2014/main" id="{D7B4883A-A052-4A27-B37F-FFC95CDD0A0F}"/>
               </a:ext>
             </a:extLst>
           </p:cNvPr>
@@ -31455,10 +31257,10 @@
       </p:sp>
       <p:sp>
         <p:nvSpPr>
-          <p:cNvPr id="23" name="S07: state lỗi đổi hoạt động.&#10;Chuẩn hóa dữ liệu và nối Retry">
+          <p:cNvPr id="22" name="S07: state lỗi đổi hoạt động.&#10;Chuẩn hóa dữ liệu và nối Retry">
             <a:extLst xmlns:a="http://schemas.openxmlformats.org/drawingml/2006/main">
               <a:ext uri="{FF2B5EF4-FFF2-40B4-BE49-F238E27FC236}">
-                <a16:creationId xmlns:a16="http://schemas.microsoft.com/office/drawing/2014/main" id="{9CE52196-9A3F-4BFD-954C-910F1B82536F}"/>
+                <a16:creationId xmlns:a16="http://schemas.microsoft.com/office/drawing/2014/main" id="{3597CD85-5B9E-4CA7-90AE-2A4B493F29F0}"/>
               </a:ext>
             </a:extLst>
           </p:cNvPr>
@@ -31636,10 +31438,10 @@
       </p:sp>
       <p:sp>
         <p:nvSpPr>
-          <p:cNvPr id="24" name="TRƯỚC">
+          <p:cNvPr id="23" name="TRƯỚC">
             <a:extLst xmlns:a="http://schemas.openxmlformats.org/drawingml/2006/main">
               <a:ext uri="{FF2B5EF4-FFF2-40B4-BE49-F238E27FC236}">
-                <a16:creationId xmlns:a16="http://schemas.microsoft.com/office/drawing/2014/main" id="{8CE5C2BB-4ED2-45F9-B20E-827CF04FD51A}"/>
+                <a16:creationId xmlns:a16="http://schemas.microsoft.com/office/drawing/2014/main" id="{981F270E-A9FA-4141-84EB-5EA2F3DC7268}"/>
               </a:ext>
             </a:extLst>
           </p:cNvPr>
@@ -31794,10 +31596,10 @@
       </p:sp>
       <p:sp>
         <p:nvSpPr>
-          <p:cNvPr id="25" name="SAU">
+          <p:cNvPr id="24" name="SAU">
             <a:extLst xmlns:a="http://schemas.openxmlformats.org/drawingml/2006/main">
               <a:ext uri="{FF2B5EF4-FFF2-40B4-BE49-F238E27FC236}">
-                <a16:creationId xmlns:a16="http://schemas.microsoft.com/office/drawing/2014/main" id="{2BA3834D-DCF6-4B31-91EC-014F8C64E657}"/>
+                <a16:creationId xmlns:a16="http://schemas.microsoft.com/office/drawing/2014/main" id="{8E95DF54-6F98-48EE-8BD4-57C50B1E5E51}"/>
               </a:ext>
             </a:extLst>
           </p:cNvPr>
@@ -31952,10 +31754,10 @@
       </p:sp>
       <p:pic>
         <p:nvPicPr>
-          <p:cNvPr id="26" name="">
+          <p:cNvPr id="25" name="">
             <a:extLst xmlns:a="http://schemas.openxmlformats.org/drawingml/2006/main">
               <a:ext uri="{FF2B5EF4-FFF2-40B4-BE49-F238E27FC236}">
-                <a16:creationId xmlns:a16="http://schemas.microsoft.com/office/drawing/2014/main" id="{58FB5EE5-D4ED-4D65-8C3D-F37EDCFDAA6B}"/>
+                <a16:creationId xmlns:a16="http://schemas.microsoft.com/office/drawing/2014/main" id="{AD6E2EA9-622D-409E-B645-7170A0095F80}"/>
               </a:ext>
             </a:extLst>
           </p:cNvPr>
@@ -31965,14 +31767,13 @@
           <p:nvPr/>
         </p:nvPicPr>
         <p:blipFill>
-          <a:blip xmlns:r="http://schemas.openxmlformats.org/officeDocument/2006/relationships" xmlns:a="http://schemas.openxmlformats.org/drawingml/2006/main" r:embed="Ra7100cd4be6445fa"/>
-          <a:srcRect xmlns:a="http://schemas.openxmlformats.org/drawingml/2006/main" l="0" t="21000" r="0" b="65000"/>
+          <a:blip xmlns:r="http://schemas.openxmlformats.org/officeDocument/2006/relationships" xmlns:a="http://schemas.openxmlformats.org/drawingml/2006/main" r:embed="Re45896490bd9437c"/>
           <a:stretch xmlns:a="http://schemas.openxmlformats.org/drawingml/2006/main"/>
         </p:blipFill>
         <p:spPr>
           <a:xfrm xmlns:a="http://schemas.openxmlformats.org/drawingml/2006/main">
-            <a:off x="7524750" y="7334250"/>
-            <a:ext cx="4381500" cy="1428750"/>
+            <a:off x="8037994" y="7334250"/>
+            <a:ext cx="3355011" cy="1428750"/>
           </a:xfrm>
           <a:prstGeom xmlns:a="http://schemas.openxmlformats.org/drawingml/2006/main" prst="rect">
             <a:avLst/>
@@ -31981,10 +31782,10 @@
       </p:pic>
       <p:pic>
         <p:nvPicPr>
-          <p:cNvPr id="27" name="">
+          <p:cNvPr id="26" name="">
             <a:extLst xmlns:a="http://schemas.openxmlformats.org/drawingml/2006/main">
               <a:ext uri="{FF2B5EF4-FFF2-40B4-BE49-F238E27FC236}">
-                <a16:creationId xmlns:a16="http://schemas.microsoft.com/office/drawing/2014/main" id="{CD15B7D0-ED90-4CF3-B8BF-C22DD656B8B3}"/>
+                <a16:creationId xmlns:a16="http://schemas.microsoft.com/office/drawing/2014/main" id="{7C0621B2-E6CA-4850-BB51-AADCAA46A4DF}"/>
               </a:ext>
             </a:extLst>
           </p:cNvPr>
@@ -31994,14 +31795,13 @@
           <p:nvPr/>
         </p:nvPicPr>
         <p:blipFill>
-          <a:blip xmlns:r="http://schemas.openxmlformats.org/officeDocument/2006/relationships" xmlns:a="http://schemas.openxmlformats.org/drawingml/2006/main" r:embed="Ra30bf0df49934615"/>
-          <a:srcRect xmlns:a="http://schemas.openxmlformats.org/drawingml/2006/main" l="0" t="6000" r="0" b="69000"/>
+          <a:blip xmlns:r="http://schemas.openxmlformats.org/officeDocument/2006/relationships" xmlns:a="http://schemas.openxmlformats.org/drawingml/2006/main" r:embed="Rdb34da9d66cc403a"/>
           <a:stretch xmlns:a="http://schemas.openxmlformats.org/drawingml/2006/main"/>
         </p:blipFill>
         <p:spPr>
           <a:xfrm xmlns:a="http://schemas.openxmlformats.org/drawingml/2006/main">
-            <a:off x="12382500" y="7334250"/>
-            <a:ext cx="4381500" cy="1428750"/>
+            <a:off x="13287375" y="7334250"/>
+            <a:ext cx="2571750" cy="1428750"/>
           </a:xfrm>
           <a:prstGeom xmlns:a="http://schemas.openxmlformats.org/drawingml/2006/main" prst="rect">
             <a:avLst/>
@@ -32010,10 +31810,10 @@
       </p:pic>
       <p:sp>
         <p:nvSpPr>
-          <p:cNvPr id="28" name="Trước Stitch OI03 / Sau Figma">
+          <p:cNvPr id="27" name="Trước Stitch OI03 / Sau Figma">
             <a:extLst xmlns:a="http://schemas.openxmlformats.org/drawingml/2006/main">
               <a:ext uri="{FF2B5EF4-FFF2-40B4-BE49-F238E27FC236}">
-                <a16:creationId xmlns:a16="http://schemas.microsoft.com/office/drawing/2014/main" id="{D84658CC-92AA-480A-8A98-35A720E515F1}"/>
+                <a16:creationId xmlns:a16="http://schemas.microsoft.com/office/drawing/2014/main" id="{7AA11F84-427D-4D44-9993-0AA64ECB5529}"/>
               </a:ext>
             </a:extLst>
           </p:cNvPr>
@@ -32169,7 +31969,7 @@
     </p:spTree>
     <p:extLst>
       <p:ext uri="{BB962C8B-B14F-4D97-AF65-F5344CB8AC3E}">
-        <p14:creationId xmlns:p14="http://schemas.microsoft.com/office/powerpoint/2010/main" val="1521771883"/>
+        <p14:creationId xmlns:p14="http://schemas.microsoft.com/office/powerpoint/2010/main" val="940768881"/>
       </p:ext>
     </p:extLst>
   </p:cSld>
@@ -32200,7 +32000,7 @@
           <p:cNvPr id="10" name="Phản biện UX và quyết định thiết kế">
             <a:extLst xmlns:a="http://schemas.openxmlformats.org/drawingml/2006/main">
               <a:ext uri="{FF2B5EF4-FFF2-40B4-BE49-F238E27FC236}">
-                <a16:creationId xmlns:a16="http://schemas.microsoft.com/office/drawing/2014/main" id="{B0516B74-CA80-45C5-B86D-FFFAD04439C1}"/>
+                <a16:creationId xmlns:a16="http://schemas.microsoft.com/office/drawing/2014/main" id="{09F052A7-17AA-46D9-9FC9-6FEEF303E3ED}"/>
               </a:ext>
             </a:extLst>
           </p:cNvPr>
@@ -32358,7 +32158,7 @@
           <p:cNvPr id="2" name="Năm phát hiện gắn với màn cụ thể; quyết định cuối phản ánh t">
             <a:extLst xmlns:a="http://schemas.openxmlformats.org/drawingml/2006/main">
               <a:ext uri="{FF2B5EF4-FFF2-40B4-BE49-F238E27FC236}">
-                <a16:creationId xmlns:a16="http://schemas.microsoft.com/office/drawing/2014/main" id="{C33AF95A-2575-4576-9F22-E4A935A6FCE4}"/>
+                <a16:creationId xmlns:a16="http://schemas.microsoft.com/office/drawing/2014/main" id="{FB9DAF09-C9D0-4E94-80D1-0E0BFA716A14}"/>
               </a:ext>
             </a:extLst>
           </p:cNvPr>
@@ -32516,7 +32316,7 @@
           <p:cNvPr id="3" name="07 / 12">
             <a:extLst xmlns:a="http://schemas.openxmlformats.org/drawingml/2006/main">
               <a:ext uri="{FF2B5EF4-FFF2-40B4-BE49-F238E27FC236}">
-                <a16:creationId xmlns:a16="http://schemas.microsoft.com/office/drawing/2014/main" id="{4E9289DE-5625-419D-95F3-419153D0AF88}"/>
+                <a16:creationId xmlns:a16="http://schemas.microsoft.com/office/drawing/2014/main" id="{0C318C51-F2F9-42B1-AE43-BA9B06EA8769}"/>
               </a:ext>
             </a:extLst>
           </p:cNvPr>
@@ -32674,7 +32474,7 @@
           <p:cNvPr id="4" name="Nguồn">
             <a:extLst xmlns:a="http://schemas.openxmlformats.org/drawingml/2006/main">
               <a:ext uri="{FF2B5EF4-FFF2-40B4-BE49-F238E27FC236}">
-                <a16:creationId xmlns:a16="http://schemas.microsoft.com/office/drawing/2014/main" id="{F8766E59-B296-4017-8630-9F8819023E8A}"/>
+                <a16:creationId xmlns:a16="http://schemas.microsoft.com/office/drawing/2014/main" id="{7369D591-852C-43E6-B6CE-36ADFB7FB6C8}"/>
               </a:ext>
             </a:extLst>
           </p:cNvPr>
@@ -32832,7 +32632,7 @@
           <p:cNvPr id="5" name="Quyết định và lý do">
             <a:extLst xmlns:a="http://schemas.openxmlformats.org/drawingml/2006/main">
               <a:ext uri="{FF2B5EF4-FFF2-40B4-BE49-F238E27FC236}">
-                <a16:creationId xmlns:a16="http://schemas.microsoft.com/office/drawing/2014/main" id="{A115C68B-ACE2-4171-9D01-47C3EC020B1F}"/>
+                <a16:creationId xmlns:a16="http://schemas.microsoft.com/office/drawing/2014/main" id="{ED859C83-6F14-464B-98E3-D1F37F3A6756}"/>
               </a:ext>
             </a:extLst>
           </p:cNvPr>
@@ -32979,7 +32779,7 @@
                 <a:latin typeface="Noto Sans"/>
                 <a:ea typeface="Noto Sans"/>
                 <a:cs typeface="Noto Sans"/>
-                <a:hlinkClick xmlns:r="http://schemas.openxmlformats.org/officeDocument/2006/relationships" r:id="Rf465a266a7644e1b"/>
+                <a:hlinkClick xmlns:r="http://schemas.openxmlformats.org/officeDocument/2006/relationships" r:id="R561e356056d84508"/>
               </a:rPr>
               <a:t>Quyết định và lý do</a:t>
             </a:r>
@@ -32991,7 +32791,7 @@
           <p:cNvPr id="6" name="Review trạng thái OI03">
             <a:extLst xmlns:a="http://schemas.openxmlformats.org/drawingml/2006/main">
               <a:ext uri="{FF2B5EF4-FFF2-40B4-BE49-F238E27FC236}">
-                <a16:creationId xmlns:a16="http://schemas.microsoft.com/office/drawing/2014/main" id="{ADC2D82D-58A1-45E9-B35D-053ECD5A265A}"/>
+                <a16:creationId xmlns:a16="http://schemas.microsoft.com/office/drawing/2014/main" id="{7C27936B-BADD-43AD-8F34-269FC55DB5BF}"/>
               </a:ext>
             </a:extLst>
           </p:cNvPr>
@@ -33138,7 +32938,7 @@
                 <a:latin typeface="Noto Sans"/>
                 <a:ea typeface="Noto Sans"/>
                 <a:cs typeface="Noto Sans"/>
-                <a:hlinkClick xmlns:r="http://schemas.openxmlformats.org/officeDocument/2006/relationships" r:id="R125fe4cf1602437d"/>
+                <a:hlinkClick xmlns:r="http://schemas.openxmlformats.org/officeDocument/2006/relationships" r:id="R85131df2203d44f9"/>
               </a:rPr>
               <a:t>Review trạng thái OI03</a:t>
             </a:r>
@@ -33150,7 +32950,7 @@
           <p:cNvPr id="7" name="Figma UI hiện hành">
             <a:extLst xmlns:a="http://schemas.openxmlformats.org/drawingml/2006/main">
               <a:ext uri="{FF2B5EF4-FFF2-40B4-BE49-F238E27FC236}">
-                <a16:creationId xmlns:a16="http://schemas.microsoft.com/office/drawing/2014/main" id="{1EA3625B-43AF-4208-9277-550D9D320496}"/>
+                <a16:creationId xmlns:a16="http://schemas.microsoft.com/office/drawing/2014/main" id="{EDA2E4E5-DC09-4B54-A4AD-B9368083810F}"/>
               </a:ext>
             </a:extLst>
           </p:cNvPr>
@@ -33297,7 +33097,7 @@
                 <a:latin typeface="Noto Sans"/>
                 <a:ea typeface="Noto Sans"/>
                 <a:cs typeface="Noto Sans"/>
-                <a:hlinkClick xmlns:r="http://schemas.openxmlformats.org/officeDocument/2006/relationships" r:id="Rac60b261a8c64ec7"/>
+                <a:hlinkClick xmlns:r="http://schemas.openxmlformats.org/officeDocument/2006/relationships" r:id="R6acbec2e74874ee9"/>
               </a:rPr>
               <a:t>Figma UI hiện hành</a:t>
             </a:r>
@@ -33309,7 +33109,7 @@
           <p:cNvPr id="8" name="">
             <a:extLst xmlns:a="http://schemas.openxmlformats.org/drawingml/2006/main">
               <a:ext uri="{FF2B5EF4-FFF2-40B4-BE49-F238E27FC236}">
-                <a16:creationId xmlns:a16="http://schemas.microsoft.com/office/drawing/2014/main" id="{82F8A403-790A-4D18-A24B-5A5EC84CBC9B}"/>
+                <a16:creationId xmlns:a16="http://schemas.microsoft.com/office/drawing/2014/main" id="{610AED85-6921-4965-842B-D2375CFDD0D4}"/>
               </a:ext>
             </a:extLst>
           </p:cNvPr>
@@ -33599,7 +33399,7 @@
                           <a:ea typeface="Noto Sans"/>
                           <a:cs typeface="Noto Sans"/>
                         </a:rPr>
-                        <a:t>Consistency and standards</a:t>
+                        <a:t>Nielsen 4: tính nhất quán</a:t>
                       </a:r>
                     </a:p>
                   </a:txBody>
@@ -33635,7 +33435,7 @@
                           <a:ea typeface="Noto Sans"/>
                           <a:cs typeface="Noto Sans"/>
                         </a:rPr>
-                        <a:t>Be Vietnam Pro; hỗ trợ tiếng Việt</a:t>
+                        <a:t>Be Vietnam Pro, đúng brief</a:t>
                       </a:r>
                     </a:p>
                   </a:txBody>
@@ -33751,7 +33551,7 @@
                           <a:ea typeface="Noto Sans"/>
                           <a:cs typeface="Noto Sans"/>
                         </a:rPr>
-                        <a:t>Aesthetic and minimalist design</a:t>
+                        <a:t>Mai cần chọn việc trong giờ nghỉ</a:t>
                       </a:r>
                     </a:p>
                   </a:txBody>
@@ -33787,7 +33587,7 @@
                           <a:ea typeface="Noto Sans"/>
                           <a:cs typeface="Noto Sans"/>
                         </a:rPr>
-                        <a:t>Giữ hoạt động, ngày giờ và CTA</a:t>
+                        <a:t>Tên đầy đủ, CTA rõ hơn</a:t>
                       </a:r>
                     </a:p>
                   </a:txBody>
@@ -33903,7 +33703,7 @@
                           <a:ea typeface="Noto Sans"/>
                           <a:cs typeface="Noto Sans"/>
                         </a:rPr>
-                        <a:t>Status và recovery</a:t>
+                        <a:t>Linh bị ngắt quãng, cần giữ lịch</a:t>
                       </a:r>
                     </a:p>
                   </a:txBody>
@@ -33939,7 +33739,7 @@
                           <a:ea typeface="Noto Sans"/>
                           <a:cs typeface="Noto Sans"/>
                         </a:rPr>
-                        <a:t>Lỗi giữ form; Retry có kết thúc</a:t>
+                        <a:t>Giữ tên/ngày/giờ; có Thử lại</a:t>
                       </a:r>
                     </a:p>
                   </a:txBody>
@@ -34129,7 +33929,7 @@
                           <a:ea typeface="Noto Sans"/>
                           <a:cs typeface="Noto Sans"/>
                         </a:rPr>
-                        <a:t>S05: chỉ 07 bung danh sách</a:t>
+                        <a:t>S05: nhóm thiếu mở/đóng</a:t>
                       </a:r>
                     </a:p>
                   </a:txBody>
@@ -34207,7 +34007,7 @@
                           <a:ea typeface="Noto Sans"/>
                           <a:cs typeface="Noto Sans"/>
                         </a:rPr>
-                        <a:t>Consistency; user control</a:t>
+                        <a:t>Nielsen 3/4: kiểm soát, nhất quán</a:t>
                       </a:r>
                     </a:p>
                   </a:txBody>
@@ -34243,7 +34043,7 @@
                           <a:ea typeface="Noto Sans"/>
                           <a:cs typeface="Noto Sans"/>
                         </a:rPr>
-                        <a:t>9 nhóm mở/đóng; thẻ đúng chi tiết</a:t>
+                        <a:t>Cả 9 nhóm mở/đóng được</a:t>
                       </a:r>
                     </a:p>
                   </a:txBody>
@@ -34275,7 +34075,7 @@
           <p:cNvPr id="9" name="Nguồn AI là đầu vào để đánh giá; dữ liệu và quyết định cần n">
             <a:extLst xmlns:a="http://schemas.openxmlformats.org/drawingml/2006/main">
               <a:ext uri="{FF2B5EF4-FFF2-40B4-BE49-F238E27FC236}">
-                <a16:creationId xmlns:a16="http://schemas.microsoft.com/office/drawing/2014/main" id="{A85B12E6-C442-4377-BB6F-08D166BBE0AA}"/>
+                <a16:creationId xmlns:a16="http://schemas.microsoft.com/office/drawing/2014/main" id="{A0DD8D27-C00C-46F7-AE37-F69B008F6ADA}"/>
               </a:ext>
             </a:extLst>
           </p:cNvPr>
@@ -34431,7 +34231,7 @@
     </p:spTree>
     <p:extLst>
       <p:ext uri="{BB962C8B-B14F-4D97-AF65-F5344CB8AC3E}">
-        <p14:creationId xmlns:p14="http://schemas.microsoft.com/office/powerpoint/2010/main" val="1901897077"/>
+        <p14:creationId xmlns:p14="http://schemas.microsoft.com/office/powerpoint/2010/main" val="156883169"/>
       </p:ext>
     </p:extLst>
   </p:cSld>
@@ -34462,7 +34262,7 @@
           <p:cNvPr id="14" name="Wireframe và bộ UI hoàn chỉnh">
             <a:extLst xmlns:a="http://schemas.openxmlformats.org/drawingml/2006/main">
               <a:ext uri="{FF2B5EF4-FFF2-40B4-BE49-F238E27FC236}">
-                <a16:creationId xmlns:a16="http://schemas.microsoft.com/office/drawing/2014/main" id="{E4915FF5-DD78-4CFE-8E14-6538BFEF8FEE}"/>
+                <a16:creationId xmlns:a16="http://schemas.microsoft.com/office/drawing/2014/main" id="{CF239CEB-4EF2-4DEB-915E-16A2935CEF30}"/>
               </a:ext>
             </a:extLst>
           </p:cNvPr>
@@ -34620,7 +34420,7 @@
           <p:cNvPr id="2" name="Giữ cấu trúc nhiệm vụ; thêm phân cấp, màu, component và các ">
             <a:extLst xmlns:a="http://schemas.openxmlformats.org/drawingml/2006/main">
               <a:ext uri="{FF2B5EF4-FFF2-40B4-BE49-F238E27FC236}">
-                <a16:creationId xmlns:a16="http://schemas.microsoft.com/office/drawing/2014/main" id="{9598492D-F263-4C70-A86F-17E37144A6A9}"/>
+                <a16:creationId xmlns:a16="http://schemas.microsoft.com/office/drawing/2014/main" id="{672AE084-C739-463F-B22D-8CD9828CC472}"/>
               </a:ext>
             </a:extLst>
           </p:cNvPr>
@@ -34778,7 +34578,7 @@
           <p:cNvPr id="3" name="08 / 12">
             <a:extLst xmlns:a="http://schemas.openxmlformats.org/drawingml/2006/main">
               <a:ext uri="{FF2B5EF4-FFF2-40B4-BE49-F238E27FC236}">
-                <a16:creationId xmlns:a16="http://schemas.microsoft.com/office/drawing/2014/main" id="{6C8ACF87-D03A-4C88-9F5B-CE9EA565EAA9}"/>
+                <a16:creationId xmlns:a16="http://schemas.microsoft.com/office/drawing/2014/main" id="{65761BE5-8AB9-4D25-A063-790A920EDCD1}"/>
               </a:ext>
             </a:extLst>
           </p:cNvPr>
@@ -34936,7 +34736,7 @@
           <p:cNvPr id="4" name="Nguồn">
             <a:extLst xmlns:a="http://schemas.openxmlformats.org/drawingml/2006/main">
               <a:ext uri="{FF2B5EF4-FFF2-40B4-BE49-F238E27FC236}">
-                <a16:creationId xmlns:a16="http://schemas.microsoft.com/office/drawing/2014/main" id="{4264DEF7-E821-4623-B6BF-5E8C9CFDCA70}"/>
+                <a16:creationId xmlns:a16="http://schemas.microsoft.com/office/drawing/2014/main" id="{180A6B0E-3B0B-4423-9E1B-F1D0E6E6E045}"/>
               </a:ext>
             </a:extLst>
           </p:cNvPr>
@@ -35094,7 +34894,7 @@
           <p:cNvPr id="5" name="Wireframe nguồn Stitch S07">
             <a:extLst xmlns:a="http://schemas.openxmlformats.org/drawingml/2006/main">
               <a:ext uri="{FF2B5EF4-FFF2-40B4-BE49-F238E27FC236}">
-                <a16:creationId xmlns:a16="http://schemas.microsoft.com/office/drawing/2014/main" id="{66F9E5EA-92CE-469E-89B3-B16391B3E0E1}"/>
+                <a16:creationId xmlns:a16="http://schemas.microsoft.com/office/drawing/2014/main" id="{92049939-2A72-4441-B66D-C2393700F7D9}"/>
               </a:ext>
             </a:extLst>
           </p:cNvPr>
@@ -35241,7 +35041,7 @@
                 <a:latin typeface="Noto Sans"/>
                 <a:ea typeface="Noto Sans"/>
                 <a:cs typeface="Noto Sans"/>
-                <a:hlinkClick xmlns:r="http://schemas.openxmlformats.org/officeDocument/2006/relationships" r:id="Rf1332bddf7344e55"/>
+                <a:hlinkClick xmlns:r="http://schemas.openxmlformats.org/officeDocument/2006/relationships" r:id="R1af4d176fa0d4a5a"/>
               </a:rPr>
               <a:t>Wireframe nguồn Stitch S07</a:t>
             </a:r>
@@ -35253,7 +35053,7 @@
           <p:cNvPr id="6" name="Figma 03 Final UI">
             <a:extLst xmlns:a="http://schemas.openxmlformats.org/drawingml/2006/main">
               <a:ext uri="{FF2B5EF4-FFF2-40B4-BE49-F238E27FC236}">
-                <a16:creationId xmlns:a16="http://schemas.microsoft.com/office/drawing/2014/main" id="{ACFCFF31-835D-4966-8F24-4895AB384BCC}"/>
+                <a16:creationId xmlns:a16="http://schemas.microsoft.com/office/drawing/2014/main" id="{D26F2943-4183-4284-B5CB-AFC95945EB34}"/>
               </a:ext>
             </a:extLst>
           </p:cNvPr>
@@ -35400,7 +35200,7 @@
                 <a:latin typeface="Noto Sans"/>
                 <a:ea typeface="Noto Sans"/>
                 <a:cs typeface="Noto Sans"/>
-                <a:hlinkClick xmlns:r="http://schemas.openxmlformats.org/officeDocument/2006/relationships" r:id="R30d46a67782d4157"/>
+                <a:hlinkClick xmlns:r="http://schemas.openxmlformats.org/officeDocument/2006/relationships" r:id="R1b7cc5d5e4e8494b"/>
               </a:rPr>
               <a:t>Figma 03 Final UI</a:t>
             </a:r>
@@ -35412,7 +35212,7 @@
           <p:cNvPr id="7" name="Nguồn ảnh và node">
             <a:extLst xmlns:a="http://schemas.openxmlformats.org/drawingml/2006/main">
               <a:ext uri="{FF2B5EF4-FFF2-40B4-BE49-F238E27FC236}">
-                <a16:creationId xmlns:a16="http://schemas.microsoft.com/office/drawing/2014/main" id="{60F24EC7-B93A-44FC-924A-7E17ACD71C7F}"/>
+                <a16:creationId xmlns:a16="http://schemas.microsoft.com/office/drawing/2014/main" id="{44C14C34-A9FD-4587-97DD-355F4751DAB3}"/>
               </a:ext>
             </a:extLst>
           </p:cNvPr>
@@ -35559,7 +35359,7 @@
                 <a:latin typeface="Noto Sans"/>
                 <a:ea typeface="Noto Sans"/>
                 <a:cs typeface="Noto Sans"/>
-                <a:hlinkClick xmlns:r="http://schemas.openxmlformats.org/officeDocument/2006/relationships" r:id="Rcea4fdc604864465"/>
+                <a:hlinkClick xmlns:r="http://schemas.openxmlformats.org/officeDocument/2006/relationships" r:id="R56c71a7eec924538"/>
               </a:rPr>
               <a:t>Nguồn ảnh và node</a:t>
             </a:r>
@@ -35571,7 +35371,7 @@
           <p:cNvPr id="8" name="Wireframe S07">
             <a:extLst xmlns:a="http://schemas.openxmlformats.org/drawingml/2006/main">
               <a:ext uri="{FF2B5EF4-FFF2-40B4-BE49-F238E27FC236}">
-                <a16:creationId xmlns:a16="http://schemas.microsoft.com/office/drawing/2014/main" id="{0BA8EBD0-A1F0-47FE-99DF-C50DDFE33779}"/>
+                <a16:creationId xmlns:a16="http://schemas.microsoft.com/office/drawing/2014/main" id="{741647B7-8C09-41E6-B097-DD66B2250CFC}"/>
               </a:ext>
             </a:extLst>
           </p:cNvPr>
@@ -35729,7 +35529,7 @@
           <p:cNvPr id="9" name="Figma S07">
             <a:extLst xmlns:a="http://schemas.openxmlformats.org/drawingml/2006/main">
               <a:ext uri="{FF2B5EF4-FFF2-40B4-BE49-F238E27FC236}">
-                <a16:creationId xmlns:a16="http://schemas.microsoft.com/office/drawing/2014/main" id="{69F97AB0-D29A-45A7-8ADC-3FEA1AA41833}"/>
+                <a16:creationId xmlns:a16="http://schemas.microsoft.com/office/drawing/2014/main" id="{EAE2E6AE-6214-47F1-86B3-8CC1D69007F6}"/>
               </a:ext>
             </a:extLst>
           </p:cNvPr>
@@ -35887,7 +35687,7 @@
           <p:cNvPr id="10" name="">
             <a:extLst xmlns:a="http://schemas.openxmlformats.org/drawingml/2006/main">
               <a:ext uri="{FF2B5EF4-FFF2-40B4-BE49-F238E27FC236}">
-                <a16:creationId xmlns:a16="http://schemas.microsoft.com/office/drawing/2014/main" id="{FF4A82D3-9566-4410-A2AD-BBBA4E4E1CEE}"/>
+                <a16:creationId xmlns:a16="http://schemas.microsoft.com/office/drawing/2014/main" id="{8E84CC1C-3767-49D9-A124-684854EF09FF}"/>
               </a:ext>
             </a:extLst>
           </p:cNvPr>
@@ -35897,7 +35697,7 @@
           <p:nvPr/>
         </p:nvPicPr>
         <p:blipFill>
-          <a:blip xmlns:r="http://schemas.openxmlformats.org/officeDocument/2006/relationships" xmlns:a="http://schemas.openxmlformats.org/drawingml/2006/main" r:embed="R01367a1a81714307"/>
+          <a:blip xmlns:r="http://schemas.openxmlformats.org/officeDocument/2006/relationships" xmlns:a="http://schemas.openxmlformats.org/drawingml/2006/main" r:embed="Rcf0b05b4106544a3"/>
           <a:stretch xmlns:a="http://schemas.openxmlformats.org/drawingml/2006/main"/>
         </p:blipFill>
         <p:spPr>
@@ -35915,7 +35715,7 @@
           <p:cNvPr id="11" name="">
             <a:extLst xmlns:a="http://schemas.openxmlformats.org/drawingml/2006/main">
               <a:ext uri="{FF2B5EF4-FFF2-40B4-BE49-F238E27FC236}">
-                <a16:creationId xmlns:a16="http://schemas.microsoft.com/office/drawing/2014/main" id="{07F494F2-6D7A-4D6F-A420-084FE8C816BF}"/>
+                <a16:creationId xmlns:a16="http://schemas.microsoft.com/office/drawing/2014/main" id="{24DF77FE-C47B-412F-A0AD-3DADCDF2E5D8}"/>
               </a:ext>
             </a:extLst>
           </p:cNvPr>
@@ -35925,7 +35725,7 @@
           <p:nvPr/>
         </p:nvPicPr>
         <p:blipFill>
-          <a:blip xmlns:r="http://schemas.openxmlformats.org/officeDocument/2006/relationships" xmlns:a="http://schemas.openxmlformats.org/drawingml/2006/main" r:embed="Rf5f76339b8c341f1"/>
+          <a:blip xmlns:r="http://schemas.openxmlformats.org/officeDocument/2006/relationships" xmlns:a="http://schemas.openxmlformats.org/drawingml/2006/main" r:embed="Rc0e828eb27f54e81"/>
           <a:stretch xmlns:a="http://schemas.openxmlformats.org/drawingml/2006/main"/>
         </p:blipFill>
         <p:spPr>
@@ -35943,7 +35743,7 @@
           <p:cNvPr id="12" name="">
             <a:extLst xmlns:a="http://schemas.openxmlformats.org/drawingml/2006/main">
               <a:ext uri="{FF2B5EF4-FFF2-40B4-BE49-F238E27FC236}">
-                <a16:creationId xmlns:a16="http://schemas.microsoft.com/office/drawing/2014/main" id="{6D5771FD-AD7A-483D-B75B-F63D764248CE}"/>
+                <a16:creationId xmlns:a16="http://schemas.microsoft.com/office/drawing/2014/main" id="{4C6CA0A0-BFE4-489F-81A0-703BDD5C79DE}"/>
               </a:ext>
             </a:extLst>
           </p:cNvPr>
@@ -35953,7 +35753,7 @@
           <p:nvPr/>
         </p:nvPicPr>
         <p:blipFill>
-          <a:blip xmlns:r="http://schemas.openxmlformats.org/officeDocument/2006/relationships" xmlns:a="http://schemas.openxmlformats.org/drawingml/2006/main" r:embed="Rc8bbce92146c4d73"/>
+          <a:blip xmlns:r="http://schemas.openxmlformats.org/officeDocument/2006/relationships" xmlns:a="http://schemas.openxmlformats.org/drawingml/2006/main" r:embed="R2df4d67f6d1f44a0"/>
           <a:stretch xmlns:a="http://schemas.openxmlformats.org/drawingml/2006/main"/>
         </p:blipFill>
         <p:spPr>
@@ -35971,7 +35771,7 @@
           <p:cNvPr id="13" name="10 màn chức năng trên page 03">
             <a:extLst xmlns:a="http://schemas.openxmlformats.org/drawingml/2006/main">
               <a:ext uri="{FF2B5EF4-FFF2-40B4-BE49-F238E27FC236}">
-                <a16:creationId xmlns:a16="http://schemas.microsoft.com/office/drawing/2014/main" id="{B07ABB4B-EE99-4F86-868F-556B5A18584A}"/>
+                <a16:creationId xmlns:a16="http://schemas.microsoft.com/office/drawing/2014/main" id="{2DB0B7F3-29F1-47E3-8B7B-ECA59B59A3EB}"/>
               </a:ext>
             </a:extLst>
           </p:cNvPr>
@@ -36127,7 +35927,7 @@
     </p:spTree>
     <p:extLst>
       <p:ext uri="{BB962C8B-B14F-4D97-AF65-F5344CB8AC3E}">
-        <p14:creationId xmlns:p14="http://schemas.microsoft.com/office/powerpoint/2010/main" val="214394446"/>
+        <p14:creationId xmlns:p14="http://schemas.microsoft.com/office/powerpoint/2010/main" val="1454248399"/>
       </p:ext>
     </p:extLst>
   </p:cSld>
@@ -36155,10 +35955,10 @@
       </p:grpSpPr>
       <p:sp>
         <p:nvSpPr>
-          <p:cNvPr id="12" name="Design system và component">
+          <p:cNvPr id="13" name="Design system và component">
             <a:extLst xmlns:a="http://schemas.openxmlformats.org/drawingml/2006/main">
               <a:ext uri="{FF2B5EF4-FFF2-40B4-BE49-F238E27FC236}">
-                <a16:creationId xmlns:a16="http://schemas.microsoft.com/office/drawing/2014/main" id="{6066EEFF-B29E-4901-8B75-CEAB7F650FAF}"/>
+                <a16:creationId xmlns:a16="http://schemas.microsoft.com/office/drawing/2014/main" id="{7C75BEE7-835A-4028-8551-D9AD422E147C}"/>
               </a:ext>
             </a:extLst>
           </p:cNvPr>
@@ -36316,7 +36116,7 @@
           <p:cNvPr id="2" name="37 biến, 6 text style, 1 effect style. 9 nhóm bắt buộc và 1 ">
             <a:extLst xmlns:a="http://schemas.openxmlformats.org/drawingml/2006/main">
               <a:ext uri="{FF2B5EF4-FFF2-40B4-BE49-F238E27FC236}">
-                <a16:creationId xmlns:a16="http://schemas.microsoft.com/office/drawing/2014/main" id="{C84593E1-3574-4E99-9894-08789330EAC0}"/>
+                <a16:creationId xmlns:a16="http://schemas.microsoft.com/office/drawing/2014/main" id="{EE8E998D-5585-40B6-99E6-F1DE237D384A}"/>
               </a:ext>
             </a:extLst>
           </p:cNvPr>
@@ -36474,7 +36274,7 @@
           <p:cNvPr id="3" name="09 / 12">
             <a:extLst xmlns:a="http://schemas.openxmlformats.org/drawingml/2006/main">
               <a:ext uri="{FF2B5EF4-FFF2-40B4-BE49-F238E27FC236}">
-                <a16:creationId xmlns:a16="http://schemas.microsoft.com/office/drawing/2014/main" id="{6A45FABB-3175-4200-BBBA-C3EEEFFD6327}"/>
+                <a16:creationId xmlns:a16="http://schemas.microsoft.com/office/drawing/2014/main" id="{075998BA-FF25-4BD6-9A27-2397D9CA3747}"/>
               </a:ext>
             </a:extLst>
           </p:cNvPr>
@@ -36632,7 +36432,7 @@
           <p:cNvPr id="4" name="Nguồn">
             <a:extLst xmlns:a="http://schemas.openxmlformats.org/drawingml/2006/main">
               <a:ext uri="{FF2B5EF4-FFF2-40B4-BE49-F238E27FC236}">
-                <a16:creationId xmlns:a16="http://schemas.microsoft.com/office/drawing/2014/main" id="{34B59118-6571-4B3D-8E3E-F67A70E1EED8}"/>
+                <a16:creationId xmlns:a16="http://schemas.microsoft.com/office/drawing/2014/main" id="{1B8DD96D-B8AF-470D-B67D-204724057606}"/>
               </a:ext>
             </a:extLst>
           </p:cNvPr>
@@ -36790,7 +36590,7 @@
           <p:cNvPr id="5" name="Figma 04 Design System">
             <a:extLst xmlns:a="http://schemas.openxmlformats.org/drawingml/2006/main">
               <a:ext uri="{FF2B5EF4-FFF2-40B4-BE49-F238E27FC236}">
-                <a16:creationId xmlns:a16="http://schemas.microsoft.com/office/drawing/2014/main" id="{BA8F74C5-BC32-41D2-8D9B-9EB289A78EB0}"/>
+                <a16:creationId xmlns:a16="http://schemas.microsoft.com/office/drawing/2014/main" id="{26EE1647-EA75-484D-B0CF-DB09E9C298C2}"/>
               </a:ext>
             </a:extLst>
           </p:cNvPr>
@@ -36937,7 +36737,7 @@
                 <a:latin typeface="Noto Sans"/>
                 <a:ea typeface="Noto Sans"/>
                 <a:cs typeface="Noto Sans"/>
-                <a:hlinkClick xmlns:r="http://schemas.openxmlformats.org/officeDocument/2006/relationships" r:id="Rf4e16f63dd5d40db"/>
+                <a:hlinkClick xmlns:r="http://schemas.openxmlformats.org/officeDocument/2006/relationships" r:id="Re892620fb06c4138"/>
               </a:rPr>
               <a:t>Figma 04 Design System</a:t>
             </a:r>
@@ -36949,7 +36749,7 @@
           <p:cNvPr id="6" name="Figma 05 Components">
             <a:extLst xmlns:a="http://schemas.openxmlformats.org/drawingml/2006/main">
               <a:ext uri="{FF2B5EF4-FFF2-40B4-BE49-F238E27FC236}">
-                <a16:creationId xmlns:a16="http://schemas.microsoft.com/office/drawing/2014/main" id="{BB4EA520-9C77-443E-9002-3D7919F373CA}"/>
+                <a16:creationId xmlns:a16="http://schemas.microsoft.com/office/drawing/2014/main" id="{8E1E4749-2EAC-4ABE-A4B9-3A66314D2AD7}"/>
               </a:ext>
             </a:extLst>
           </p:cNvPr>
@@ -37096,7 +36896,7 @@
                 <a:latin typeface="Noto Sans"/>
                 <a:ea typeface="Noto Sans"/>
                 <a:cs typeface="Noto Sans"/>
-                <a:hlinkClick xmlns:r="http://schemas.openxmlformats.org/officeDocument/2006/relationships" r:id="R54376fe6e5f34b25"/>
+                <a:hlinkClick xmlns:r="http://schemas.openxmlformats.org/officeDocument/2006/relationships" r:id="R94596ad5832042cc"/>
               </a:rPr>
               <a:t>Figma 05 Components</a:t>
             </a:r>
@@ -37108,7 +36908,7 @@
           <p:cNvPr id="7" name="Audit thư viện và accordion">
             <a:extLst xmlns:a="http://schemas.openxmlformats.org/drawingml/2006/main">
               <a:ext uri="{FF2B5EF4-FFF2-40B4-BE49-F238E27FC236}">
-                <a16:creationId xmlns:a16="http://schemas.microsoft.com/office/drawing/2014/main" id="{9B7B4ACF-28D3-49C1-ACAD-3E82EC2221F6}"/>
+                <a16:creationId xmlns:a16="http://schemas.microsoft.com/office/drawing/2014/main" id="{ADB9AFD7-1267-4740-9015-2C75CEA54514}"/>
               </a:ext>
             </a:extLst>
           </p:cNvPr>
@@ -37255,7 +37055,7 @@
                 <a:latin typeface="Noto Sans"/>
                 <a:ea typeface="Noto Sans"/>
                 <a:cs typeface="Noto Sans"/>
-                <a:hlinkClick xmlns:r="http://schemas.openxmlformats.org/officeDocument/2006/relationships" r:id="R63403fc0d97b4b19"/>
+                <a:hlinkClick xmlns:r="http://schemas.openxmlformats.org/officeDocument/2006/relationships" r:id="Rb4e663ffa46e4c9c"/>
               </a:rPr>
               <a:t>Audit thư viện và accordion</a:t>
             </a:r>
@@ -37267,7 +37067,7 @@
           <p:cNvPr id="8" name="">
             <a:extLst xmlns:a="http://schemas.openxmlformats.org/drawingml/2006/main">
               <a:ext uri="{FF2B5EF4-FFF2-40B4-BE49-F238E27FC236}">
-                <a16:creationId xmlns:a16="http://schemas.microsoft.com/office/drawing/2014/main" id="{CD1EE2AD-6831-477E-A879-C642FCABFD20}"/>
+                <a16:creationId xmlns:a16="http://schemas.microsoft.com/office/drawing/2014/main" id="{6D06DDFB-4743-42BF-BCBF-70AFAC9CFB1D}"/>
               </a:ext>
             </a:extLst>
           </p:cNvPr>
@@ -38010,7 +37810,7 @@
           <p:cNvPr id="9" name="Type: 24/32, 20/28, 16/24, 14/20">
             <a:extLst xmlns:a="http://schemas.openxmlformats.org/drawingml/2006/main">
               <a:ext uri="{FF2B5EF4-FFF2-40B4-BE49-F238E27FC236}">
-                <a16:creationId xmlns:a16="http://schemas.microsoft.com/office/drawing/2014/main" id="{A434684B-1DCF-42C8-8653-BD46ABE7AAF9}"/>
+                <a16:creationId xmlns:a16="http://schemas.microsoft.com/office/drawing/2014/main" id="{F68AEB46-F4C5-4DCC-9EC4-6509A3AEF2D4}"/>
               </a:ext>
             </a:extLst>
           </p:cNvPr>
@@ -38021,7 +37821,7 @@
         </p:nvSpPr>
         <p:spPr>
           <a:xfrm xmlns:a="http://schemas.openxmlformats.org/drawingml/2006/main">
-            <a:off x="1066800" y="7239000"/>
+            <a:off x="1066800" y="7096125"/>
             <a:ext cx="10763250" cy="523875"/>
           </a:xfrm>
           <a:prstGeom xmlns:a="http://schemas.openxmlformats.org/drawingml/2006/main" prst="rect">
@@ -38165,10 +37965,10 @@
       </p:sp>
       <p:sp>
         <p:nvSpPr>
-          <p:cNvPr id="10" name="Button, TextField, Card, Navigation, AppBar,&#10;Dialog, Loading">
+          <p:cNvPr id="10" name="Elevation: 1 effect style dùng cho card">
             <a:extLst xmlns:a="http://schemas.openxmlformats.org/drawingml/2006/main">
               <a:ext uri="{FF2B5EF4-FFF2-40B4-BE49-F238E27FC236}">
-                <a16:creationId xmlns:a16="http://schemas.microsoft.com/office/drawing/2014/main" id="{3C89462F-3071-4F6B-95DF-9EF1A490C959}"/>
+                <a16:creationId xmlns:a16="http://schemas.microsoft.com/office/drawing/2014/main" id="{AED14CA4-A406-4B69-AA05-79BA78CA5DD2}"/>
               </a:ext>
             </a:extLst>
           </p:cNvPr>
@@ -38179,7 +37979,165 @@
         </p:nvSpPr>
         <p:spPr>
           <a:xfrm xmlns:a="http://schemas.openxmlformats.org/drawingml/2006/main">
-            <a:off x="1066800" y="8143875"/>
+            <a:off x="1066800" y="7715250"/>
+            <a:ext cx="10763250" cy="428625"/>
+          </a:xfrm>
+          <a:prstGeom xmlns:a="http://schemas.openxmlformats.org/drawingml/2006/main" prst="rect">
+            <a:avLst/>
+          </a:prstGeom>
+          <a:noFill xmlns:a="http://schemas.openxmlformats.org/drawingml/2006/main"/>
+          <a:ln xmlns:a="http://schemas.openxmlformats.org/drawingml/2006/main" w="0">
+            <a:noFill/>
+          </a:ln>
+        </p:spPr>
+        <p:txBody>
+          <a:bodyPr xmlns:a="http://schemas.openxmlformats.org/drawingml/2006/main" lIns="0" tIns="0" rIns="0" bIns="0">
+            <a:noAutofit/>
+          </a:bodyPr>
+          <a:lstStyle xmlns:a="http://schemas.openxmlformats.org/drawingml/2006/main">
+            <a:defPPr>
+              <a:defRPr sz="2175" b="0">
+                <a:solidFill>
+                  <a:srgbClr val="031C36"/>
+                </a:solidFill>
+                <a:latin typeface="Noto Sans"/>
+                <a:ea typeface="Noto Sans"/>
+                <a:cs typeface="Noto Sans"/>
+              </a:defRPr>
+            </a:defPPr>
+            <a:lvl1pPr>
+              <a:defRPr sz="2175" b="0">
+                <a:solidFill>
+                  <a:srgbClr val="031C36"/>
+                </a:solidFill>
+                <a:latin typeface="Noto Sans"/>
+                <a:ea typeface="Noto Sans"/>
+                <a:cs typeface="Noto Sans"/>
+              </a:defRPr>
+            </a:lvl1pPr>
+            <a:lvl2pPr>
+              <a:defRPr sz="2175" b="0">
+                <a:solidFill>
+                  <a:srgbClr val="031C36"/>
+                </a:solidFill>
+                <a:latin typeface="Noto Sans"/>
+                <a:ea typeface="Noto Sans"/>
+                <a:cs typeface="Noto Sans"/>
+              </a:defRPr>
+            </a:lvl2pPr>
+            <a:lvl3pPr>
+              <a:defRPr sz="2175" b="0">
+                <a:solidFill>
+                  <a:srgbClr val="031C36"/>
+                </a:solidFill>
+                <a:latin typeface="Noto Sans"/>
+                <a:ea typeface="Noto Sans"/>
+                <a:cs typeface="Noto Sans"/>
+              </a:defRPr>
+            </a:lvl3pPr>
+            <a:lvl4pPr>
+              <a:defRPr sz="2175" b="0">
+                <a:solidFill>
+                  <a:srgbClr val="031C36"/>
+                </a:solidFill>
+                <a:latin typeface="Noto Sans"/>
+                <a:ea typeface="Noto Sans"/>
+                <a:cs typeface="Noto Sans"/>
+              </a:defRPr>
+            </a:lvl4pPr>
+            <a:lvl5pPr>
+              <a:defRPr sz="2175" b="0">
+                <a:solidFill>
+                  <a:srgbClr val="031C36"/>
+                </a:solidFill>
+                <a:latin typeface="Noto Sans"/>
+                <a:ea typeface="Noto Sans"/>
+                <a:cs typeface="Noto Sans"/>
+              </a:defRPr>
+            </a:lvl5pPr>
+            <a:lvl6pPr>
+              <a:defRPr sz="2175" b="0">
+                <a:solidFill>
+                  <a:srgbClr val="031C36"/>
+                </a:solidFill>
+                <a:latin typeface="Noto Sans"/>
+                <a:ea typeface="Noto Sans"/>
+                <a:cs typeface="Noto Sans"/>
+              </a:defRPr>
+            </a:lvl6pPr>
+            <a:lvl7pPr>
+              <a:defRPr sz="2175" b="0">
+                <a:solidFill>
+                  <a:srgbClr val="031C36"/>
+                </a:solidFill>
+                <a:latin typeface="Noto Sans"/>
+                <a:ea typeface="Noto Sans"/>
+                <a:cs typeface="Noto Sans"/>
+              </a:defRPr>
+            </a:lvl7pPr>
+            <a:lvl8pPr>
+              <a:defRPr sz="2175" b="0">
+                <a:solidFill>
+                  <a:srgbClr val="031C36"/>
+                </a:solidFill>
+                <a:latin typeface="Noto Sans"/>
+                <a:ea typeface="Noto Sans"/>
+                <a:cs typeface="Noto Sans"/>
+              </a:defRPr>
+            </a:lvl8pPr>
+            <a:lvl9pPr>
+              <a:defRPr sz="2175" b="0">
+                <a:solidFill>
+                  <a:srgbClr val="031C36"/>
+                </a:solidFill>
+                <a:latin typeface="Noto Sans"/>
+                <a:ea typeface="Noto Sans"/>
+                <a:cs typeface="Noto Sans"/>
+              </a:defRPr>
+            </a:lvl9pPr>
+          </a:lstStyle>
+          <a:p xmlns:a="http://schemas.openxmlformats.org/drawingml/2006/main">
+            <a:pPr>
+              <a:defRPr sz="2175" b="0">
+                <a:solidFill>
+                  <a:srgbClr val="031C36"/>
+                </a:solidFill>
+                <a:latin typeface="Noto Sans"/>
+                <a:ea typeface="Noto Sans"/>
+                <a:cs typeface="Noto Sans"/>
+              </a:defRPr>
+            </a:pPr>
+            <a:r>
+              <a:rPr sz="2175" b="0">
+                <a:solidFill>
+                  <a:srgbClr val="031C36"/>
+                </a:solidFill>
+                <a:latin typeface="Noto Sans"/>
+                <a:ea typeface="Noto Sans"/>
+                <a:cs typeface="Noto Sans"/>
+              </a:rPr>
+              <a:t>Elevation: 1 effect style dùng cho card</a:t>
+            </a:r>
+          </a:p>
+        </p:txBody>
+      </p:sp>
+      <p:sp>
+        <p:nvSpPr>
+          <p:cNvPr id="11" name="Button, TextField, Card, Navigation, AppBar,&#10;Dialog, Loading">
+            <a:extLst xmlns:a="http://schemas.openxmlformats.org/drawingml/2006/main">
+              <a:ext uri="{FF2B5EF4-FFF2-40B4-BE49-F238E27FC236}">
+                <a16:creationId xmlns:a16="http://schemas.microsoft.com/office/drawing/2014/main" id="{995E04A7-E626-46E0-A66A-500105D6A488}"/>
+              </a:ext>
+            </a:extLst>
+          </p:cNvPr>
+          <p:cNvSpPr>
+            <a:spLocks xmlns:a="http://schemas.openxmlformats.org/drawingml/2006/main" noGrp="1"/>
+          </p:cNvSpPr>
+          <p:nvPr/>
+        </p:nvSpPr>
+        <p:spPr>
+          <a:xfrm xmlns:a="http://schemas.openxmlformats.org/drawingml/2006/main">
+            <a:off x="1066800" y="8334375"/>
             <a:ext cx="10668000" cy="857250"/>
           </a:xfrm>
           <a:prstGeom xmlns:a="http://schemas.openxmlformats.org/drawingml/2006/main" prst="rect">
@@ -38196,7 +38154,7 @@
           </a:bodyPr>
           <a:lstStyle xmlns:a="http://schemas.openxmlformats.org/drawingml/2006/main">
             <a:defPPr>
-              <a:defRPr sz="2250" b="0">
+              <a:defRPr sz="2100" b="0">
                 <a:solidFill>
                   <a:srgbClr val="031C36"/>
                 </a:solidFill>
@@ -38206,7 +38164,7 @@
               </a:defRPr>
             </a:defPPr>
             <a:lvl1pPr>
-              <a:defRPr sz="2250" b="0">
+              <a:defRPr sz="2100" b="0">
                 <a:solidFill>
                   <a:srgbClr val="031C36"/>
                 </a:solidFill>
@@ -38216,7 +38174,7 @@
               </a:defRPr>
             </a:lvl1pPr>
             <a:lvl2pPr>
-              <a:defRPr sz="2250" b="0">
+              <a:defRPr sz="2100" b="0">
                 <a:solidFill>
                   <a:srgbClr val="031C36"/>
                 </a:solidFill>
@@ -38226,7 +38184,7 @@
               </a:defRPr>
             </a:lvl2pPr>
             <a:lvl3pPr>
-              <a:defRPr sz="2250" b="0">
+              <a:defRPr sz="2100" b="0">
                 <a:solidFill>
                   <a:srgbClr val="031C36"/>
                 </a:solidFill>
@@ -38236,7 +38194,7 @@
               </a:defRPr>
             </a:lvl3pPr>
             <a:lvl4pPr>
-              <a:defRPr sz="2250" b="0">
+              <a:defRPr sz="2100" b="0">
                 <a:solidFill>
                   <a:srgbClr val="031C36"/>
                 </a:solidFill>
@@ -38246,7 +38204,7 @@
               </a:defRPr>
             </a:lvl4pPr>
             <a:lvl5pPr>
-              <a:defRPr sz="2250" b="0">
+              <a:defRPr sz="2100" b="0">
                 <a:solidFill>
                   <a:srgbClr val="031C36"/>
                 </a:solidFill>
@@ -38256,7 +38214,7 @@
               </a:defRPr>
             </a:lvl5pPr>
             <a:lvl6pPr>
-              <a:defRPr sz="2250" b="0">
+              <a:defRPr sz="2100" b="0">
                 <a:solidFill>
                   <a:srgbClr val="031C36"/>
                 </a:solidFill>
@@ -38266,7 +38224,7 @@
               </a:defRPr>
             </a:lvl6pPr>
             <a:lvl7pPr>
-              <a:defRPr sz="2250" b="0">
+              <a:defRPr sz="2100" b="0">
                 <a:solidFill>
                   <a:srgbClr val="031C36"/>
                 </a:solidFill>
@@ -38276,7 +38234,7 @@
               </a:defRPr>
             </a:lvl7pPr>
             <a:lvl8pPr>
-              <a:defRPr sz="2250" b="0">
+              <a:defRPr sz="2100" b="0">
                 <a:solidFill>
                   <a:srgbClr val="031C36"/>
                 </a:solidFill>
@@ -38286,7 +38244,7 @@
               </a:defRPr>
             </a:lvl8pPr>
             <a:lvl9pPr>
-              <a:defRPr sz="2250" b="0">
+              <a:defRPr sz="2100" b="0">
                 <a:solidFill>
                   <a:srgbClr val="031C36"/>
                 </a:solidFill>
@@ -38298,7 +38256,7 @@
           </a:lstStyle>
           <a:p xmlns:a="http://schemas.openxmlformats.org/drawingml/2006/main">
             <a:pPr>
-              <a:defRPr sz="2250" b="0">
+              <a:defRPr sz="2100" b="0">
                 <a:solidFill>
                   <a:srgbClr val="031C36"/>
                 </a:solidFill>
@@ -38308,7 +38266,7 @@
               </a:defRPr>
             </a:pPr>
             <a:r>
-              <a:rPr sz="2250" b="0">
+              <a:rPr sz="2100" b="0">
                 <a:solidFill>
                   <a:srgbClr val="031C36"/>
                 </a:solidFill>
@@ -38321,7 +38279,7 @@
           </a:p>
           <a:p xmlns:a="http://schemas.openxmlformats.org/drawingml/2006/main">
             <a:pPr>
-              <a:defRPr sz="2250" b="0">
+              <a:defRPr sz="2100" b="0">
                 <a:solidFill>
                   <a:srgbClr val="031C36"/>
                 </a:solidFill>
@@ -38331,7 +38289,7 @@
               </a:defRPr>
             </a:pPr>
             <a:r>
-              <a:rPr sz="2250" b="0">
+              <a:rPr sz="2100" b="0">
                 <a:solidFill>
                   <a:srgbClr val="031C36"/>
                 </a:solidFill>
@@ -38346,10 +38304,10 @@
       </p:sp>
       <p:pic>
         <p:nvPicPr>
-          <p:cNvPr id="11" name="">
+          <p:cNvPr id="12" name="">
             <a:extLst xmlns:a="http://schemas.openxmlformats.org/drawingml/2006/main">
               <a:ext uri="{FF2B5EF4-FFF2-40B4-BE49-F238E27FC236}">
-                <a16:creationId xmlns:a16="http://schemas.microsoft.com/office/drawing/2014/main" id="{6C4C5498-6831-4125-8D3D-60C59A6C46C2}"/>
+                <a16:creationId xmlns:a16="http://schemas.microsoft.com/office/drawing/2014/main" id="{85F85FC1-0D4E-4DCD-814B-95A70B787A1B}"/>
               </a:ext>
             </a:extLst>
           </p:cNvPr>
@@ -38359,7 +38317,7 @@
           <p:nvPr/>
         </p:nvPicPr>
         <p:blipFill>
-          <a:blip xmlns:r="http://schemas.openxmlformats.org/officeDocument/2006/relationships" xmlns:a="http://schemas.openxmlformats.org/drawingml/2006/main" r:embed="Rfc367127f63c4043"/>
+          <a:blip xmlns:r="http://schemas.openxmlformats.org/officeDocument/2006/relationships" xmlns:a="http://schemas.openxmlformats.org/drawingml/2006/main" r:embed="R70f73e0e805f4c55"/>
           <a:stretch xmlns:a="http://schemas.openxmlformats.org/drawingml/2006/main"/>
         </p:blipFill>
         <p:spPr>
@@ -38375,7 +38333,7 @@
     </p:spTree>
     <p:extLst>
       <p:ext uri="{BB962C8B-B14F-4D97-AF65-F5344CB8AC3E}">
-        <p14:creationId xmlns:p14="http://schemas.microsoft.com/office/powerpoint/2010/main" val="261181667"/>
+        <p14:creationId xmlns:p14="http://schemas.microsoft.com/office/powerpoint/2010/main" val="931077328"/>
       </p:ext>
     </p:extLst>
   </p:cSld>

</xml_diff>